<commit_message>
adding links to slides
</commit_message>
<xml_diff>
--- a/slides/01-2-GraphsDFSTopoSCC.pptx
+++ b/slides/01-2-GraphsDFSTopoSCC.pptx
@@ -561,7 +561,7 @@
           <a:noFill/>
           <a:extLst>
             <a:ext uri="{909E8E84-426E-40dd-AFC4-6F175D3DCCD1}">
-              <a14:hiddenFill xmlns:a14="http://schemas.microsoft.com/office/drawing/2010/main" xmlns="">
+              <a14:hiddenFill xmlns="" xmlns:a14="http://schemas.microsoft.com/office/drawing/2010/main">
                 <a:solidFill>
                   <a:srgbClr val="FFFFFF"/>
                 </a:solidFill>
@@ -620,7 +620,7 @@
             </a:ln>
             <a:extLst>
               <a:ext uri="{91240B29-F687-4f45-9708-019B960494DF}">
-                <a14:hiddenLine xmlns:a14="http://schemas.microsoft.com/office/drawing/2010/main" xmlns="" w="9525">
+                <a14:hiddenLine xmlns="" xmlns:a14="http://schemas.microsoft.com/office/drawing/2010/main" w="9525">
                   <a:solidFill>
                     <a:srgbClr val="000000"/>
                   </a:solidFill>
@@ -710,7 +710,7 @@
             </a:ln>
             <a:extLst>
               <a:ext uri="{91240B29-F687-4f45-9708-019B960494DF}">
-                <a14:hiddenLine xmlns:a14="http://schemas.microsoft.com/office/drawing/2010/main" xmlns="" w="9525">
+                <a14:hiddenLine xmlns="" xmlns:a14="http://schemas.microsoft.com/office/drawing/2010/main" w="9525">
                   <a:solidFill>
                     <a:srgbClr val="000000"/>
                   </a:solidFill>
@@ -800,7 +800,7 @@
             </a:ln>
             <a:extLst>
               <a:ext uri="{91240B29-F687-4f45-9708-019B960494DF}">
-                <a14:hiddenLine xmlns:a14="http://schemas.microsoft.com/office/drawing/2010/main" xmlns="" w="9525">
+                <a14:hiddenLine xmlns="" xmlns:a14="http://schemas.microsoft.com/office/drawing/2010/main" w="9525">
                   <a:solidFill>
                     <a:srgbClr val="000000"/>
                   </a:solidFill>
@@ -834,7 +834,7 @@
             </a:ln>
             <a:extLst>
               <a:ext uri="{91240B29-F687-4f45-9708-019B960494DF}">
-                <a14:hiddenLine xmlns:a14="http://schemas.microsoft.com/office/drawing/2010/main" xmlns="" w="9525">
+                <a14:hiddenLine xmlns="" xmlns:a14="http://schemas.microsoft.com/office/drawing/2010/main" w="9525">
                   <a:solidFill>
                     <a:srgbClr val="000000"/>
                   </a:solidFill>
@@ -924,7 +924,7 @@
             </a:ln>
             <a:extLst>
               <a:ext uri="{91240B29-F687-4f45-9708-019B960494DF}">
-                <a14:hiddenLine xmlns:a14="http://schemas.microsoft.com/office/drawing/2010/main" xmlns="" w="9525">
+                <a14:hiddenLine xmlns="" xmlns:a14="http://schemas.microsoft.com/office/drawing/2010/main" w="9525">
                   <a:solidFill>
                     <a:srgbClr val="000000"/>
                   </a:solidFill>
@@ -986,7 +986,7 @@
             </a:ln>
             <a:extLst>
               <a:ext uri="{91240B29-F687-4f45-9708-019B960494DF}">
-                <a14:hiddenLine xmlns:a14="http://schemas.microsoft.com/office/drawing/2010/main" xmlns="" w="9525">
+                <a14:hiddenLine xmlns="" xmlns:a14="http://schemas.microsoft.com/office/drawing/2010/main" w="9525">
                   <a:solidFill>
                     <a:srgbClr val="000000"/>
                   </a:solidFill>
@@ -1048,7 +1048,7 @@
             </a:ln>
             <a:extLst>
               <a:ext uri="{91240B29-F687-4f45-9708-019B960494DF}">
-                <a14:hiddenLine xmlns:a14="http://schemas.microsoft.com/office/drawing/2010/main" xmlns="" w="9525">
+                <a14:hiddenLine xmlns="" xmlns:a14="http://schemas.microsoft.com/office/drawing/2010/main" w="9525">
                   <a:solidFill>
                     <a:srgbClr val="000000"/>
                   </a:solidFill>
@@ -1138,7 +1138,7 @@
             </a:ln>
             <a:extLst>
               <a:ext uri="{91240B29-F687-4f45-9708-019B960494DF}">
-                <a14:hiddenLine xmlns:a14="http://schemas.microsoft.com/office/drawing/2010/main" xmlns="" w="9525">
+                <a14:hiddenLine xmlns="" xmlns:a14="http://schemas.microsoft.com/office/drawing/2010/main" w="9525">
                   <a:solidFill>
                     <a:srgbClr val="000000"/>
                   </a:solidFill>
@@ -1200,7 +1200,7 @@
             </a:ln>
             <a:extLst>
               <a:ext uri="{91240B29-F687-4f45-9708-019B960494DF}">
-                <a14:hiddenLine xmlns:a14="http://schemas.microsoft.com/office/drawing/2010/main" xmlns="" w="9525">
+                <a14:hiddenLine xmlns="" xmlns:a14="http://schemas.microsoft.com/office/drawing/2010/main" w="9525">
                   <a:solidFill>
                     <a:srgbClr val="000000"/>
                   </a:solidFill>
@@ -1262,7 +1262,7 @@
             </a:ln>
             <a:extLst>
               <a:ext uri="{91240B29-F687-4f45-9708-019B960494DF}">
-                <a14:hiddenLine xmlns:a14="http://schemas.microsoft.com/office/drawing/2010/main" xmlns="" w="9525">
+                <a14:hiddenLine xmlns="" xmlns:a14="http://schemas.microsoft.com/office/drawing/2010/main" w="9525">
                   <a:solidFill>
                     <a:srgbClr val="000000"/>
                   </a:solidFill>
@@ -1352,7 +1352,7 @@
             </a:ln>
             <a:extLst>
               <a:ext uri="{91240B29-F687-4f45-9708-019B960494DF}">
-                <a14:hiddenLine xmlns:a14="http://schemas.microsoft.com/office/drawing/2010/main" xmlns="" w="9525">
+                <a14:hiddenLine xmlns="" xmlns:a14="http://schemas.microsoft.com/office/drawing/2010/main" w="9525">
                   <a:solidFill>
                     <a:srgbClr val="000000"/>
                   </a:solidFill>
@@ -1442,7 +1442,7 @@
             </a:ln>
             <a:extLst>
               <a:ext uri="{91240B29-F687-4f45-9708-019B960494DF}">
-                <a14:hiddenLine xmlns:a14="http://schemas.microsoft.com/office/drawing/2010/main" xmlns="" w="9525">
+                <a14:hiddenLine xmlns="" xmlns:a14="http://schemas.microsoft.com/office/drawing/2010/main" w="9525">
                   <a:solidFill>
                     <a:srgbClr val="000000"/>
                   </a:solidFill>
@@ -1504,7 +1504,7 @@
             </a:ln>
             <a:extLst>
               <a:ext uri="{91240B29-F687-4f45-9708-019B960494DF}">
-                <a14:hiddenLine xmlns:a14="http://schemas.microsoft.com/office/drawing/2010/main" xmlns="" w="9525">
+                <a14:hiddenLine xmlns="" xmlns:a14="http://schemas.microsoft.com/office/drawing/2010/main" w="9525">
                   <a:solidFill>
                     <a:srgbClr val="000000"/>
                   </a:solidFill>
@@ -1614,7 +1614,7 @@
             </a:ln>
             <a:extLst>
               <a:ext uri="{91240B29-F687-4f45-9708-019B960494DF}">
-                <a14:hiddenLine xmlns:a14="http://schemas.microsoft.com/office/drawing/2010/main" xmlns="" w="9525">
+                <a14:hiddenLine xmlns="" xmlns:a14="http://schemas.microsoft.com/office/drawing/2010/main" w="9525">
                   <a:solidFill>
                     <a:srgbClr val="000000"/>
                   </a:solidFill>
@@ -1676,7 +1676,7 @@
             </a:ln>
             <a:extLst>
               <a:ext uri="{91240B29-F687-4f45-9708-019B960494DF}">
-                <a14:hiddenLine xmlns:a14="http://schemas.microsoft.com/office/drawing/2010/main" xmlns="" w="9525">
+                <a14:hiddenLine xmlns="" xmlns:a14="http://schemas.microsoft.com/office/drawing/2010/main" w="9525">
                   <a:solidFill>
                     <a:srgbClr val="000000"/>
                   </a:solidFill>
@@ -1766,7 +1766,7 @@
             </a:ln>
             <a:extLst>
               <a:ext uri="{91240B29-F687-4f45-9708-019B960494DF}">
-                <a14:hiddenLine xmlns:a14="http://schemas.microsoft.com/office/drawing/2010/main" xmlns="" w="9525">
+                <a14:hiddenLine xmlns="" xmlns:a14="http://schemas.microsoft.com/office/drawing/2010/main" w="9525">
                   <a:solidFill>
                     <a:srgbClr val="000000"/>
                   </a:solidFill>
@@ -1856,7 +1856,7 @@
             </a:ln>
             <a:extLst>
               <a:ext uri="{91240B29-F687-4f45-9708-019B960494DF}">
-                <a14:hiddenLine xmlns:a14="http://schemas.microsoft.com/office/drawing/2010/main" xmlns="" w="9525">
+                <a14:hiddenLine xmlns="" xmlns:a14="http://schemas.microsoft.com/office/drawing/2010/main" w="9525">
                   <a:solidFill>
                     <a:srgbClr val="000000"/>
                   </a:solidFill>
@@ -1918,7 +1918,7 @@
             </a:ln>
             <a:extLst>
               <a:ext uri="{91240B29-F687-4f45-9708-019B960494DF}">
-                <a14:hiddenLine xmlns:a14="http://schemas.microsoft.com/office/drawing/2010/main" xmlns="" w="9525">
+                <a14:hiddenLine xmlns="" xmlns:a14="http://schemas.microsoft.com/office/drawing/2010/main" w="9525">
                   <a:solidFill>
                     <a:srgbClr val="000000"/>
                   </a:solidFill>
@@ -2008,7 +2008,7 @@
             </a:ln>
             <a:extLst>
               <a:ext uri="{91240B29-F687-4f45-9708-019B960494DF}">
-                <a14:hiddenLine xmlns:a14="http://schemas.microsoft.com/office/drawing/2010/main" xmlns="" w="9525">
+                <a14:hiddenLine xmlns="" xmlns:a14="http://schemas.microsoft.com/office/drawing/2010/main" w="9525">
                   <a:solidFill>
                     <a:srgbClr val="000000"/>
                   </a:solidFill>
@@ -2098,7 +2098,7 @@
             </a:ln>
             <a:extLst>
               <a:ext uri="{91240B29-F687-4f45-9708-019B960494DF}">
-                <a14:hiddenLine xmlns:a14="http://schemas.microsoft.com/office/drawing/2010/main" xmlns="" w="9525">
+                <a14:hiddenLine xmlns="" xmlns:a14="http://schemas.microsoft.com/office/drawing/2010/main" w="9525">
                   <a:solidFill>
                     <a:srgbClr val="000000"/>
                   </a:solidFill>
@@ -2154,7 +2154,7 @@
             </a:ln>
             <a:extLst>
               <a:ext uri="{91240B29-F687-4f45-9708-019B960494DF}">
-                <a14:hiddenLine xmlns:a14="http://schemas.microsoft.com/office/drawing/2010/main" xmlns="" w="9525">
+                <a14:hiddenLine xmlns="" xmlns:a14="http://schemas.microsoft.com/office/drawing/2010/main" w="9525">
                   <a:solidFill>
                     <a:srgbClr val="000000"/>
                   </a:solidFill>
@@ -2244,7 +2244,7 @@
             </a:ln>
             <a:extLst>
               <a:ext uri="{91240B29-F687-4f45-9708-019B960494DF}">
-                <a14:hiddenLine xmlns:a14="http://schemas.microsoft.com/office/drawing/2010/main" xmlns="" w="9525">
+                <a14:hiddenLine xmlns="" xmlns:a14="http://schemas.microsoft.com/office/drawing/2010/main" w="9525">
                   <a:solidFill>
                     <a:srgbClr val="000000"/>
                   </a:solidFill>
@@ -2300,7 +2300,7 @@
             </a:ln>
             <a:extLst>
               <a:ext uri="{91240B29-F687-4f45-9708-019B960494DF}">
-                <a14:hiddenLine xmlns:a14="http://schemas.microsoft.com/office/drawing/2010/main" xmlns="" w="9525">
+                <a14:hiddenLine xmlns="" xmlns:a14="http://schemas.microsoft.com/office/drawing/2010/main" w="9525">
                   <a:solidFill>
                     <a:srgbClr val="000000"/>
                   </a:solidFill>
@@ -2390,7 +2390,7 @@
             </a:ln>
             <a:extLst>
               <a:ext uri="{91240B29-F687-4f45-9708-019B960494DF}">
-                <a14:hiddenLine xmlns:a14="http://schemas.microsoft.com/office/drawing/2010/main" xmlns="" w="9525">
+                <a14:hiddenLine xmlns="" xmlns:a14="http://schemas.microsoft.com/office/drawing/2010/main" w="9525">
                   <a:solidFill>
                     <a:srgbClr val="000000"/>
                   </a:solidFill>
@@ -2458,7 +2458,7 @@
             </a:ln>
             <a:extLst>
               <a:ext uri="{91240B29-F687-4f45-9708-019B960494DF}">
-                <a14:hiddenLine xmlns:a14="http://schemas.microsoft.com/office/drawing/2010/main" xmlns="" w="9525">
+                <a14:hiddenLine xmlns="" xmlns:a14="http://schemas.microsoft.com/office/drawing/2010/main" w="9525">
                   <a:solidFill>
                     <a:srgbClr val="000000"/>
                   </a:solidFill>
@@ -2548,7 +2548,7 @@
             </a:ln>
             <a:extLst>
               <a:ext uri="{91240B29-F687-4f45-9708-019B960494DF}">
-                <a14:hiddenLine xmlns:a14="http://schemas.microsoft.com/office/drawing/2010/main" xmlns="" w="9525">
+                <a14:hiddenLine xmlns="" xmlns:a14="http://schemas.microsoft.com/office/drawing/2010/main" w="9525">
                   <a:solidFill>
                     <a:srgbClr val="000000"/>
                   </a:solidFill>
@@ -2616,7 +2616,7 @@
             </a:ln>
             <a:extLst>
               <a:ext uri="{91240B29-F687-4f45-9708-019B960494DF}">
-                <a14:hiddenLine xmlns:a14="http://schemas.microsoft.com/office/drawing/2010/main" xmlns="" w="9525">
+                <a14:hiddenLine xmlns="" xmlns:a14="http://schemas.microsoft.com/office/drawing/2010/main" w="9525">
                   <a:solidFill>
                     <a:srgbClr val="000000"/>
                   </a:solidFill>
@@ -2706,7 +2706,7 @@
             </a:ln>
             <a:extLst>
               <a:ext uri="{91240B29-F687-4f45-9708-019B960494DF}">
-                <a14:hiddenLine xmlns:a14="http://schemas.microsoft.com/office/drawing/2010/main" xmlns="" w="9525">
+                <a14:hiddenLine xmlns="" xmlns:a14="http://schemas.microsoft.com/office/drawing/2010/main" w="9525">
                   <a:solidFill>
                     <a:srgbClr val="000000"/>
                   </a:solidFill>
@@ -2740,7 +2740,7 @@
             </a:ln>
             <a:extLst>
               <a:ext uri="{91240B29-F687-4f45-9708-019B960494DF}">
-                <a14:hiddenLine xmlns:a14="http://schemas.microsoft.com/office/drawing/2010/main" xmlns="" w="9525">
+                <a14:hiddenLine xmlns="" xmlns:a14="http://schemas.microsoft.com/office/drawing/2010/main" w="9525">
                   <a:solidFill>
                     <a:srgbClr val="000000"/>
                   </a:solidFill>
@@ -2830,7 +2830,7 @@
             </a:ln>
             <a:extLst>
               <a:ext uri="{91240B29-F687-4f45-9708-019B960494DF}">
-                <a14:hiddenLine xmlns:a14="http://schemas.microsoft.com/office/drawing/2010/main" xmlns="" w="9525">
+                <a14:hiddenLine xmlns="" xmlns:a14="http://schemas.microsoft.com/office/drawing/2010/main" w="9525">
                   <a:solidFill>
                     <a:srgbClr val="000000"/>
                   </a:solidFill>
@@ -2892,7 +2892,7 @@
             </a:ln>
             <a:extLst>
               <a:ext uri="{91240B29-F687-4f45-9708-019B960494DF}">
-                <a14:hiddenLine xmlns:a14="http://schemas.microsoft.com/office/drawing/2010/main" xmlns="" w="9525">
+                <a14:hiddenLine xmlns="" xmlns:a14="http://schemas.microsoft.com/office/drawing/2010/main" w="9525">
                   <a:solidFill>
                     <a:srgbClr val="000000"/>
                   </a:solidFill>
@@ -2954,7 +2954,7 @@
             </a:ln>
             <a:extLst>
               <a:ext uri="{91240B29-F687-4f45-9708-019B960494DF}">
-                <a14:hiddenLine xmlns:a14="http://schemas.microsoft.com/office/drawing/2010/main" xmlns="" w="9525">
+                <a14:hiddenLine xmlns="" xmlns:a14="http://schemas.microsoft.com/office/drawing/2010/main" w="9525">
                   <a:solidFill>
                     <a:srgbClr val="000000"/>
                   </a:solidFill>
@@ -3044,7 +3044,7 @@
             </a:ln>
             <a:extLst>
               <a:ext uri="{91240B29-F687-4f45-9708-019B960494DF}">
-                <a14:hiddenLine xmlns:a14="http://schemas.microsoft.com/office/drawing/2010/main" xmlns="" w="9525">
+                <a14:hiddenLine xmlns="" xmlns:a14="http://schemas.microsoft.com/office/drawing/2010/main" w="9525">
                   <a:solidFill>
                     <a:srgbClr val="000000"/>
                   </a:solidFill>
@@ -3112,7 +3112,7 @@
             </a:ln>
             <a:extLst>
               <a:ext uri="{91240B29-F687-4f45-9708-019B960494DF}">
-                <a14:hiddenLine xmlns:a14="http://schemas.microsoft.com/office/drawing/2010/main" xmlns="" w="9525">
+                <a14:hiddenLine xmlns="" xmlns:a14="http://schemas.microsoft.com/office/drawing/2010/main" w="9525">
                   <a:solidFill>
                     <a:srgbClr val="000000"/>
                   </a:solidFill>
@@ -3174,7 +3174,7 @@
             </a:ln>
             <a:extLst>
               <a:ext uri="{91240B29-F687-4f45-9708-019B960494DF}">
-                <a14:hiddenLine xmlns:a14="http://schemas.microsoft.com/office/drawing/2010/main" xmlns="" w="9525">
+                <a14:hiddenLine xmlns="" xmlns:a14="http://schemas.microsoft.com/office/drawing/2010/main" w="9525">
                   <a:solidFill>
                     <a:srgbClr val="000000"/>
                   </a:solidFill>
@@ -3264,7 +3264,7 @@
             </a:ln>
             <a:extLst>
               <a:ext uri="{91240B29-F687-4f45-9708-019B960494DF}">
-                <a14:hiddenLine xmlns:a14="http://schemas.microsoft.com/office/drawing/2010/main" xmlns="" w="9525">
+                <a14:hiddenLine xmlns="" xmlns:a14="http://schemas.microsoft.com/office/drawing/2010/main" w="9525">
                   <a:solidFill>
                     <a:srgbClr val="000000"/>
                   </a:solidFill>
@@ -3326,7 +3326,7 @@
             </a:ln>
             <a:extLst>
               <a:ext uri="{91240B29-F687-4f45-9708-019B960494DF}">
-                <a14:hiddenLine xmlns:a14="http://schemas.microsoft.com/office/drawing/2010/main" xmlns="" w="9525">
+                <a14:hiddenLine xmlns="" xmlns:a14="http://schemas.microsoft.com/office/drawing/2010/main" w="9525">
                   <a:solidFill>
                     <a:srgbClr val="000000"/>
                   </a:solidFill>
@@ -3416,7 +3416,7 @@
             </a:ln>
             <a:extLst>
               <a:ext uri="{91240B29-F687-4f45-9708-019B960494DF}">
-                <a14:hiddenLine xmlns:a14="http://schemas.microsoft.com/office/drawing/2010/main" xmlns="" w="9525">
+                <a14:hiddenLine xmlns="" xmlns:a14="http://schemas.microsoft.com/office/drawing/2010/main" w="9525">
                   <a:solidFill>
                     <a:srgbClr val="000000"/>
                   </a:solidFill>
@@ -3478,7 +3478,7 @@
             </a:ln>
             <a:extLst>
               <a:ext uri="{91240B29-F687-4f45-9708-019B960494DF}">
-                <a14:hiddenLine xmlns:a14="http://schemas.microsoft.com/office/drawing/2010/main" xmlns="" w="9525">
+                <a14:hiddenLine xmlns="" xmlns:a14="http://schemas.microsoft.com/office/drawing/2010/main" w="9525">
                   <a:solidFill>
                     <a:srgbClr val="000000"/>
                   </a:solidFill>
@@ -3568,7 +3568,7 @@
             </a:ln>
             <a:extLst>
               <a:ext uri="{91240B29-F687-4f45-9708-019B960494DF}">
-                <a14:hiddenLine xmlns:a14="http://schemas.microsoft.com/office/drawing/2010/main" xmlns="" w="9525">
+                <a14:hiddenLine xmlns="" xmlns:a14="http://schemas.microsoft.com/office/drawing/2010/main" w="9525">
                   <a:solidFill>
                     <a:srgbClr val="000000"/>
                   </a:solidFill>
@@ -3602,7 +3602,7 @@
             </a:ln>
             <a:extLst>
               <a:ext uri="{91240B29-F687-4f45-9708-019B960494DF}">
-                <a14:hiddenLine xmlns:a14="http://schemas.microsoft.com/office/drawing/2010/main" xmlns="" w="9525">
+                <a14:hiddenLine xmlns="" xmlns:a14="http://schemas.microsoft.com/office/drawing/2010/main" w="9525">
                   <a:solidFill>
                     <a:srgbClr val="000000"/>
                   </a:solidFill>
@@ -3667,7 +3667,7 @@
             </a:ln>
             <a:extLst>
               <a:ext uri="{91240B29-F687-4f45-9708-019B960494DF}">
-                <a14:hiddenLine xmlns:a14="http://schemas.microsoft.com/office/drawing/2010/main" xmlns="" w="9525">
+                <a14:hiddenLine xmlns="" xmlns:a14="http://schemas.microsoft.com/office/drawing/2010/main" w="9525">
                   <a:solidFill>
                     <a:srgbClr val="000000"/>
                   </a:solidFill>
@@ -3757,7 +3757,7 @@
             </a:ln>
             <a:extLst>
               <a:ext uri="{91240B29-F687-4f45-9708-019B960494DF}">
-                <a14:hiddenLine xmlns:a14="http://schemas.microsoft.com/office/drawing/2010/main" xmlns="" w="9525">
+                <a14:hiddenLine xmlns="" xmlns:a14="http://schemas.microsoft.com/office/drawing/2010/main" w="9525">
                   <a:solidFill>
                     <a:srgbClr val="000000"/>
                   </a:solidFill>
@@ -3819,7 +3819,7 @@
             </a:ln>
             <a:extLst>
               <a:ext uri="{91240B29-F687-4f45-9708-019B960494DF}">
-                <a14:hiddenLine xmlns:a14="http://schemas.microsoft.com/office/drawing/2010/main" xmlns="" w="9525">
+                <a14:hiddenLine xmlns="" xmlns:a14="http://schemas.microsoft.com/office/drawing/2010/main" w="9525">
                   <a:solidFill>
                     <a:srgbClr val="000000"/>
                   </a:solidFill>
@@ -3909,7 +3909,7 @@
             </a:ln>
             <a:extLst>
               <a:ext uri="{91240B29-F687-4f45-9708-019B960494DF}">
-                <a14:hiddenLine xmlns:a14="http://schemas.microsoft.com/office/drawing/2010/main" xmlns="" w="9525">
+                <a14:hiddenLine xmlns="" xmlns:a14="http://schemas.microsoft.com/office/drawing/2010/main" w="9525">
                   <a:solidFill>
                     <a:srgbClr val="000000"/>
                   </a:solidFill>
@@ -3999,7 +3999,7 @@
             </a:ln>
             <a:extLst>
               <a:ext uri="{91240B29-F687-4f45-9708-019B960494DF}">
-                <a14:hiddenLine xmlns:a14="http://schemas.microsoft.com/office/drawing/2010/main" xmlns="" w="9525">
+                <a14:hiddenLine xmlns="" xmlns:a14="http://schemas.microsoft.com/office/drawing/2010/main" w="9525">
                   <a:solidFill>
                     <a:srgbClr val="000000"/>
                   </a:solidFill>
@@ -4064,7 +4064,7 @@
             </a:ln>
             <a:extLst>
               <a:ext uri="{91240B29-F687-4f45-9708-019B960494DF}">
-                <a14:hiddenLine xmlns:a14="http://schemas.microsoft.com/office/drawing/2010/main" xmlns="" w="9525">
+                <a14:hiddenLine xmlns="" xmlns:a14="http://schemas.microsoft.com/office/drawing/2010/main" w="9525">
                   <a:solidFill>
                     <a:srgbClr val="000000"/>
                   </a:solidFill>
@@ -4126,7 +4126,7 @@
             </a:ln>
             <a:extLst>
               <a:ext uri="{91240B29-F687-4f45-9708-019B960494DF}">
-                <a14:hiddenLine xmlns:a14="http://schemas.microsoft.com/office/drawing/2010/main" xmlns="" w="9525">
+                <a14:hiddenLine xmlns="" xmlns:a14="http://schemas.microsoft.com/office/drawing/2010/main" w="9525">
                   <a:solidFill>
                     <a:srgbClr val="000000"/>
                   </a:solidFill>
@@ -4216,7 +4216,7 @@
             </a:ln>
             <a:extLst>
               <a:ext uri="{91240B29-F687-4f45-9708-019B960494DF}">
-                <a14:hiddenLine xmlns:a14="http://schemas.microsoft.com/office/drawing/2010/main" xmlns="" w="9525">
+                <a14:hiddenLine xmlns="" xmlns:a14="http://schemas.microsoft.com/office/drawing/2010/main" w="9525">
                   <a:solidFill>
                     <a:srgbClr val="000000"/>
                   </a:solidFill>
@@ -4306,7 +4306,7 @@
             </a:ln>
             <a:extLst>
               <a:ext uri="{91240B29-F687-4f45-9708-019B960494DF}">
-                <a14:hiddenLine xmlns:a14="http://schemas.microsoft.com/office/drawing/2010/main" xmlns="" w="9525">
+                <a14:hiddenLine xmlns="" xmlns:a14="http://schemas.microsoft.com/office/drawing/2010/main" w="9525">
                   <a:solidFill>
                     <a:srgbClr val="000000"/>
                   </a:solidFill>
@@ -4368,7 +4368,7 @@
             </a:ln>
             <a:extLst>
               <a:ext uri="{91240B29-F687-4f45-9708-019B960494DF}">
-                <a14:hiddenLine xmlns:a14="http://schemas.microsoft.com/office/drawing/2010/main" xmlns="" w="9525">
+                <a14:hiddenLine xmlns="" xmlns:a14="http://schemas.microsoft.com/office/drawing/2010/main" w="9525">
                   <a:solidFill>
                     <a:srgbClr val="000000"/>
                   </a:solidFill>
@@ -4488,7 +4488,7 @@
             </a:ln>
             <a:extLst>
               <a:ext uri="{91240B29-F687-4f45-9708-019B960494DF}">
-                <a14:hiddenLine xmlns:a14="http://schemas.microsoft.com/office/drawing/2010/main" xmlns="" w="9525">
+                <a14:hiddenLine xmlns="" xmlns:a14="http://schemas.microsoft.com/office/drawing/2010/main" w="9525">
                   <a:solidFill>
                     <a:srgbClr val="000000"/>
                   </a:solidFill>
@@ -4556,7 +4556,7 @@
             </a:ln>
             <a:extLst>
               <a:ext uri="{91240B29-F687-4f45-9708-019B960494DF}">
-                <a14:hiddenLine xmlns:a14="http://schemas.microsoft.com/office/drawing/2010/main" xmlns="" w="9525">
+                <a14:hiddenLine xmlns="" xmlns:a14="http://schemas.microsoft.com/office/drawing/2010/main" w="9525">
                   <a:solidFill>
                     <a:srgbClr val="000000"/>
                   </a:solidFill>
@@ -4646,7 +4646,7 @@
             </a:ln>
             <a:extLst>
               <a:ext uri="{91240B29-F687-4f45-9708-019B960494DF}">
-                <a14:hiddenLine xmlns:a14="http://schemas.microsoft.com/office/drawing/2010/main" xmlns="" w="9525">
+                <a14:hiddenLine xmlns="" xmlns:a14="http://schemas.microsoft.com/office/drawing/2010/main" w="9525">
                   <a:solidFill>
                     <a:srgbClr val="000000"/>
                   </a:solidFill>
@@ -9475,7 +9475,7 @@
           <a:noFill/>
           <a:extLst>
             <a:ext uri="{909E8E84-426E-40dd-AFC4-6F175D3DCCD1}">
-              <a14:hiddenFill xmlns:a14="http://schemas.microsoft.com/office/drawing/2010/main" xmlns="">
+              <a14:hiddenFill xmlns="" xmlns:a14="http://schemas.microsoft.com/office/drawing/2010/main">
                 <a:solidFill>
                   <a:srgbClr val="FFFFFF"/>
                 </a:solidFill>
@@ -9549,7 +9549,7 @@
               </a:ln>
               <a:extLst>
                 <a:ext uri="{91240B29-F687-4f45-9708-019B960494DF}">
-                  <a14:hiddenLine xmlns:a14="http://schemas.microsoft.com/office/drawing/2010/main" xmlns="" w="9525">
+                  <a14:hiddenLine xmlns="" xmlns:a14="http://schemas.microsoft.com/office/drawing/2010/main" w="9525">
                     <a:solidFill>
                       <a:srgbClr val="000000"/>
                     </a:solidFill>
@@ -9639,7 +9639,7 @@
               </a:ln>
               <a:extLst>
                 <a:ext uri="{91240B29-F687-4f45-9708-019B960494DF}">
-                  <a14:hiddenLine xmlns:a14="http://schemas.microsoft.com/office/drawing/2010/main" xmlns="" w="9525">
+                  <a14:hiddenLine xmlns="" xmlns:a14="http://schemas.microsoft.com/office/drawing/2010/main" w="9525">
                     <a:solidFill>
                       <a:srgbClr val="000000"/>
                     </a:solidFill>
@@ -9729,7 +9729,7 @@
               </a:ln>
               <a:extLst>
                 <a:ext uri="{91240B29-F687-4f45-9708-019B960494DF}">
-                  <a14:hiddenLine xmlns:a14="http://schemas.microsoft.com/office/drawing/2010/main" xmlns="" w="9525">
+                  <a14:hiddenLine xmlns="" xmlns:a14="http://schemas.microsoft.com/office/drawing/2010/main" w="9525">
                     <a:solidFill>
                       <a:srgbClr val="000000"/>
                     </a:solidFill>
@@ -9791,7 +9791,7 @@
               </a:ln>
               <a:extLst>
                 <a:ext uri="{91240B29-F687-4f45-9708-019B960494DF}">
-                  <a14:hiddenLine xmlns:a14="http://schemas.microsoft.com/office/drawing/2010/main" xmlns="" w="9525">
+                  <a14:hiddenLine xmlns="" xmlns:a14="http://schemas.microsoft.com/office/drawing/2010/main" w="9525">
                     <a:solidFill>
                       <a:srgbClr val="000000"/>
                     </a:solidFill>
@@ -9881,7 +9881,7 @@
               </a:ln>
               <a:extLst>
                 <a:ext uri="{91240B29-F687-4f45-9708-019B960494DF}">
-                  <a14:hiddenLine xmlns:a14="http://schemas.microsoft.com/office/drawing/2010/main" xmlns="" w="9525">
+                  <a14:hiddenLine xmlns="" xmlns:a14="http://schemas.microsoft.com/office/drawing/2010/main" w="9525">
                     <a:solidFill>
                       <a:srgbClr val="000000"/>
                     </a:solidFill>
@@ -9943,7 +9943,7 @@
               </a:ln>
               <a:extLst>
                 <a:ext uri="{91240B29-F687-4f45-9708-019B960494DF}">
-                  <a14:hiddenLine xmlns:a14="http://schemas.microsoft.com/office/drawing/2010/main" xmlns="" w="9525">
+                  <a14:hiddenLine xmlns="" xmlns:a14="http://schemas.microsoft.com/office/drawing/2010/main" w="9525">
                     <a:solidFill>
                       <a:srgbClr val="000000"/>
                     </a:solidFill>
@@ -10005,7 +10005,7 @@
               </a:ln>
               <a:extLst>
                 <a:ext uri="{91240B29-F687-4f45-9708-019B960494DF}">
-                  <a14:hiddenLine xmlns:a14="http://schemas.microsoft.com/office/drawing/2010/main" xmlns="" w="9525">
+                  <a14:hiddenLine xmlns="" xmlns:a14="http://schemas.microsoft.com/office/drawing/2010/main" w="9525">
                     <a:solidFill>
                       <a:srgbClr val="000000"/>
                     </a:solidFill>
@@ -10095,7 +10095,7 @@
               </a:ln>
               <a:extLst>
                 <a:ext uri="{91240B29-F687-4f45-9708-019B960494DF}">
-                  <a14:hiddenLine xmlns:a14="http://schemas.microsoft.com/office/drawing/2010/main" xmlns="" w="9525">
+                  <a14:hiddenLine xmlns="" xmlns:a14="http://schemas.microsoft.com/office/drawing/2010/main" w="9525">
                     <a:solidFill>
                       <a:srgbClr val="000000"/>
                     </a:solidFill>
@@ -10185,7 +10185,7 @@
               </a:ln>
               <a:extLst>
                 <a:ext uri="{91240B29-F687-4f45-9708-019B960494DF}">
-                  <a14:hiddenLine xmlns:a14="http://schemas.microsoft.com/office/drawing/2010/main" xmlns="" w="9525">
+                  <a14:hiddenLine xmlns="" xmlns:a14="http://schemas.microsoft.com/office/drawing/2010/main" w="9525">
                     <a:solidFill>
                       <a:srgbClr val="000000"/>
                     </a:solidFill>
@@ -10247,7 +10247,7 @@
               </a:ln>
               <a:extLst>
                 <a:ext uri="{91240B29-F687-4f45-9708-019B960494DF}">
-                  <a14:hiddenLine xmlns:a14="http://schemas.microsoft.com/office/drawing/2010/main" xmlns="" w="9525">
+                  <a14:hiddenLine xmlns="" xmlns:a14="http://schemas.microsoft.com/office/drawing/2010/main" w="9525">
                     <a:solidFill>
                       <a:srgbClr val="000000"/>
                     </a:solidFill>
@@ -10357,7 +10357,7 @@
               </a:ln>
               <a:extLst>
                 <a:ext uri="{91240B29-F687-4f45-9708-019B960494DF}">
-                  <a14:hiddenLine xmlns:a14="http://schemas.microsoft.com/office/drawing/2010/main" xmlns="" w="9525">
+                  <a14:hiddenLine xmlns="" xmlns:a14="http://schemas.microsoft.com/office/drawing/2010/main" w="9525">
                     <a:solidFill>
                       <a:srgbClr val="000000"/>
                     </a:solidFill>
@@ -10441,7 +10441,7 @@
               </a:ln>
               <a:extLst>
                 <a:ext uri="{91240B29-F687-4f45-9708-019B960494DF}">
-                  <a14:hiddenLine xmlns:a14="http://schemas.microsoft.com/office/drawing/2010/main" xmlns="" w="9525">
+                  <a14:hiddenLine xmlns="" xmlns:a14="http://schemas.microsoft.com/office/drawing/2010/main" w="9525">
                     <a:solidFill>
                       <a:srgbClr val="000000"/>
                     </a:solidFill>
@@ -10503,7 +10503,7 @@
               </a:ln>
               <a:extLst>
                 <a:ext uri="{91240B29-F687-4f45-9708-019B960494DF}">
-                  <a14:hiddenLine xmlns:a14="http://schemas.microsoft.com/office/drawing/2010/main" xmlns="" w="9525">
+                  <a14:hiddenLine xmlns="" xmlns:a14="http://schemas.microsoft.com/office/drawing/2010/main" w="9525">
                     <a:solidFill>
                       <a:srgbClr val="000000"/>
                     </a:solidFill>
@@ -10565,7 +10565,7 @@
               </a:ln>
               <a:extLst>
                 <a:ext uri="{91240B29-F687-4f45-9708-019B960494DF}">
-                  <a14:hiddenLine xmlns:a14="http://schemas.microsoft.com/office/drawing/2010/main" xmlns="" w="9525">
+                  <a14:hiddenLine xmlns="" xmlns:a14="http://schemas.microsoft.com/office/drawing/2010/main" w="9525">
                     <a:solidFill>
                       <a:srgbClr val="000000"/>
                     </a:solidFill>
@@ -10655,7 +10655,7 @@
               </a:ln>
               <a:extLst>
                 <a:ext uri="{91240B29-F687-4f45-9708-019B960494DF}">
-                  <a14:hiddenLine xmlns:a14="http://schemas.microsoft.com/office/drawing/2010/main" xmlns="" w="9525">
+                  <a14:hiddenLine xmlns="" xmlns:a14="http://schemas.microsoft.com/office/drawing/2010/main" w="9525">
                     <a:solidFill>
                       <a:srgbClr val="000000"/>
                     </a:solidFill>
@@ -10689,7 +10689,7 @@
               </a:ln>
               <a:extLst>
                 <a:ext uri="{91240B29-F687-4f45-9708-019B960494DF}">
-                  <a14:hiddenLine xmlns:a14="http://schemas.microsoft.com/office/drawing/2010/main" xmlns="" w="9525">
+                  <a14:hiddenLine xmlns="" xmlns:a14="http://schemas.microsoft.com/office/drawing/2010/main" w="9525">
                     <a:solidFill>
                       <a:srgbClr val="000000"/>
                     </a:solidFill>
@@ -10754,7 +10754,7 @@
               </a:ln>
               <a:extLst>
                 <a:ext uri="{91240B29-F687-4f45-9708-019B960494DF}">
-                  <a14:hiddenLine xmlns:a14="http://schemas.microsoft.com/office/drawing/2010/main" xmlns="" w="9525">
+                  <a14:hiddenLine xmlns="" xmlns:a14="http://schemas.microsoft.com/office/drawing/2010/main" w="9525">
                     <a:solidFill>
                       <a:srgbClr val="000000"/>
                     </a:solidFill>
@@ -10844,7 +10844,7 @@
               </a:ln>
               <a:extLst>
                 <a:ext uri="{91240B29-F687-4f45-9708-019B960494DF}">
-                  <a14:hiddenLine xmlns:a14="http://schemas.microsoft.com/office/drawing/2010/main" xmlns="" w="9525">
+                  <a14:hiddenLine xmlns="" xmlns:a14="http://schemas.microsoft.com/office/drawing/2010/main" w="9525">
                     <a:solidFill>
                       <a:srgbClr val="000000"/>
                     </a:solidFill>
@@ -10906,7 +10906,7 @@
               </a:ln>
               <a:extLst>
                 <a:ext uri="{91240B29-F687-4f45-9708-019B960494DF}">
-                  <a14:hiddenLine xmlns:a14="http://schemas.microsoft.com/office/drawing/2010/main" xmlns="" w="9525">
+                  <a14:hiddenLine xmlns="" xmlns:a14="http://schemas.microsoft.com/office/drawing/2010/main" w="9525">
                     <a:solidFill>
                       <a:srgbClr val="000000"/>
                     </a:solidFill>
@@ -10996,7 +10996,7 @@
               </a:ln>
               <a:extLst>
                 <a:ext uri="{91240B29-F687-4f45-9708-019B960494DF}">
-                  <a14:hiddenLine xmlns:a14="http://schemas.microsoft.com/office/drawing/2010/main" xmlns="" w="9525">
+                  <a14:hiddenLine xmlns="" xmlns:a14="http://schemas.microsoft.com/office/drawing/2010/main" w="9525">
                     <a:solidFill>
                       <a:srgbClr val="000000"/>
                     </a:solidFill>
@@ -11061,7 +11061,7 @@
               </a:ln>
               <a:extLst>
                 <a:ext uri="{91240B29-F687-4f45-9708-019B960494DF}">
-                  <a14:hiddenLine xmlns:a14="http://schemas.microsoft.com/office/drawing/2010/main" xmlns="" w="9525">
+                  <a14:hiddenLine xmlns="" xmlns:a14="http://schemas.microsoft.com/office/drawing/2010/main" w="9525">
                     <a:solidFill>
                       <a:srgbClr val="000000"/>
                     </a:solidFill>
@@ -11123,7 +11123,7 @@
               </a:ln>
               <a:extLst>
                 <a:ext uri="{91240B29-F687-4f45-9708-019B960494DF}">
-                  <a14:hiddenLine xmlns:a14="http://schemas.microsoft.com/office/drawing/2010/main" xmlns="" w="9525">
+                  <a14:hiddenLine xmlns="" xmlns:a14="http://schemas.microsoft.com/office/drawing/2010/main" w="9525">
                     <a:solidFill>
                       <a:srgbClr val="000000"/>
                     </a:solidFill>
@@ -11213,7 +11213,7 @@
               </a:ln>
               <a:extLst>
                 <a:ext uri="{91240B29-F687-4f45-9708-019B960494DF}">
-                  <a14:hiddenLine xmlns:a14="http://schemas.microsoft.com/office/drawing/2010/main" xmlns="" w="9525">
+                  <a14:hiddenLine xmlns="" xmlns:a14="http://schemas.microsoft.com/office/drawing/2010/main" w="9525">
                     <a:solidFill>
                       <a:srgbClr val="000000"/>
                     </a:solidFill>
@@ -11303,7 +11303,7 @@
               </a:ln>
               <a:extLst>
                 <a:ext uri="{91240B29-F687-4f45-9708-019B960494DF}">
-                  <a14:hiddenLine xmlns:a14="http://schemas.microsoft.com/office/drawing/2010/main" xmlns="" w="9525">
+                  <a14:hiddenLine xmlns="" xmlns:a14="http://schemas.microsoft.com/office/drawing/2010/main" w="9525">
                     <a:solidFill>
                       <a:srgbClr val="000000"/>
                     </a:solidFill>
@@ -11368,7 +11368,7 @@
               </a:ln>
               <a:extLst>
                 <a:ext uri="{91240B29-F687-4f45-9708-019B960494DF}">
-                  <a14:hiddenLine xmlns:a14="http://schemas.microsoft.com/office/drawing/2010/main" xmlns="" w="9525">
+                  <a14:hiddenLine xmlns="" xmlns:a14="http://schemas.microsoft.com/office/drawing/2010/main" w="9525">
                     <a:solidFill>
                       <a:srgbClr val="000000"/>
                     </a:solidFill>
@@ -11488,7 +11488,7 @@
               </a:ln>
               <a:extLst>
                 <a:ext uri="{91240B29-F687-4f45-9708-019B960494DF}">
-                  <a14:hiddenLine xmlns:a14="http://schemas.microsoft.com/office/drawing/2010/main" xmlns="" w="9525">
+                  <a14:hiddenLine xmlns="" xmlns:a14="http://schemas.microsoft.com/office/drawing/2010/main" w="9525">
                     <a:solidFill>
                       <a:srgbClr val="000000"/>
                     </a:solidFill>
@@ -11569,7 +11569,7 @@
               </a:ln>
               <a:extLst>
                 <a:ext uri="{91240B29-F687-4f45-9708-019B960494DF}">
-                  <a14:hiddenLine xmlns:a14="http://schemas.microsoft.com/office/drawing/2010/main" xmlns="" w="9525">
+                  <a14:hiddenLine xmlns="" xmlns:a14="http://schemas.microsoft.com/office/drawing/2010/main" w="9525">
                     <a:solidFill>
                       <a:srgbClr val="000000"/>
                     </a:solidFill>
@@ -11684,7 +11684,7 @@
               </a:ln>
               <a:extLst>
                 <a:ext uri="{91240B29-F687-4f45-9708-019B960494DF}">
-                  <a14:hiddenLine xmlns:a14="http://schemas.microsoft.com/office/drawing/2010/main" xmlns="" w="9525">
+                  <a14:hiddenLine xmlns="" xmlns:a14="http://schemas.microsoft.com/office/drawing/2010/main" w="9525">
                     <a:solidFill>
                       <a:srgbClr val="000000"/>
                     </a:solidFill>
@@ -11774,7 +11774,7 @@
               </a:ln>
               <a:extLst>
                 <a:ext uri="{91240B29-F687-4f45-9708-019B960494DF}">
-                  <a14:hiddenLine xmlns:a14="http://schemas.microsoft.com/office/drawing/2010/main" xmlns="" w="9525">
+                  <a14:hiddenLine xmlns="" xmlns:a14="http://schemas.microsoft.com/office/drawing/2010/main" w="9525">
                     <a:solidFill>
                       <a:srgbClr val="000000"/>
                     </a:solidFill>
@@ -11839,7 +11839,7 @@
               </a:ln>
               <a:extLst>
                 <a:ext uri="{91240B29-F687-4f45-9708-019B960494DF}">
-                  <a14:hiddenLine xmlns:a14="http://schemas.microsoft.com/office/drawing/2010/main" xmlns="" w="9525">
+                  <a14:hiddenLine xmlns="" xmlns:a14="http://schemas.microsoft.com/office/drawing/2010/main" w="9525">
                     <a:solidFill>
                       <a:srgbClr val="000000"/>
                     </a:solidFill>
@@ -11929,7 +11929,7 @@
               </a:ln>
               <a:extLst>
                 <a:ext uri="{91240B29-F687-4f45-9708-019B960494DF}">
-                  <a14:hiddenLine xmlns:a14="http://schemas.microsoft.com/office/drawing/2010/main" xmlns="" w="9525">
+                  <a14:hiddenLine xmlns="" xmlns:a14="http://schemas.microsoft.com/office/drawing/2010/main" w="9525">
                     <a:solidFill>
                       <a:srgbClr val="000000"/>
                     </a:solidFill>
@@ -11997,7 +11997,7 @@
               </a:ln>
               <a:extLst>
                 <a:ext uri="{91240B29-F687-4f45-9708-019B960494DF}">
-                  <a14:hiddenLine xmlns:a14="http://schemas.microsoft.com/office/drawing/2010/main" xmlns="" w="9525">
+                  <a14:hiddenLine xmlns="" xmlns:a14="http://schemas.microsoft.com/office/drawing/2010/main" w="9525">
                     <a:solidFill>
                       <a:srgbClr val="000000"/>
                     </a:solidFill>
@@ -12087,7 +12087,7 @@
               </a:ln>
               <a:extLst>
                 <a:ext uri="{91240B29-F687-4f45-9708-019B960494DF}">
-                  <a14:hiddenLine xmlns:a14="http://schemas.microsoft.com/office/drawing/2010/main" xmlns="" w="9525">
+                  <a14:hiddenLine xmlns="" xmlns:a14="http://schemas.microsoft.com/office/drawing/2010/main" w="9525">
                     <a:solidFill>
                       <a:srgbClr val="000000"/>
                     </a:solidFill>
@@ -12155,7 +12155,7 @@
               </a:ln>
               <a:extLst>
                 <a:ext uri="{91240B29-F687-4f45-9708-019B960494DF}">
-                  <a14:hiddenLine xmlns:a14="http://schemas.microsoft.com/office/drawing/2010/main" xmlns="" w="9525">
+                  <a14:hiddenLine xmlns="" xmlns:a14="http://schemas.microsoft.com/office/drawing/2010/main" w="9525">
                     <a:solidFill>
                       <a:srgbClr val="000000"/>
                     </a:solidFill>
@@ -12245,7 +12245,7 @@
               </a:ln>
               <a:extLst>
                 <a:ext uri="{91240B29-F687-4f45-9708-019B960494DF}">
-                  <a14:hiddenLine xmlns:a14="http://schemas.microsoft.com/office/drawing/2010/main" xmlns="" w="9525">
+                  <a14:hiddenLine xmlns="" xmlns:a14="http://schemas.microsoft.com/office/drawing/2010/main" w="9525">
                     <a:solidFill>
                       <a:srgbClr val="000000"/>
                     </a:solidFill>
@@ -12279,7 +12279,7 @@
               </a:ln>
               <a:extLst>
                 <a:ext uri="{91240B29-F687-4f45-9708-019B960494DF}">
-                  <a14:hiddenLine xmlns:a14="http://schemas.microsoft.com/office/drawing/2010/main" xmlns="" w="9525">
+                  <a14:hiddenLine xmlns="" xmlns:a14="http://schemas.microsoft.com/office/drawing/2010/main" w="9525">
                     <a:solidFill>
                       <a:srgbClr val="000000"/>
                     </a:solidFill>
@@ -24426,14 +24426,14 @@
           </a:ln>
           <a:extLst>
             <a:ext uri="{909E8E84-426E-40dd-AFC4-6F175D3DCCD1}">
-              <a14:hiddenFill xmlns:a14="http://schemas.microsoft.com/office/drawing/2010/main" xmlns="">
+              <a14:hiddenFill xmlns="" xmlns:a14="http://schemas.microsoft.com/office/drawing/2010/main">
                 <a:solidFill>
                   <a:srgbClr val="FFFFFF"/>
                 </a:solidFill>
               </a14:hiddenFill>
             </a:ext>
             <a:ext uri="{91240B29-F687-4f45-9708-019B960494DF}">
-              <a14:hiddenLine xmlns:a14="http://schemas.microsoft.com/office/drawing/2010/main" xmlns="" w="9525">
+              <a14:hiddenLine xmlns="" xmlns:a14="http://schemas.microsoft.com/office/drawing/2010/main" w="9525">
                 <a:solidFill>
                   <a:srgbClr val="000000"/>
                 </a:solidFill>
@@ -26023,14 +26023,14 @@
           </a:ln>
           <a:extLst>
             <a:ext uri="{909E8E84-426E-40dd-AFC4-6F175D3DCCD1}">
-              <a14:hiddenFill xmlns:a14="http://schemas.microsoft.com/office/drawing/2010/main" xmlns="">
+              <a14:hiddenFill xmlns="" xmlns:a14="http://schemas.microsoft.com/office/drawing/2010/main">
                 <a:solidFill>
                   <a:srgbClr val="FFFFFF"/>
                 </a:solidFill>
               </a14:hiddenFill>
             </a:ext>
             <a:ext uri="{91240B29-F687-4f45-9708-019B960494DF}">
-              <a14:hiddenLine xmlns:a14="http://schemas.microsoft.com/office/drawing/2010/main" xmlns="" w="9525">
+              <a14:hiddenLine xmlns="" xmlns:a14="http://schemas.microsoft.com/office/drawing/2010/main" w="9525">
                 <a:solidFill>
                   <a:srgbClr val="000000"/>
                 </a:solidFill>
@@ -36912,13 +36912,13 @@
                   </p:cNvPr>
                   <p:cNvCxnSpPr>
                     <a:cxnSpLocks/>
-                    <a:stCxn id="35" idx="4"/>
-                    <a:endCxn id="37" idx="0"/>
+                    <a:stCxn id="37" idx="0"/>
+                    <a:endCxn id="35" idx="4"/>
                   </p:cNvCxnSpPr>
                   <p:nvPr/>
                 </p:nvCxnSpPr>
                 <p:spPr>
-                  <a:xfrm>
+                  <a:xfrm flipV="1">
                     <a:off x="6543675" y="4038600"/>
                     <a:ext cx="0" cy="1114424"/>
                   </a:xfrm>

</xml_diff>

<commit_message>
reordering slides and renaming
</commit_message>
<xml_diff>
--- a/slides/01-2-GraphsDFSTopoSCC.pptx
+++ b/slides/01-2-GraphsDFSTopoSCC.pptx
@@ -155,6 +155,183 @@
 </p:presentation>
 </file>
 
+<file path=ppt/ink/ink1.xml><?xml version="1.0" encoding="utf-8"?>
+<inkml:ink xmlns:inkml="http://www.w3.org/2003/InkML">
+  <inkml:definitions>
+    <inkml:context xml:id="ctx0">
+      <inkml:inkSource xml:id="inkSrc0">
+        <inkml:traceFormat>
+          <inkml:channel name="X" type="integer" min="-2.14748E9" max="2.14748E9" units="cm"/>
+          <inkml:channel name="Y" type="integer" min="-2.14748E9" max="2.14748E9" units="cm"/>
+          <inkml:channel name="F" type="integer" max="32767" units="dev"/>
+        </inkml:traceFormat>
+        <inkml:channelProperties>
+          <inkml:channelProperty channel="X" name="resolution" value="1000" units="1/cm"/>
+          <inkml:channelProperty channel="Y" name="resolution" value="1000" units="1/cm"/>
+          <inkml:channelProperty channel="F" name="resolution" value="0" units="1/dev"/>
+        </inkml:channelProperties>
+      </inkml:inkSource>
+      <inkml:timestamp xml:id="ts0" timeString="2026-01-28T17:39:33.206"/>
+    </inkml:context>
+    <inkml:brush xml:id="br0">
+      <inkml:brushProperty name="width" value="0.05292" units="cm"/>
+      <inkml:brushProperty name="height" value="0.05292" units="cm"/>
+      <inkml:brushProperty name="color" value="#FFC000"/>
+    </inkml:brush>
+  </inkml:definitions>
+  <inkml:trace contextRef="#ctx0" brushRef="#br0">3571 11556 24575,'30'0'0,"-13"0"0,9-4 0,0 0 0,-6 2 0,19-13 0,-25 14 0,16-12 0,-6 6 0,3 0 0,-5 2 0,-2 2 0,-9 2 0,9-3 0,-11 3 0,6 0 0,-6-1 0,4 1 0,-6-2 0,0 1 0,1 0 0,2 2 0,4 0 0,7 0 0,15 1 0,6-2 0,-7-1 0,3 0-879,-1 2 1,3 0 0,-2-1 878,9-3 0,-5-1 0,-14 4 0,-3-1 0,17-3 0,-12-1 0,-7 3 0,17-2 0,7 3 0,-12 2 0,5-2 0,5 1 0,-23-3 0,17 3 0,-22-4 2635,-4 5-2635,-1-3 0,-4 3 0,-2 0 0,2 2 0,22-1 0,-6 3 0,18-1 0,-18-1 0,11 1 0,-20-3 0,8 1 0,-17 0 0,4 1 0,7 1 0,3-2 0,16 2 0,-14-3 0,17 0 0,-24 0 0,28 0 0,-26 0 0,11 0 0,-1 0 0,-15 0 0,21 0 0,6-4 0,-4 3 0,10-3 0,-25 4 0,10 0 0,-15 0 0,16 1 0,-7 4 0,-4-2 0,-1 2 0,-4-3 0,-3-1 0,0 1 0,0-2 0,-4 0 0,7 0 0,-5 0 0,8 0 0,-9 0 0,5 2 0,-5-1 0,6 1 0,-3 0 0,11-1 0,1 1 0,0-2 0,-7 0 0,-7 0 0,-6 0 0,2 0 0,2 2 0,4 2 0,-1-1 0,-1 2 0,-4-5 0,-2 2 0,0-2 0,2 0 0,-2 0 0,2 0 0,-2 0 0,0 0 0,2 2 0,-1-2 0,0 2 0,-1-2 0,1 0 0,-3 0 0,0 0 0</inkml:trace>
+  <inkml:trace contextRef="#ctx0" brushRef="#br0" timeOffset="1017">5973 11348 24575,'12'6'0,"2"0"0,-3-1 0,-1-2 0,-4-1 0,-2-1 0,2 0 0,2 5 0,2 0 0,1 8 0,-1-3 0,-4 1 0,-2-6 0,1 3 0,-2 0 0,7 5 0,-5-4 0,4 4 0,-4-6 0,-1 0 0,-1-4 0,0 0 0,-1-2 0,1 2 0,0 2 0,1 0 0,-2 0 0,0 0 0,-2-2 0,0 0 0,0 0 0,-4 4 0,2-3 0,-7 7 0,1-3 0,-11 6 0,9-7 0,-7 1 0,9-5 0,-2 0 0,1-2 0,3 2 0,3-2 0,1 4 0,-6 2 0,3-3 0,-1 0 0,5-5 0</inkml:trace>
+  <inkml:trace contextRef="#ctx0" brushRef="#br0" timeOffset="3000">3683 13103 24575,'11'-2'0,"26"-4"0,-8 5 0,8-3 0,5 0 0,5 3 0,3 1-1093,-6-3 1,4 0 0,-1 0-1,-4 3 1,0 0 0,0-1 820,0 0 1,0-1-1,-3 0 136,6 0 0,-4 0 136,-3 1 0,-1 1 795,-1-3 0,0 1-795,-4 2 0,1 0 0,6 0 0,1 0-714,-10 0 1,1 0 713,4 0 0,2 0 0,8 0 0,0 0 0,-11 0 0,0 0 0,-1 1 0,3 1 0,-3 0 0,5-2 0,-1 1 0,-4 0 0,2 1 0,0-1 894,-2 0 0,-1-2 0,1 1-894,5 0 0,1 1 0,-2-2 0,6-1 0,-3 0 0,-12 2 0,-2-1 0,-1-1 0,-1 0 0,12 2 2128,1 0-2128,-2 0 0,3 0 0,-11 0 0,1 0 0,15 0 0,1 0-566,-19 0 1,0 0 565,5 0 0,0 0 915,-5 0 0,0 0-915,13-2 0,0 0 334,-7 1 0,-1 1-334,18-7 0,-28 7 0,-11-2 1301,-4 2-1301,7 0 0,17 3 0,18 1 0,-22-2 0,0 0 0,23 1 0,-23-3 0,0 0 0,-6 0 0,18 0 0,6 4 0,-9-4 0,-4 4 0,-21-4 0,-4 0 0,-2 0 0,2 0 0,16 2 0,-7-2 0,20 3 0,-18-3 0,1-2 0,-8 1 0,-6 0 0,-2 1 0</inkml:trace>
+  <inkml:trace contextRef="#ctx0" brushRef="#br0" timeOffset="3803">6924 12968 24575,'21'5'0,"17"8"0,-9-7 0,1 0 0,-6 2 0,2-1 0,14 2 0,-3-1 0,-8-1 0,6 1 0,-1-2 0,-16-1 0,30 5 0,-37-5 0,8 2 0,-9 1 0,-5-3 0,2 4 0,-4-4 0,2 2 0,-2 3 0,1 1 0,-2 1 0,-2-2 0,0-2 0,-2-2 0,-2 2 0,-13 3 0,-3 0 0,-11 6 0,7-9 0,2 2 0,7-5 0,-4 2 0,-1 4 0,3-1 0,2 3 0,11-7 0,0-2 0,4-2 0</inkml:trace>
+  <inkml:trace contextRef="#ctx0" brushRef="#br0" timeOffset="8949">2409 11303 24575,'6'1'0,"0"0"0,2 4 0,-1-2 0,9 10 0,-7-5 0,5 6 0,11 7 0,-6-4 0,7 6 0,-2 0 0,9 13 0,-9-9 0,8 7 0,-10-6 0,-11-16 0,10 13 0,-11-15 0,0 2 0,15 14 0,-13-11 0,11 6 0,-17-13 0,1-2 0,-2 2 0,3 2 0,-1 0 0,3 0 0,-2 0 0,-2-3 0,0-2 0,-2-1 0,0-1 0,0 0 0,0-1 0,0-1 0,5-16 0,-1 2 0,6-18 0,-1 8 0,-3 1 0,2-3 0,-1 2 0,0 0 0,4-9 0,0 0 0,-3 6 0,0 2 0,5-19 0,-5 8 0,-5 6 0,-1 6 0,2-11 0,-4 6 0,2 1 0,-4 6 0,2 10 0,-1-2 0,0 1 0,4-12 0,-3 10 0,1-8 0,0 7 0,-3 8 0,0-5 0,0 10 0,-2-2 0</inkml:trace>
+  <inkml:trace contextRef="#ctx0" brushRef="#br0" timeOffset="28901">12663 14086 24575,'29'0'0,"15"0"0,8 0 0,-16 0 0,0 0 0,2 0-1093,9 0 1,1 0 0,1 0-1,2 0 1,0 0 0,-3 0 711,-11 0 0,-2 0 0,2 0 381,-1 0 0,3 0 0,0 0 0,-2 0 454,4 0 0,-1 0 0,-1 0-454,1-1 0,1-1 0,-4 0 0,4 0 0,-5 0 0,12-3 1371,-32 0-1371,-5 3 0,-1-4 0,1 1 3276,6-1-2429,-8 2-637,4 2 0,-10 0 0,0 2 1</inkml:trace>
+  <inkml:trace contextRef="#ctx0" brushRef="#br0" timeOffset="30103">8988 16844 24575,'11'0'0,"-2"0"0,11-3 0,-9 2 0,15-2 0,15-1 0,0 1 0,7 0-820,-10 1 1,5-1 0,0 0 0,-1 1 392,2 0 1,-1 0 0,2 0 426,-3 0 0,3-1 0,-2 1 0,-6-1 0,-2 1 0,-5-1 0,19-4 0,-30 3 0,-17 2 0</inkml:trace>
+  <inkml:trace contextRef="#ctx0" brushRef="#br0" timeOffset="30816">9763 16629 24575,'10'8'0,"9"4"0,-3-2 0,14 11 0,-12-12 0,17 15 0,-17-12 0,16 13 0,-16 3 0,-3 2 0,-7-3 0,-15-1 0,2-17 0,-6 7 0,2-9 0,2-1 0,-1 0 0,6-2 0,-2 0 0,2-2 0,-4 1 0,2 0 0,-5 1 0,5 0 0,-3-2 0,3 3 0,-2 0 0,-4 3 0,4-2 0,0-2 0,4-2 0</inkml:trace>
+  <inkml:trace contextRef="#ctx0" brushRef="#br0" timeOffset="32820">6442 12037 24575,'22'11'0,"-5"-1"0,10 0 0,2 3 0,-5-8 0,17 5 0,6 1 0,-19-7 0,4 0 0,6 1 0,7 1 0,1 0 0,-7-1-1145,-5 0 1,-2-1 1144,9 0 0,3-1 0,-11-1 0,-16 0 0,27 2 0,-32-3 0,18 5 0,-22-6 0,5 2 0,-9-2 0,-2 0 0,0 0 0</inkml:trace>
+  <inkml:trace contextRef="#ctx0" brushRef="#br0" timeOffset="33284">7193 12072 24575,'25'0'0,"4"3"0,4 0 0,2 6 0,-5-5 0,5 9 0,-19-7 0,8 4 0,-13-4 0,-5 5 0,-8 12 0,-18 14 0,-2-5 0,-10 4 0,5-9 0,12-10 0,-4 2 0,11-9 0,-1-5 0,1 2 0,1-5 0,2 1 0,-1-2 0,4-1 0,0 0 0</inkml:trace>
+  <inkml:trace contextRef="#ctx0" brushRef="#br0" timeOffset="38983">9468 14220 24575,'48'-3'0,"1"1"0,-6-1 0,4 0 0,-8-1 0,4 0 0,2-1 0,-3 1-1093,2 0 1,-3 0 0,6-1 620,-6 2 0,4-1 1,4-1-1,1 1 0,-1 1 1,-3 0 10,1 0 1,-1 1 0,-2 1 0,2 0 0,2 0 460,-5 0 0,1 0 0,2 1 0,0 0 0,0 0 0,-2 0 0,-3 1-325,2 0 1,-2 1-1,-1 1 1,-1 0-1,-1 0 325,6 2 0,0 0 0,-2 1 0,-2 0 0,-3 1 0,-3 0 0,-1 1-516,13 2 1,-2 0 515,-8-4 0,-5 0 456,0 2 0,-12-8 0,-17 0 0</inkml:trace>
+  <inkml:trace contextRef="#ctx0" brushRef="#br0" timeOffset="40133">9752 17118 8191,'17'-3'0,"15"-6"3276,-7 1-2383,0-1 1,2 0-894,18 1 0,-20 1 0,2 0 944,12 4 1,1 2-945,-14-2 0,2 2-223,4 2 1,4 1 0,-1 0 222,6 0 0,4 2 0,-7-1 0,5 2 0,4 0 0,1-1 0,0 1 0,-6-2 0,2 1 0,0-1 0,0 0 0,0 0 0,0 0 0,1 1 0,0 0 0,-1 1 0,1-1 0,-1 0 0,0-1 0,7 0 0,1 0 0,-1-1 0,-3 0 0,-4 0 0,4 0 0,-4 0 0,-1-1-524,-2-1 1,0 0 0,-1 0 523,-2 0 0,-2 0 0,1 0 0,-2 0 0,0 0 0,3 0 0,3 0 0,3 0 0,2 0 0,-3 0 0,5 0 0,-1 0 0,4 0 0,-12 0 0,4 0 0,2 0 0,0 0 0,-2 0 0,-3 0 0,3 0 0,-2 0 0,-2 0 0,0 0-349,1-1 1,-1 0-1,0 0 1,-2 0 348,1 1 0,-1 0 0,-3-1 0,6-3 0,-1 0 896,-1 4 1,-1 0-897,-2-4 0,-5 1 0,0 2 3276,-9-2-1990,-13 3 1168,10 0-2454,-8 0 3276,23 0-2787,-7 0 0,0 0-489,12 0 0,-10 1 0,-4-2 0,-16-1 0,-1 2 0,-7-2 0</inkml:trace>
+  <inkml:trace contextRef="#ctx0" brushRef="#br0" timeOffset="62216">2489 11065 24575,'-12'14'0,"0"3"0,1-7 0,1 1 0,-1-2 0,3-1 0,-1 10 0,-1 3 0,0 12 0,1-2 0,3-8 0,0 3 0,2 1 0,0 10 0,3-10 0,2 2 0,5 3 0,0 1 0,-1-4 0,1 1 0,3 1 0,1-2 0,-1 8 0,0-13 0,0-1 0,3 6 0,6 1 0,1-2 0,-2-6 0,3 1 0,2-1 0,11 3 0,-7-7 0,4 0 0,0-3 0,2-1 0,2 0-334,2-1 1,1 0 0,1-1 333,6 0 0,1 0 0,-3-2-1471,3 0 0,-2-1 1471,-8-4 0,1 0 0,-6-2 0,6-2-70,-3 0 1,5 0-1,-2-2 70,0-5 0,0-3 0,-2-1 0,1-3 0,-2-1-556,-2-4 1,-4-4 555,-5-4 0,-5-1 0,-4-9 187,-2-4 1,-1-3-188,-2 8 0,-1-2 0,2-1 0,1-4 0,-1 1 0,0-6 0,-2 2 404,1 9 1,-2 1-405,-3-5 0,-2 3 0,-1 3 33,-4-3 0,-5-2-33,-4 0 0,-3 0 0,-1 1 0,-3-2-232,1 6 1,-2-1 0,2 3 231,1 6 0,0 0 0,-2-1 0,-2-2 0,3 4-150,-9-10 150,8 10 0,-1 0 0,0 4 0,-3 3 0,-14 1 0,-3 2 0,6-3 0,-3 1-219,1 8 0,-3 2 0,1 1 219,-3 3 0,-1 1-948,-3 0 1,-4 0-1,1 1 948,9 1 0,2 0 0,-2 0 0,-6 0 0,-2 0 0,3 0 0,10 0 0,1 0 0,2 0 729,-15 2 0,3 0-729,14-1 0,3 1 0,-13 3 488,32 1-488,2 1 0,4-3 0,-2 0 0</inkml:trace>
+  <inkml:trace contextRef="#ctx0" brushRef="#br0" timeOffset="65871">13495 12715 24575,'24'-8'0,"13"-1"0,8 1 0,-3 1 0,5 1 0,-1 0-1093,-2 0 1,1 1 0,0-1-1,3 1 1,1-1 0,-4 3 206,-1 2 0,1 1 886,-6-2 0,4-1 0,1 0 0,-2 1 0,-2 0 0,-2 0 0,5 0-163,-3-1 0,7 1 0,2-1 0,1 0 0,-2 0 0,-3 0 163,3 0 0,-3 0 0,-1 0 0,0 0 0,4 0 0,0 0 0,-1 0 0,-1 1 0,5 0 0,-1 1 0,-7-1 0,-9 0 0,-2 0 913,5 0 1,0-1-914,-6-2 0,-4-1 0,2 1 0,-11 4 3276,-16 9-2676,3 10 2676,4 10-3114,-2 3 1,3 5-163,2-5 0,1 1 0,0 3-1093,0 8 1,1 2 0,0 0 1033,1-5 0,1 0 0,-1 0 59,-1 2 0,0 0 0,-1-1 0,2 4 0,1 1-468,-3-6 0,0 3 1,2 0 467,1 1 0,2 0 0,-1 0 0,1 1 0,1 1 0,-1-3 0,-1-4 0,1-2 0,-2-3 0,2 4 0,-1-2 0,-1-2 0,0-2 0,-3-6 0,-1 0 0,-1-2 0,1 2-117,5 10 1,0 3 116,-3-5 0,-1 0 0,5 8 0,-2 2-633,-2-3 1,-1-2 632,-4-14 0,-1-1 2403,-2 12-2403,5 3 1484,-5-5-1484,1 6 0,2-1 0,-3-7 273,-2-14-273,3 14 1637,-4-22-1637,7 32 558,-2-19-558,-29 13 0,-10-15 0,-7-2 0,2-6 0,-4-1 0,-2 1-820,4-1 1,-2 0 0,0 1 0,0-1 161,3-1 0,0 0 0,1-1 1,1 0 657,-8 3 0,2-2 0,-4-1-521,5-3 1,-2-2 0,-3-1-1,0 0 1,1-1 520,3-2 0,0-1 0,0 0 0,0-1 0,-2 1 0,1 0 0,-3 0 0,0 0 0,0 0 0,1-1 0,4 0 0,-6-2 0,2 0 0,2 0 0,2 0 0,-4 1 0,2 0 0,7 1-658,-12 1 658,20 0 0,2 0 0,2 0 0,-1 2 0,-4 0 0,-6-1 0,-3-1 0,-10 2 0,0 0 1638,9-2 0,3 0-1200,7 0 1,5 0 380,11 0 0,4 0 0,4 0 0</inkml:trace>
+  <inkml:trace contextRef="#ctx0" brushRef="#br0" timeOffset="71900">18287 9942 24575,'-26'-6'0,"-6"3"0,-16 0-1639,14 0 1,-1 1 1136,6 1 0,-2 1 502,-2-1 0,-5-1 0,2 0 0,-10-1 0,-2 1 0,6 1 0,-5 1 0,-2-1 0,2 2 0,2-1 0,1 0 0,-1 2 0,1 0 0,-4 2 0,1 1 0,0 1 0,2 3 0,5 2 0,2 2 0,2 1 0,3 1 0,-11 9 0,6 3 0,4 4 0,5 2 0,12-9 0,1 2 180,-5 16 1,1 4-181,10-14 0,2 2 0,0 0 0,-1 4 0,0 0 0,3-1-261,3 0 1,4-1 0,1-2 260,7 8 0,3-2 0,3-1 0,2 0 0,2-1 0,3 0 0,-1-6 0,3 0 0,3-2 0,3-3 0,3-1 0,3-2 0,-2-3 0,1-1 0,3-2 0,1-2 0,7-3 0,4-4 0,-1-1 0,-3-3 0,-4 1 0,-3-2 0,3-4 0,-3-1 0,4-3 0,1-1 0,-2-2 0,-5-1 0,1-5 0,-5-2 0,2-2 0,3 0 0,3-2 0,-1-1 0,-3-1 0,2-7 0,-3-2 0,-5 0 0,3-6 0,-4-1 0,-5 2 0,-3 0 0,-8 13 0,-2 1-3,1-7 0,-1-2 3,0-9 0,-2-2 0,-3 7 0,-2 0 0,2-11 0,-1 0 0,-5 15 0,-1 3 1962,4-11-1962,-4-6 762,-7 14-762,-9 0 0,-7-2 0,0 7 0,-3-1 0,0 2-477,-1 1 0,-1 1 0,-1 0 477,-3-1 0,-2 0 0,2 3 0,-5 0 0,3 4-275,11 2 1,0 1 274,-6 0 0,1 0-95,-10-8 95,3 3 0,9 4 0,22 12 0</inkml:trace>
+  <inkml:trace contextRef="#ctx0" brushRef="#br0" timeOffset="72284">17892 9931 17609,'8'-6'0,"13"-9"851,6-6 0,5-4-851,-7 6 0,2-1 0,4-2 0,-1-2 0,5-2 0,1-2 0,1-1 0,-1 0-656,1-1 1,1 0-1,0-1 1,0 0 0,0-1 302,-5 6 1,0-1 0,0 0 0,0 0-1,0 0 1,-1-1-2,5-4 1,0-1-1,0 0 1,-2 0 0,-1 1 353,0-1 0,-2 0 0,-1 0 0,2-3-151,-6 4 1,2-1 0,0-1 0,0-2 0,0 1 0,-1-1 150,-1 1 0,0 0 0,0-1 0,0 0 0,-1 0 0,0 0 0,1-1 0,-1 0 0,1-1 0,-1 1 0,-1 0 0,-1 2 0,4-9 0,0 2 0,-3 1 0,-2 3 0,-3 1 0,-2 3 0,-2 3 163,-4 6 0,-1 3-163,4-12 0,-12 30 0,-2 2 0</inkml:trace>
+  <inkml:trace contextRef="#ctx0" brushRef="#br0" timeOffset="72783">18488 10355 24054,'35'20'0,"0"1"0,0-1 0,-5-2 0,0 0 0,1-2 0,6-2 0,2-2 0,3 0-820,-1-1 1,2 0 0,1 0 0,-1-2-274,5 1 1,-1-2 0,3 0 436,-7 0 1,3 0-1,2 0 1,-2 0 0,-2-2 197,-5-2 0,-2-1 0,-1 0 0,1-1 458,13 2 0,0 0 0,0 0 0,-2 0 0,0-1 0,-1 0 0,-4 0 0,-2-1 0,1 0 0,-1 0 0,1 0 0,0 0 62,8 1 1,2 1-1,-4-1-62,-14-1 0,-1-1 0,3 2 0,2 3 0,6 1 0,1 1 0,-1 0 0,-5 0 0,2 1 0,-5-1 0,4 2 0,5 0 0,4 2 0,-2-1 0,-8-1 0,-10-1 0,-5-1 0,18 1 0</inkml:trace>
+  <inkml:trace contextRef="#ctx0" brushRef="#br0" timeOffset="73383">21236 10347 24575,'-28'25'0,"12"-5"0,-1 5 0,-1 3 0,-1 4 0,1-1-1639,-5 11 1,2 0 720,3 0 0,3-1 918,5-14 0,2 0 680,2 2 0,4 2-680,4 7 0,3 1 0,0-2 0,2 0-883,9 7 1,6-1 882,2-6 0,4-2 0,1-6 0,3 1 0,1-1 0,2 1 0,0-1 0,6-1 0,-5-8 0,4-1 0,2 0 0,2-2 0,-1-1 0,2-2 0,1-2 0,0-1 0,1-2 0,1 0-547,-5-2 1,0-1 0,1-1 0,0 0 0,-1-2 0,-1-1 210,1-2 0,0 0 0,-2-2 0,-1-2 0,-2-1 336,14-7 0,-4-3 0,-7-1 131,-5-2 0,-6-5-131,-4-13 0,-6-3-198,-7 16 1,-4-4 197,-5-16 0,-3-8 0,-5-1 0,-2 16 0,-3 1 0,-2-2 0,0 0-397,-2-10 1,-1-1 0,-2-1-1,-2 3 397,0 7 0,-3 2 0,0 1 0,-1 1 0,-5-4 0,0 2 0,-2 4 804,3 7 0,-1 3 0,0 2-804,-11-10 0,-3 3 9,7 8 1,-2 1-1,-3 3-9,0 3 0,-3 1 0,-1 2 0,0 1 0,-2 1 0,-1 1 0,1 1 0,0 0 0,4 0 0,1 0 0,1 1 0,3 2 0,-18 2 0,12 2 0,24-1 0</inkml:trace>
+  <inkml:trace contextRef="#ctx0" brushRef="#br0" timeOffset="74050">19350 7410 24575,'-3'26'0,"-1"0"0,3 10 0,5 2 0,4 0 0,7 2-820,1-8 1,6 3 0,2 0 0,1-3-274,6 7 1,2-3 0,4-1 435,-4-4 1,4 1-1,0-2 1,0-4 656,6 0 0,-1-4 0,4-1 147,-6-3 1,1-1 0,2-1 0,-1-3-148,7 0 0,-1-5 0,0-1 418,3-1 1,-1-2 0,-7-11-419,-11-14 0,-5-7 0,-7-3 0,-2-8 0,-9-3-659,-9 2 1,-4-3-1,-3 1 659,-2-6 0,-4 1 0,-4 3 0,-4-2 0,-2 1 0,5 11 0,-2-1 0,1 2 0,0 1 0,0-2 0,1 2 0,0 2 0,-8-3 0,1 0 0</inkml:trace>
+  <inkml:trace contextRef="#ctx0" brushRef="#br0" timeOffset="74750">22143 9688 24575,'0'13'0,"5"12"0,-2-11 0,3 12 0,-4-14 0,-2-2 0,0-5 0,2-2 0,15-21 0,9-16 0,-3 4 0,2-5 0,3-2-656,-3 4 1,2-2-1,2-2 1,0-1 0,0 3-1,-4 1 1,0 2-1,1 0 1,0-1 0,2-1 616,0 0 1,2-2 0,1 0-1,1 0 1,-1 1 0,0 2-543,2-1 1,-1 2-1,0 0 1,1 1-1,2-2 581,1 1 0,2-1 0,0 0 0,2 0 0,-2 0 0,0 2 0,-4 4 0,0 0 0,0 1 0,0 1 0,-2 1 0,1 0 0,8-5 0,0 1 0,-1 3 0,-5 1 0,11-4 0,-10 5 0,-10 5 0</inkml:trace>
+  <inkml:trace contextRef="#ctx0" brushRef="#br0" timeOffset="75120">22543 10787 19493,'40'5'0,"1"0"0,-1-1 0,1 1 0,-1 0 0,1-1 0,2-1 0,2 1 0,0-1 0,0-1 0,-3 0 0,-2 0-820,6-3 1,-4 0 0,0-1 0,4 0 272,0 2 1,3-1 0,2 0 0,0 0 0,-1 0 0,-3-1 409,-4-1 0,-2-1 0,-2 0 0,2 1 0,1-1 137,3 2 0,2-1 0,1 1 0,1 0 0,0 0 0,1 0 0,-2 0 0,1-1 0,0 0 0,1 0 0,0 1 0,1-1 0,-2 1-185,2 1 1,-1 0-1,1 0 1,0 0-1,-1 0 1,-1 1 0,-1-1 184,3 0 0,-1 0 0,-1 0 0,-1 0 0,-1 0 0,-2 0-64,0 1 0,1 0 0,-3 0 0,-3 0 0,-6 0 0,6 0 0,-7 0 0,15 0 0</inkml:trace>
+  <inkml:trace contextRef="#ctx0" brushRef="#br0" timeOffset="75555">25313 9941 24575,'-20'36'0,"9"-4"0,2 5 0,5-5 0,1 4 0,1-1-1093,1 0 1,1-1 0,2 1-1,2 7 1,1 2 0,2-5 990,4-2 1,3-2 101,0-5 0,1 2 0,3-2 122,1-3 0,2 0 0,4 0-122,0-1 0,3 2 0,2-1 0,4-1 0,2-1 0,3-1 0,3 0 0,1-2 0,1-1-547,-5-5 1,0-1 0,2-1 0,0-1 0,1-1 0,0 0 468,2 0 0,2-1 0,0 0 1,-1-1-1,0-3 0,-2-2-457,2-4 1,-1-1-1,-1-3 1,-1-1 0,-3-2 534,11-2 0,-4-2 0,-6-5 417,2-10 0,-10-5-417,-10-3 0,-10-5 0,-12-1 0,-9-5 0,-1 1 0,-1 6 0,-2 1 0,-2-1-341,-1 1 0,-3-3 0,-1 2 1,-1 2 340,-4 2 0,-1 2 0,-1 1 0,-1-3 0,-1 1 0,4 3 0,2 3 0,2 3 0,1 3 0,0 1 0</inkml:trace>
+  <inkml:trace contextRef="#ctx0" brushRef="#br0" timeOffset="76119">24006 7720 24575,'-26'22'0,"0"0"0,-1-2 0,1 0 0,5-2 0,2 2 0,1 17 0,9 5-1639,13 0 1,9 2 1198,-2-10 0,3 1 0,5-3-287,8-3 0,5-3 1,1-3 726,-1-3 0,1-2 0,1-2 0,1 0 0,2-1 0,1-2 0,1 1 0,1-1 0,3-1 0,-2-4 0,3-2 0,1 0 0,-2-3 0,-4-1 0,-1-2 0,0-1 0,0-1 0,13-1 0,-1-2 0,-5-4 0,3-12 0,-10-5 131,-17 9 1,-6-2-132,-4-12 0,-4-2 0,1-8 0,-3 1 0,-1 2 0,-3 11 0,4-10 0</inkml:trace>
+  <inkml:trace contextRef="#ctx0" brushRef="#br0" timeOffset="76867">17212 10355 24575,'38'7'0,"1"0"0,-11-2 0,4 3-1093,10 4 1,6 2 0,-1 1 901,-4-1 1,1 1 0,0 0-512,-6-2 1,1-1 0,-1 1-1,-3-1 702,12 7 0,-8-3 0,-8-2 1427,-15-5-1427,-8-4 0,-4-1 0,2 0 0,-4-1 0,0-2 0</inkml:trace>
+  <inkml:trace contextRef="#ctx0" brushRef="#br0" timeOffset="77220">17847 10319 24575,'-15'12'0,"-4"4"0,3 2 0,-1 3 0,-8 9 0,0 4 0,-4 3 0,1 1-1448,1-1 1,3-1 1447,7-6 0,2-3 0,-10 15-63,4 0 63,-4 0 697,3 1-697,3-5 0,8-11 0,4-12 0,5-11 0</inkml:trace>
+  <inkml:trace contextRef="#ctx0" brushRef="#br0" timeOffset="79716">18062 9874 24575,'5'-4'0,"-1"0"0,2 0 0,-2 0 0,5-5 0,3-4 0,10-7 0,13-15-748,-11 15 748,-2-1 0,1-3 0,-5 5 0,2-1 0,4-7 0,3-4 0,1 0 0,0 0 0,0 0 0,1-1-1093,1-3 1,0-1 0,-1 2 944,4-2 1,0 1 147,-11 9 0,0 1 0,0 0-53,5-3 1,2-2 52,-5 3 0,1-4 0,0-1 0,-1 2 0,0 3 0,-2 2 0,0-1-542,8-11 0,0-1 1,-2 4 541,-4 7 0,0 3 0,3-4 0,-1 1 0,10-4-24,-10 8 0,3-3 1,0 1 23,0-2 0,0-1 0,2 0 0,3-2 0,-4 1 0,-3 0 0,-2 1 0,-3 1 0,-4 2 0,-2-2 2861,3-12-2861,-8 12 112,7-16-112,-2 9 1952,-2 8-1952,-7 20 830,-7 30-830,-8 1 0,-4 5 0,2 2 0,-1 2-1114,-11 10 1,-3 1 1113,3-6 0,-4 1-1093,1-6 1,-4 1 0,1 0 1059,3-5 1,1 0 0,-3 2 32,-3 2 0,-3 3 0,-1 0 0,2 0-450,4-5 0,1 0 0,0 0 0,0 2 450,3-2 0,-1 1 0,1 1 0,0 0 0,2-2 0,-7 9 0,2-2 0,3 0 0,6-4 0,1-1 0,4-2 0,2-3 0,3-3 0,-1 14 0,4-19 1842,8-16-1842,20-45 0,1 5 0,7-6 0,-1 1-522,-4 2 0,-1 1 1,2-3 521,0 2 0,1-3 0,0 1 0,-2 2 0,-3 2 0,-1 2 0,-2-1-419,2-3 1,-2-1 0,-1 0 418,-3 6 0,-1 0 0,0-2-171,1-2 1,1-2 0,-1 0 0,-3 3 170,2-13 0,-2 4 0,3-6 0,-3 6 0,-8 17 3276,-12 33-2340,-8 23-936,-1 0 0,-6 5 515,-2 1 0,-3 4 0,-3 2-515,2-3 0,-1 2 0,-2 2 0,-1 1-547,7-9 1,-2 1 0,-1 1 0,0 1 0,1-1 0,1-2 226,-2 4 0,0-2 0,1 0 0,0 0 1,1 0-133,0-2 1,-1 0 0,1-1 0,2 0 0,2-3 451,-1 3 0,4-2 0,-1 0-78,-3 4 1,-1 1 0,3-3 77,2 0 0,2-1 0,-3 3 0,2-3 0,1-1 0,15-23 0,4-8 1394,12-14-1394,5-5 0,7-5 0,1-2 0,-1-1 0,3-3 0,1 0 0,-1 0 359,-2 2 1,1 0 0,-1 0 0,1 0-360,1-2 0,1-1 0,-1 1 0,-4 2 0,5-10 0,-4 1 614,-4-2 0,-3 0-614,-1 10 0,-4 2 331,-5-13-331,-22 56 0,-4 11 0,3-5 0,-1 4-501,-6 7 0,-3 7 1,-3 2-1,0-1 501,2-2 0,-1 0 0,0 0 0,-1 0-162,0 1 0,-1 0 1,1 1-1,-1-2 162,0 0 0,-1 0 0,1-1 0,1-2 0,-2 2 0,2-3 0,1-1-624,-4 6 0,3 0 624,-2 4 0,6-4 0,10-9 0,10-9 0,3-15 0</inkml:trace>
+  <inkml:trace contextRef="#ctx0" brushRef="#br0" timeOffset="80933">18465 10302 24575,'18'-2'0,"14"0"0,-3 4 0,4 1-1639,8 0 1,2 0 643,-10 2 1,2 0 0,0 1 994,2-2 0,0-1 0,4 2-820,5 1 1,3 1 0,2 0 0,-2-1 431,-7-2 0,-1-1 0,0 0 0,1 1 388,-1 0 0,2 1 0,1 0 0,-1-1 0,-1 0 0,5-2 0,0-1 0,-2 0 0,0 1-252,-4 1 1,-1-1 0,0 1 0,1-1 251,5-1 0,1-1 0,1 0 0,-1 1 0,-2 1 0,-1 1 0,-1-1 0,2 1 0,0-1 0,0-1 0,1 0 0,0 2 0,-5 0 0,1 1 0,0 1 0,0-1 0,0 1 0,6 0 0,1 1 0,-1 0 0,-3 0 0,5 2 0,-3 1 0,-2-1 0,9 1 0,-13 1-572,-27-3 572,-4-4 1563,-37 1-1563,-6 1 0,4-1 0,-4 1 1638,-5 0 0,-5 0-1619,6-2 1,-4 0-1,-3-1 1,-3 0-72,3-1 1,-3 0 0,-2-1-1,-1-1 1,-1 1 0,1 0 51,4 1 0,0-1 0,0 1 0,0 0 0,-2 0 0,-1-1 0,0 0-365,2-1 1,-2 0 0,-2 0 0,0 0 0,0-1 0,0 0 0,2 1 0,1 0 0,4 0 325,-6 0 1,4 1 0,1 0 0,1 0-1,1 0 1,-1 0 38,0-1 0,-1 0 0,0 0 0,2 0 0,3 0 0,4 0-307,-5 1 0,5 0 1,5 0 306,4 0 0,4 0 811,0 0-811,28-2 3276,17 1-3077,21-1-199,-4 3 0,8 3 540,-4 2 0,6 2 1,3 1-1,1 0-540,-12-2 0,0-1 0,2 0 0,1 0 0,1 1 0,2 0-410,-3 1 0,3 1 1,1 0-1,2 0 1,-1 1-1,-1-1 0,-1-1 1,-2 0 343,3 0 0,-2-2 0,-1 1 0,-1-1 0,-1 0 1,1 0-314,8 2 1,1 1 0,-2 0 0,-3-2 0,-7-2 378,8-1 0,-9-2 0,9 3 0,-33-5 2411,-47-7-2411,-4 5 0,3-3 0,-5-1 1092,2 3 0,-3 2 0,1-1-809,-8-1 1,-3 0-489,9 1 0,-5-1 0,-2 0 0,-4 1 205,10-1 0,-2 1 0,-1 0 0,-3-1 0,1 0 0,-1 1 0,0-1-469,-1-1 1,-1 1 0,1-1 0,-1 0 0,-1 0 0,0 1 0,-1-1 285,3 1 0,-2-1 0,0 1 0,-1 0 0,0-1 0,2 1 0,1 0 0,2 0-257,-4 0 1,1 0 0,1 0-1,2 0 1,3 0 0,1 1 439,-1-1 0,1 0 0,4 0 0,3 2 401,-6 0 0,6 0-401,-2-3 0,77 4 0,-5 2 0,6 2 0,1-1-40,-3-2 0,1-1 0,2 2 40,0 2 0,3 1 0,1 1 0,0-1 0,-3-3 0,0 0 0,1-1 0,1 2 0,-3 0 0,2 0 0,0 1 0,2-1 0,0 0 365,-4 0 0,3-1 0,0 0 1,0 0-1,-1 0 0,-3-1-365,7 1 0,-1 0 0,-3-1 0,-2 1 1092,10 1 0,-2-1 0,-28-2-640,-41-5-452,-27 0 0,0 4 0,-10 1 0,8 0 0,19-2 0,0 1 0,-6 2 0,-1 1 0,1-1 0</inkml:trace>
+  <inkml:trace contextRef="#ctx0" brushRef="#br0" timeOffset="83354">18387 8410 24575,'-2'13'0,"0"15"0,2-7 0,0 28 0,2-33 0,-2 34 0,2-33 0,-2 28 0,2-30 0,-2 13 0,2-21 0,-2 4 0,0-8 0,0-2 0</inkml:trace>
+  <inkml:trace contextRef="#ctx0" brushRef="#br0" timeOffset="83807">20061 9941 24575,'6'-2'0,"-1"5"0,-1 2 0,-2 20 0,-2-10 0,0 17 0,0 6 0,0-14 0,0 2 0,0 24 0,0 0 0,0-22 0,0-2 0,0 20 0,0-33 0</inkml:trace>
+  <inkml:trace contextRef="#ctx0" brushRef="#br0" timeOffset="87900">21503 10806 24575,'30'13'0,"4"3"0,-21-10 0,26 13 0,-22-10 0,6 5 0,0 1 0,-11-5 0,9 9 0,-1 0 0,-9-8 0,9 12 0,-19-20 0</inkml:trace>
+  <inkml:trace contextRef="#ctx0" brushRef="#br0" timeOffset="88267">21854 10711 24575,'-12'19'0,"1"-7"0,-1 14 0,0 3 0,-1 5 0,-2-1 0,-2 1 0,2-1 0,0-2 0,3-8 0,-2-1 0,-15 16 0,2-3 0,6-10 0,2-6 0,2-1 0,7-4 0,2-5 0,2-1 0,3-4 0</inkml:trace>
+  <inkml:trace contextRef="#ctx0" brushRef="#br0" timeOffset="89201">22504 8428 24575,'0'20'0,"0"-5"0,0 6 0,2-5 0,-1 5 0,1 3 0,-2 2 0,0-8 0,0-3 0,0-11 0,0-2 0,0-28 0,0-1 0,2 2 0,0-1 0,3-16 0,3 6 0,-2-5 0,-2 18 0,-1 9 0,-3 47 0,-2 1 0,0 3 0,0 5 0,-1-1 0,1-2 0,0-5 0,-2-7 0,4-22 0,0-13 0,0 4 0</inkml:trace>
+  <inkml:trace contextRef="#ctx0" brushRef="#br0" timeOffset="90150">24250 10316 24575,'6'15'0,"-2"3"0,-5 13 0,-2-3 0,0-1 0,-2-10 0,4-11 0,-2-7 0,2-6 0,-1-7 0,2-7 0,0-3 0,0 4 0,0 7 0,0 12 0,0 16 0,0 3 0,0 11 0,0-9 0,0-9 0,0-14 0,2-4 0,-1 0 0,1 3 0,-2 0 0,1 7 0,4 15 0,1 11 0,-2 2 0,2-3 0,-6-18 0,2-1 0,-2-7 0,0 0 0</inkml:trace>
+  <inkml:trace contextRef="#ctx0" brushRef="#br0" timeOffset="90933">20477 7449 24575,'-2'-11'0,"0"-3"0,2 6 0,10-31 0,1 3-577,1 6 1,5-4 576,3 0 0,3-4 0,-1 4-1274,0 1 1,3 0 1273,-3 4 0,2-4 0,2-1 0,-2 4 0,0 1 0,-1 3 0,3-2 0,2-2 0,2-1 0,3-1 0,0-1 0,-1 3 0,1-1 0,1-1 0,0 1 0,-1 1 0,-1 1 0,0 0 0,0 1 0,-1 1 0,0 0 0,5-4 0,0 1 0,-2 1 0,-3 4 0,5-6 0,-8 7 0,-8 8 0</inkml:trace>
+  <inkml:trace contextRef="#ctx0" brushRef="#br0" timeOffset="91304">20374 7767 24575,'50'3'0,"-1"-1"0,-6-1 0,6 1 0,1-2 0,-2 1 0,-9-2 0,0 0 0,0-1 0,3 1-547,-3 0 1,4 0 0,1 0 0,1 0 0,-2 0 0,-4-1-274,3 0 1,-3-2 0,-1 1 0,5 1 272,-3 0 1,3 1 0,1 0 0,2 0 0,0 0 0,-1 0 291,-1 0 1,1 0 0,0 0 0,-1 0-1,1 0 1,-1 1 254,5 0 0,1 1 0,-1 0 0,-1 0 0,-4 0 0,-1-1 0,-2 0 0,-4 0 0,-5 1 0,-5 1 0,1 0 0</inkml:trace>
+  <inkml:trace contextRef="#ctx0" brushRef="#br0" timeOffset="91851">20782 6501 24575,'7'38'0,"-6"0"0,6 9 0,-7-18 0,0-27 0,0-18 0,0-3 0,0 1 0,0 11 0</inkml:trace>
+  <inkml:trace contextRef="#ctx0" brushRef="#br0" timeOffset="91967">20797 6547 24575,'0'0'0</inkml:trace>
+  <inkml:trace contextRef="#ctx0" brushRef="#br0" timeOffset="92633">21101 7368 24575,'6'4'0,"0"1"0,-4 2 0,2 4 0,-1 3 0,1 0 0,0 2 0,-2-8 0,2-6 0,1-10 0,0-1 0,0 8 0,-3 19 0,0 2 0,-1 4 0,1-15 0,-2-11 0,0 3 0,0-5 0</inkml:trace>
+</inkml:ink>
+</file>
+
+<file path=ppt/ink/ink2.xml><?xml version="1.0" encoding="utf-8"?>
+<inkml:ink xmlns:inkml="http://www.w3.org/2003/InkML">
+  <inkml:definitions>
+    <inkml:context xml:id="ctx0">
+      <inkml:inkSource xml:id="inkSrc0">
+        <inkml:traceFormat>
+          <inkml:channel name="X" type="integer" min="-2.14748E9" max="2.14748E9" units="cm"/>
+          <inkml:channel name="Y" type="integer" min="-2.14748E9" max="2.14748E9" units="cm"/>
+          <inkml:channel name="F" type="integer" max="32767" units="dev"/>
+        </inkml:traceFormat>
+        <inkml:channelProperties>
+          <inkml:channelProperty channel="X" name="resolution" value="1000" units="1/cm"/>
+          <inkml:channelProperty channel="Y" name="resolution" value="1000" units="1/cm"/>
+          <inkml:channelProperty channel="F" name="resolution" value="0" units="1/dev"/>
+        </inkml:channelProperties>
+      </inkml:inkSource>
+      <inkml:timestamp xml:id="ts0" timeString="2026-01-28T17:33:44.071"/>
+    </inkml:context>
+    <inkml:brush xml:id="br0">
+      <inkml:brushProperty name="width" value="0.05292" units="cm"/>
+      <inkml:brushProperty name="height" value="0.05292" units="cm"/>
+      <inkml:brushProperty name="color" value="#FFC000"/>
+    </inkml:brush>
+  </inkml:definitions>
+  <inkml:trace contextRef="#ctx0" brushRef="#br0">14018 10919 24575,'10'27'0,"-2"0"0,0 4 0,0 1 0,0 4-1093,2-2 1,0 2 0,-2-1 450,-1 5 0,-1-1 642,2-2 0,0 2 0,0-2 682,0 8 1,-2-2-683,0-1 0,-1-4 0,4 7 749,-8-24-749,2-15 0,-2-2 0,0-2 0</inkml:trace>
+  <inkml:trace contextRef="#ctx0" brushRef="#br0" timeOffset="21917">26177 10280 9362,'-5'47'0,"0"0"0,1 1 0,-1-1 0,1 1 0,-1-1 0,1 1 0,-1-1 0,0 1 0,1-1 0,-1 1 0,-1 0 0,1-1 0,0 1 0,-1-2 0,1 0 0,-1 0 0,1-2 0,-1 0-89,0 2 0,0 0 0,0-2 0,-1 0 0,1-1 1,-1 0-1,0 0 89,-2 4 0,1 0 0,-1-1 0,0 0 0,-1 0 0,0 0 0,-1 1 0,-1 1 0,-1-1 0,0 1 0,0-1 0,0-1 226,0 0 1,-1 0-1,0-1 1,0 0 0,0-1-1,-1-2-226,-2 4 0,-1-2 0,0 0 0,0-3 0,0-2 461,-6 10 0,-1-5 0,1-8-461,-1-9 0,1-9 0,2-6 0,9-5 0</inkml:trace>
+  <inkml:trace contextRef="#ctx0" brushRef="#br0" timeOffset="26153">23807 5334 24575,'43'-2'0,"0"0"0,-8 0 0,3 1 0,-1 0 0,-1 1 0,0 0 0,3 0-820,3 1 1,4-1 0,0 0 0,-3-1 735,-2 0 0,-2-1 0,1 1 84,9-1 0,2 1 0,-4-1-84,2-1 0,-7-1 84,-1 0 0,-30 4 0,-9 2 856,9 20-856,1 22 0,2-1 0,1 4-1238,-2 0 1,-2 1 1237,-2-12 0,-1 1 0,0-2 0,0 9 0,-1 0 0,-2-4 0,0 3 0,0-1 37,1 0 1,-1 1 0,0 1-38,0-4 0,-1 2 0,0 0 0,-1-1 0,1 4 0,0-1 0,-1-1-448,-1-4 1,-1 0 0,0-3 447,1 2 0,0 0 0,0-3 0,-1 2 0,2 1-412,3 3 1,1 0-1,0 3 412,-2-6 0,1 2 0,-1 1 0,1 1 0,-1-2 0,-1 1 0,1 1 0,-1-2 0,1-3 0,1 6 0,1-4 0,-1 1 0,-2 9 0,-1 1 0,0-8 2074,4 2-2074,-3 1 1345,-2-31-1345,-2-5 2546,0 1-2546,0 5 1815,-6 14-1815,3-12 0,-13 1 0,-8-21 0,-6-5 0,-16 3 0,-4 0-1639,3-4 1,-4 1 1596,5 4 0,-4 3 0,-1 0 42,8-1 0,-1 1 0,-1 0 0,3 0 0,-6 2 0,1 1 0,1 0 0,-5-2 0,0-1 0,8 3 0,11 3 0,9 1 0,12-1 0,-2 3 0,11-5 0,0-3 0</inkml:trace>
+  <inkml:trace contextRef="#ctx0" brushRef="#br0" timeOffset="26819">25663 5927 24575,'4'8'0,"2"13"0,2 17 0,0 5 0,-2-11 0,-1 1-1093,3 5 1,1 5 0,-1-1-1,-2-3 1,-1 0 0,1 3 1055,-1-3 0,1 2 1,0 2-1,-1-1 170,-1 1 1,1 0 0,-1 0 0,0-1-134,0 8 0,1-1 0,-2-6 670,-1-4 1,1-9-671,2-16 0,-4-21 0,3-1 0,-4 6 0</inkml:trace>
+  <inkml:trace contextRef="#ctx0" brushRef="#br0" timeOffset="31800">25874 8025 8191,'-6'6'0,"-10"6"3276,-5-3-1489,-2 3 1031,-2-2-2818,13-5 1719,-7 6-1719,12-5 3276,-6 0 0,9 0-3044,0-5-232,-1 9 0,3-7 0,-2 12 0,4-4 0,-2 5 0,2-5 0,0 0 0,15 6 0,7 2 0,5 1 0,8 3 0,-12-12 0,10 10 0,-13-9 0,-1 1 0,-9-4 0,5 6 0,0-2 0,7 2 0,-2-7 0,-5-3 0,-2-2 0,-11-2 0,0 0 0</inkml:trace>
+  <inkml:trace contextRef="#ctx0" brushRef="#br0" timeOffset="42835">6883 1863 8191,'-28'-2'0,"1"-1"0,-10 2 3276,-11 8-1489,27 1 1031,2 3-2818,9-3 1719,5 0-1719,2-1 3276,2 9 0,8 27-3160,12-4 0,4 3-116,-5-4 0,3-2-737,1-7 0,2 0 0,2-4 737,5-1 0,3-4 0,5 2 0,5-2 0,0-5 0,4 0 0,0-3 0,0 0 0,0-2 0,0-3 0,3-3 0,-1-4 0,-3-4-148,-9-3 0,-3-4 0,-6-6 148,-7-8 0,-6-7 0,-2-1 0,-2 2 0,-3-1 0,-1-3-1093,-1-10 1,-3-4 0,0 3 920,0 8 0,-1 2 0,0 1 172,1-13 0,-4 0-225,-3 10 0,-4-2 1,-2 3 224,-2 5 0,-3 1 0,-2 1 0,-5-6 0,-3-1 0,-3 4 0,-4 4 0,-4 4 0,-1 4-231,3 7 1,0 4-1,-1 2 231,-14 0 0,0 3 0,-2 1 0,1 3 0,6 4 0,1 2 0,-4 2 0,2 1 0,10-1 0,4 0 316,-7 11-316,16-9 3276,13-1-3218,-11 5 0,13-7 0,-4 2 1</inkml:trace>
+  <inkml:trace contextRef="#ctx0" brushRef="#br0" timeOffset="44654">10475 4001 24575,'0'0'0</inkml:trace>
+  <inkml:trace contextRef="#ctx0" brushRef="#br0" timeOffset="46617">12300 1018 8191,'-9'2'0,"-4"14"1638,2 12 0,1 3-694,-2 5-944,5 8 0,5 3 0,9-15 0,7-2 0,5-1 0,4 1 0,3-1 0,1-2 0,3-2 0,2-2-162,6-3 0,2-4 1,3-2 161,4-2 0,2-3 0,0-4 0,-8-5 0,-1-4 0,1-1 524,5 1 0,0-2 1,-2-7-525,-1-9 0,-2-7 0,-4-1 0,-11 6 0,-3-1 0,-1-2 0,2-4 0,-1-3 0,-7-1 0,-10-3 0,-7 0 0,-2 2 0,-3 2 0,-3 1 1092,-3-1 0,-3-2 0,-3 6-1064,-5 5 0,-3 5-28,-5-1 0,-2 2 0,-3 2 0,-5 5 0,3 8 0,-8 5 0,1 1 0,6-2 0,2-4 0,0 1 0,-5 7 0,-1-1 0,1 0 0</inkml:trace>
+  <inkml:trace contextRef="#ctx0" brushRef="#br0" timeOffset="48067">8815 3611 24575,'29'-3'0,"0"0"0,12-3 0,4 0 0,-7 0 0,1 1 0,3-1-820,-3 1 1,1-1 0,3 0 0,3 0 272,-2 0 1,4 0 0,2 0 0,1-1 0,0 0 0,-2-1-1,0-1 1,-1 0 0,1-1 0,-1 0 0,1-1 0,1 1 523,-4 0 0,3 1 0,0-1 0,-1 0 0,0 0 0,-3-1 0,-3 1 23,1-2 0,-2-1 0,-2 1 0,-4-1 0,-2 2 0,18-8 0,-12 2 0,-21 6 0</inkml:trace>
+  <inkml:trace contextRef="#ctx0" brushRef="#br0" timeOffset="50218">11725 2661 24575,'2'-12'0,"3"-3"0,28-17 0,-9 11 0,3-4 0,0 1-1639,7-5 1,5-4 1304,-8 5 0,6-5 0,2-2 0,0-1 0,-5 2-486,-1-1 1,-3-1 0,-1 1 0,3-2 610,-1 2 0,3-1 1,1-1-1,-3 1 0,-3 3 1,1-6-1,-4 2 1,-4 5-1,-4 7 0,0 0 1</inkml:trace>
+  <inkml:trace contextRef="#ctx0" brushRef="#br0" timeOffset="50701">9174 1376 24575,'44'5'0,"1"1"0,0 0 0,0 0 0,-1-1 0,-4-1 0,2 0 0,2 0 0,1-1 0,0 1 0,1-1 0,-1 0 0,-1 1-469,4-1 1,0 1 0,0 0 0,0-1 0,1 0 0,0 1 0,2-1 103,-6-1 1,3 1 0,0-1 0,2 0 0,-1 0 0,-1 0 0,0 0 0,-3 0 0,-2 0-183,4 1 1,-4 0 0,-1 0 0,0 0 0,1 0 0,3 0 234,-4-1 1,2 0 0,2 0 0,0 0 0,1 0 0,1 0 0,-1-1 0,-1 1 0,-1 0 207,1 1 0,-2-1 0,0 0 1,0 1-1,0-1 0,0 1 1,1-1-1,1 0 104,0 0 0,3 1 0,0-1 0,2 0 0,-2 0 0,0 0 0,-1 0 0,-3 0 0,-4 0 0,10 1 0,-3-1 0,-3 1 0,-3-1 0,-2 0 0,5 0 0,-1 0 0,0-1 0</inkml:trace>
+  <inkml:trace contextRef="#ctx0" brushRef="#br0" timeOffset="52451">3593 3977 24575,'24'4'0,"15"15"0,-9-5 0,0 2 0,-5-2 0,0 1 0,5 5 0,-3-1 0,-7-6 0,2 4 0,1 2 0,0 6 0,5 4 0,1 0 0,1 3 0,-11-11 0,-1-2 0,-6-10 0,-6-1 0,0-5 0,-2 2 0,-2-5 0,0 2 0</inkml:trace>
+  <inkml:trace contextRef="#ctx0" brushRef="#br0" timeOffset="52801">4026 3988 24575,'-4'-9'0,"0"2"0</inkml:trace>
+  <inkml:trace contextRef="#ctx0" brushRef="#br0" timeOffset="52925">4011 3944 24575,'-3'4'0,"2"0"0</inkml:trace>
+  <inkml:trace contextRef="#ctx0" brushRef="#br0" timeOffset="53500">3943 3886 24575,'-9'13'0,"0"7"0,-3-1 0,-2 12 0,2-10 0,-3 3 0,0 8 0,0-8 0,0 1 0,-3 11 0,-3-2 0,0-1 0,5-6 0,-8 11 0,14-19 0,3-4 0,5-8 0,-1 0 0,3-5 0</inkml:trace>
+  <inkml:trace contextRef="#ctx0" brushRef="#br0" timeOffset="55666">17593 7987 24575,'45'8'0,"-14"-6"0,3 0 0,12 0 0,4 0-1093,-14-1 1,1-2 0,2 1-1,4 0 1,2 0 0,1 0 1066,-1 1 1,1 0 0,1 1 0,0-1 25,-2 1 0,0-1 0,0 1 0,0-1 0,0 1 0,0-1 0,-1 1 0,-4 0 0,1-1 0,-3 1 0,-4 0 858,-1-2 0,-6 0-858,-8 0 277,3 0 1,-20 0-1,0 0 1</inkml:trace>
+  <inkml:trace contextRef="#ctx0" brushRef="#br0" timeOffset="56422">18722 7827 24575,'29'8'0,"-1"1"0,-6-2 0,3 3 0,6 0 0,6 2 0,3 1 0,-3 0-1049,5 2 0,-1 1 0,1 0 1049,-4-3 0,1 0 0,0-1 0,-2 1 0,-1 2 0,-3 0 0,-2-2 0,-1-3 0,-5 0 991,-6 3-991,-15-7 517,4 9-517,-6-4 0,1 9 0,-3-8 1639,-1 0-1639,-14 12 0,-1-1 0,-5-1 0,-12 10 0,12-16 0,-2 1 0,-1 4 0,0 3 0,-9 11 0,3 0-547,1 0 547,11-7 0,2-3 0,8-14 0,-15 16 0,18-21 0,-6 6 0</inkml:trace>
+  <inkml:trace contextRef="#ctx0" brushRef="#br0" timeOffset="69934">5274 2969 24575,'0'0'0</inkml:trace>
+  <inkml:trace contextRef="#ctx0" brushRef="#br0" timeOffset="72601">20418 9840 16247,'14'46'0,"0"0"0,-1-1 0,1 1 0,0 0 0,0 0 0,4-5 0,3 1 0,1 0 0,2 0 0,0-3 0,1-2 0,0-4-820,9 5 1,1-5 0,1-3 0,3-2 540,-2-2 0,3-1 1,1-1-1,1-4 0,-1-4 279,2-4 0,1-5 0,0-4 0,-2-3 0,8-3 0,-1-6 0,-1-1 100,2 0 0,0-3 0,-6 0 0,-5-3 0,-5 0 0,-9 4 0,0 0 0</inkml:trace>
+  <inkml:trace contextRef="#ctx0" brushRef="#br0" timeOffset="75368">5710 3783 24575,'3'26'0,"-2"6"0,4-7 0,-1 8 0,1-16 0,6 23 0,-1-19 0,2 17 0,-3-23 0,-2-3 0,-2-9 0,9-7 0,19-16 0,-4 0 0,1-2 0,3-4 0,-1-2-1356,-1 1 0,-2 0 1356,1-7 0,-1-2 0,-10 8 0,-1-1 0,-1-1-275,3-8 0,0-1 0,0 0 275,-1 3 0,0 1 0,-2 0 0,0-10 0,-2 3 0,5-3 0,-10 16 0,-2 9 0,-2 8 0,2 2 0,-1 4 0,-3 2 0,-2 2 0</inkml:trace>
+  <inkml:trace contextRef="#ctx0" brushRef="#br0" timeOffset="78884">9115 2971 24575,'4'2'0,"0"2"0,2-2 0,-1 0 0,3 5 0,3 1 0,-4 3 0,16 9 0,-7-2 0,6 3 0,-8-6 0,-6-9 0,-2-3 0,9-5 0,10-15 0,-2-2 0,2-5 0,8-12 0,-1-2-1275,-6 5 0,0 0 1275,4-4 0,-3 2 0,-13 13 0,-2 1 0,4-2 0,-2 1 0,4-7 0,-6 7 0,-9 16 0,-3 4 0</inkml:trace>
+  <inkml:trace contextRef="#ctx0" brushRef="#br0" timeOffset="80101">9500 4147 24575,'11'16'0,"-3"-3"0,1-2 0,-1 1 0,-1-3 0,19 12 0,-17-15 0,19 5 0,-15-21 0,6-4 0,2-8 0,-1 2 0,2-2 0,2-1 0,1-2 0,9-7 0,0 0 0,-10 10 0,-2 2 0,11-9 0,-24 22 0,-6 5 0,-1 0 0</inkml:trace>
+  <inkml:trace contextRef="#ctx0" brushRef="#br0" timeOffset="81050">11142 4698 24575,'18'24'0,"0"1"0,4 3 0,3 2 0,0-3 0,-9-9 0,5 4 0,-17-16 0,-2-4 0,0 0 0</inkml:trace>
+  <inkml:trace contextRef="#ctx0" brushRef="#br0" timeOffset="81401">11299 4729 24575,'-15'27'0,"-1"-1"0,0 7 0,1-1 0,-8 12 0,5 2 0,13-31 0,0 1 0,1-6 0,2-2 0,0-7 0</inkml:trace>
+  <inkml:trace contextRef="#ctx0" brushRef="#br0" timeOffset="98516">18521 4436 24575,'10'2'0,"0"-1"0,-2 2 0,0-1 0,0 2 0,10-1 0,-5-2 0,20-1 0,16 0 0,-22-1 0,0-1 0,1 2 0,-2-1 0,4-2 0,-15 3 0,-9 2 0,6 4 0,4 3 0,13 5 0,-7-1 0,7 0 0,11 11 0,-18-10 0,18 7 0,-17-9 0,-6-4 0,0 0 0,-9-3 0,-4-5 0,-2 4 0,2 3 0,-2 4 0,0 1 0,-2 3 0,-4 4 0,-8 7 0,-2 3 0,1-7 0,0-1 0,-2 6 0,-2-1 0,-9 8 0,12-22 0,-13 15 0,-1-4 0,2-4 0,-2 7 0,12-15 0,-10 11 0,9-10 0,-7 5 0,1 0 0,2-5 0,0 2 0,10-9 0,7-3 0</inkml:trace>
+  <inkml:trace contextRef="#ctx0" brushRef="#br0" timeOffset="100434">16034 4871 24575,'7'-4'0,"28"2"0,-18 0 0,9 2 0,-1 0 0,-10 0 0,16-2 0,2 0 0,-8-1 0,2 0 0,-2-1 0,-15 0 0,-1 1 0,-6-1 0,-2 4 0,-1-2 0</inkml:trace>
+  <inkml:trace contextRef="#ctx0" brushRef="#br0" timeOffset="101483">16875 4764 24575,'0'8'0,"3"10"0,-2-8 0,2 14 0,-3-14 0,0-15 0,0-10 0,-3-17 0,2 5 0,1 0 0,0-21 0,5 13 0,1 1 0,1 7 0,0 3 0,6-8 0,5 3 0,-5 23 0,15-3 0,-1 18 0,2 4 0,11 8 0,-14-5 0,-4 0 0,-8 0 0,-12-10 0,-2-4 0</inkml:trace>
+  <inkml:trace contextRef="#ctx0" brushRef="#br0" timeOffset="106271">19355 3394 24575,'2'12'0,"6"30"0,3 6 0,-4-17 0,1 5 0,-1-3-1360,1-4 1,1 0 1359,2 17 0,1-3 0,0-10 864,2 14-864,-8-20 447,1-7-447,-2-4 0,-1-11 0,-2 2 0,0-6 0,-2 0 0</inkml:trace>
+  <inkml:trace contextRef="#ctx0" brushRef="#br0" timeOffset="110202">19037 5068 24575,'1'8'0,"14"1"0,4-6 0,11 0 0,5-3 0,-5 0 0,11 0 0,-15 0 0,2 0 0,18 0 0,4 0-1639,-3 2 1,2 1 1364,-6-1 0,2 0 0,0 0 274,-4 0 0,-1-1 0,1 2 0,6 0 0,1 1 0,1-1 0,-10-2 0,0-1 0,2-1 0,3 2 0,-2 0 0,3 1 0,2 0 0,1 0 0,0 0 0,1-1 0,-7 0 0,1-1 0,0 1 0,1-2 0,-1 1 0,2 0 0,0 1 0,1-1 0,0 1 0,2 0 0,0 0 0,-1 0 0,0 0 0,-1-1 0,-3 0 0,5-1 0,-1 0 0,-2 0 0,-1-1 0,-2 1 0,-3 0 0,4 1 0,-2 0 0,-3 0 0,-7-2 0,1-1 0,-12-1 0,-18 2 0,0 2 0,-2-2 0</inkml:trace>
+  <inkml:trace contextRef="#ctx0" brushRef="#br0" timeOffset="112601">21123 11102 24575,'8'0'0,"17"4"0,-1-3 0,4-1 0,14 2 0,3 0 0,-12-2 0,1 0 0,-1 0-842,10-2 1,-1 0 841,-8 1 0,-2 1 545,10-4-545,-10 4 0,3 0 0,6 0 0,3 0 0,-11 1 0,3 1 0,1 0-1093,11 0 1,3-1 0,-4 1 842,-10 0 1,-3 0 0,1 0 249,9 0 0,2 0 0,-4-1-122,-2-1 1,-2 0 121,10 1 0,-1 1 0,-10-1 0,-1-1 0,7 2 0,-3 0 0,6-2 330,-11 0 0,1 0-330,-7 0 0,1 0 0,17 0 0,4 0-1010,-7 1 1,3 1 0,-3-1 1009,0-1 0,-1 1 0,-7 0 0,1 0 0,-1 0 1638,7 0 0,-1-2-1625,-1 0 1,1-1-14,-5-1 0,1 1 0,-4-1 0,-4 0 0,-4 1 0,14-5 0,-36 7 0,-2 0 0</inkml:trace>
+  <inkml:trace contextRef="#ctx0" brushRef="#br0" timeOffset="117286">19965 10649 24575,'24'-3'0,"18"2"0,7 1 0,-10 0 0,3 0-722,0 0 1,4 0-1,-1 0 722,-1 0 0,-1 0 0,-3 0 0,-3 0 0,-2 0 0,7 0 0,-7 0 173,-19 0 1,-9 0 0,-5 0 0</inkml:trace>
+  <inkml:trace contextRef="#ctx0" brushRef="#br0" timeOffset="117735">20565 10515 24575,'18'7'0,"5"0"0,2 3 0,3 1 0,-1-3 0,1 1 0,7 4 0,-2 0 0,8 5 0,-24-5 0,-11 0 0,-6-1 0,-8 13 0,0-7 0,-10 8 0,9-15 0,0-1 0,5-7 0,2-2 0,0-1 0,0 0 0</inkml:trace>
+  <inkml:trace contextRef="#ctx0" brushRef="#br0" timeOffset="121050">22485 7976 9843,'13'48'0,"-1"1"0,1-1 0,0 0 0,0 0 0,0 0 0,0 0 0,-1 1 0,1-1 0,-3-2 0,0 2 0,0 0 0,0 0 0,-1 1 0,-1-1 0,-1 0 0,-2-1 0,-1-1 0,-2-1-52,-2 2 1,-1-2 0,-3 0 0,-1-2-1,-1 1 1,-1-1 0,0 1 0,-1 1 51,0-1 0,-1 0 0,-1 1 0,0 1 0,-1-1 0,-1 0 0,-1-1 0,0-1 0,-1-1-65,-3 7 1,-1-2-1,-2 0 1,0-2 0,-1 0-1,0-1 1,0-2 64,-1 2 0,0-2 0,-1-1 0,1-1 0,-1-1 0,-1-1 71,-2 2 0,-1-1 0,0-2 1,1-2-1,4-4 0,-7 12 1,2-5-1,-2-1 0,0 0 1</inkml:trace>
+  <inkml:trace contextRef="#ctx0" brushRef="#br0" timeOffset="122934">19917 15425 8191,'-12'0'0,"-3"2"3276,-3 2-1489,-5 2 1031,-11-2-2818,7-1 0,-1 0 0,-4-3 0,-1 0 0,0 1 0,0 1 0,1 1 0,4 1 0,3 0 1719,-6 19-1719,23-14 1638,-9 18 0,-1 5 1638,1 2-3160,-3 5 0,1 0-116,4-5 0,2 8 0,2 4 0,5-15 0,1 1 0,1 2 0,0 3 0,1 1-385,0 1 1,-1 2 0,2-1 384,2-1 0,1-1 0,1 0 0,-1-3 0,1-2 0,3 0 0,10 15 0,3-6 0,3-12 0,6-2 0,-1-3 0,-9-11 0,5 2 0,4 2 0,-1-2 0,0 0 0,18 6 0,-17-8 0,-2-2 0,-7-7 0,-3-5 0,12-10 0,8-8 576,-6 2 1,2-2-577,-2-3 0,0 0 0,-1 0 0,-2 1-413,9-9 413,-6-5 0,-17 6 0,7-14 0,3-7 0,-7 15 0,0-1 0,2-1-960,5-8 0,1-3 0,-1 3 960,-5 12 0,-1 1 0,0 1 0,9-12 0,-4 4 0,-8 5 0,-3 7 0,-2-2 0,-1-18 0,-2 2 0,-2 16 0,0 1 0,-6-8 0,-4 6 0,-2 0 0,-1 3 0,-5 3 0,-2 2 353,-4-1-353,0 1 0,-9-5 2940,20 17-2940,-17-9 0,11 6 0,-2 2 0,4 2 0,0 3 0,9 3 0,-5 0 0</inkml:trace>
+  <inkml:trace contextRef="#ctx0" brushRef="#br0" timeOffset="126818">17462 14517 24575,'19'2'0,"10"2"0,-1-1 0,12 4 0,-10-2 0,-4-2 0,1 2 0,19 9 0,-15-6 0,0 1 0,-5 2 0,-1 1 0,12 2 0,8 3 0,3 1-401,-15-7 0,2 0 401,7 1 0,5 1 0,-3 0 0,-10-3 0,-1 0 0,-2-1 0,9 0 0,-3-1 0,-9 1 0,-3-2 0,-4-4 0,-8 5 0,5-4 0,18 11 0,8-3 0,-17-5 0,-2 0 0,12 3 802,-3-7-802,-17 2 0,5-2 0,-1 6 0,8 8 0,-3-2 0,2 2 0,-5-4 0,-1 0 0,2 0 0,-3-1 0,-4-2 0,-12-10 0,-4 2 0,1-2 0</inkml:trace>
+  <inkml:trace contextRef="#ctx0" brushRef="#br0" timeOffset="127437">18996 14847 24575,'28'20'0,"-9"-6"0,0 1 0,1 2 0,0 4 0,1 2 0,-1-2 0,0 1 0,4 6 0,-1-2 0,-4-2 0,-4-5 0,-17-12 0,-12-4 0,-18 6 0,-6-3 0,1 5 0,-5 7 0,22-6 0,-7 4 0,16-10 0,-4-3 0,5-2 0,-8-1 0,9-1 0,-1 0 0,6-1 0,3 2 0</inkml:trace>
+  <inkml:trace contextRef="#ctx0" brushRef="#br0" timeOffset="129001">15677 13996 8610,'-4'4'0,"-2"-1"3276,2 0-2820,-2-2 0,4 0 0,0-1 0</inkml:trace>
+  <inkml:trace contextRef="#ctx0" brushRef="#br0" timeOffset="143168">14581 13719 24575,'6'-2'0,"-2"5"0,-2 2 0,-2 26 0,0 9 0,0-15 0,0 1 0,2 6 0,0 2 0,1-5 0,-1-1 0,6 17 0,-1 1 0,-3-34 0,-1 3 0,-3-13 0,0 0 0</inkml:trace>
+  <inkml:trace contextRef="#ctx0" brushRef="#br0" timeOffset="143537">14865 13421 24575,'12'29'0,"-1"0"0,2 11 0,0 3 0,-3 2 0,0 2-1093,-3-8 1,1 1 0,0-1 32,0 9 1,-2-3 1059,0-3 0,-2-4 0,0 10 1619,-4-18-1619,0-8 873,0-9-873,-4-8 0,3 1 0,-2-5 0</inkml:trace>
+  <inkml:trace contextRef="#ctx0" brushRef="#br0" timeOffset="143901">14332 13863 24575,'31'4'0,"0"1"0,1-3 0,4 0 0,0 1-1093,1 0 1,0 1 0,2-2 310,5-2 1,1-2-1,-3 0 782,3 0 0,-2-3 0,3-7 0,-2-3 839,-5 5 0,-2 0-839,-8-1 0,-4 0 0,-1-1 0,-19 8 0</inkml:trace>
+  <inkml:trace contextRef="#ctx0" brushRef="#br0" timeOffset="144235">14537 14111 24575,'4'-4'0,"2"0"0,1 0 0,4 2 0,13-3 0,7 0 0,2 0 0,5-1 0,1 0-1093,6-1 1,2-2 0,0 0 336,-9 2 0,1-1 0,-1-1 1,-3 1 755,2 0 0,-2 0 0,-5-1 564,0-1 0,-4-1-564,13-4 0,-29 8 0,3 1 0</inkml:trace>
+  <inkml:trace contextRef="#ctx0" brushRef="#br0" timeOffset="144919">15650 13277 8191,'6'-2'0,"5"2"3276,-1 6-1489,5 10 1031,1 10-2818,-6-5 0,4 11 0,1 5 0,-3-5 0,-1 1 859,2-2 1,1 2-860,1 15 0,-2-8 0,-7-24 1638,2 9 0,-1 1 1638,-1-6-3044,-2-3-232,-1 3 0,-3-16 0,0 3 0</inkml:trace>
+  <inkml:trace contextRef="#ctx0" brushRef="#br0" timeOffset="145236">15628 13567 24575,'22'10'0,"14"-2"0,6-4-1353,-4-1 1353,-9-2 0,-1-2 0,17-8 0,-3 5 0,-15-4 0,-4-1 441,-11 4-441,15-8 0,-22 10 0,2-1 0</inkml:trace>
+  <inkml:trace contextRef="#ctx0" brushRef="#br0" timeOffset="145518">16117 13493 24575,'15'36'0,"-4"-13"0,1 1 0,0 0 0,0-1 0,8 13 0,0-4 0,-18-27 0,0-2 0</inkml:trace>
+  <inkml:trace contextRef="#ctx0" brushRef="#br0" timeOffset="145976">16105 13305 24575,'0'0'0</inkml:trace>
+  <inkml:trace contextRef="#ctx0" brushRef="#br0" timeOffset="147125">16438 13474 24575,'12'18'0,"-5"-1"0,2-2 0,-5 6 0,4-4 0,-2 8 0,-3-12 0,-1-7 0,-2-17 0,0-5 0,0-3 0,0-2 0,-3-17 0,2-5 0,-1 8 0,0 2 0,4-1 0,3-5 0,2 26 0,3 3 0,-1 1 0,-3 7 0,0 0 0,0 4 0,6 8 0,7 12 0,3 15 0,-4 3 0,-7-10 0,-9-11 0,0-13 0,4-9 0,4-23 0,0 11 0,7-24 0,-1 9 0,4 5 0,4-2 0,-1 20 0,-8 4 0,2 3 0,-10 2 0,0 0 0,-5 4 0,5 7 0,0 6 0,0-2 0,-1-1 0,-6-9 0,0-2 0,0 1 0,0-4 0,0 0 0</inkml:trace>
+  <inkml:trace contextRef="#ctx0" brushRef="#br0" timeOffset="148168">16993 13238 24575,'20'0'0,"-5"-3"0,5-5 0,-5-1 0,-1-4 0,5-5 0,-6 1 0,4-7 0,-8 9 0,-4-9 0,-3 14 0,-5-12 0,-5 7 0,-2 4 0,-3 3 0,5 9 0,-1 7 0,2 2 0,-3 2 0,-6 15 0,5-2 0,-5 18 0,11-15 0,1 6 0,8-11 0,7 24 0,2-20 0,3 1 0,3 3 0,2-1 0,-6-9 0,2-2 0,20 9 0,-23-24 0,9 2 0,-8-9 0,2-3 0,-10 1 0,0 1 0</inkml:trace>
+  <inkml:trace contextRef="#ctx0" brushRef="#br0" timeOffset="148868">17562 12933 24575,'-14'2'0,"-17"13"0,13-4 0,-9 7 0,19-10 0,4-2 0,0 4 0,2 2 0,0 4 0,2-3 0,2-2 0,10 9 0,-4-9 0,17 11 0,1-8 0,-2-4 0,-2 3 0,-12 0 0,-7 6 0,1 2 0,-13 8 0,1-11 0,-4 2 0,5-8 0,4-4 0,2-2 0,1-2 0,0 4 0,0 5 0,0 6 0,0-3 0,0-4 0,0-9 0</inkml:trace>
+  <inkml:trace contextRef="#ctx0" brushRef="#br0" timeOffset="150301">14077 14770 24575,'8'28'0,"3"16"0,-4-18 0,-1 0-1145,6 18 1145,-4-18 0,1-1 374,0 4-374,2 7 190,-5-14-190,-3-13 0,-5-23 0,3-1 581,-8-20-581,3 7 0,-1-4 0,-2-1 0,3 5 0,1-1 0,0-4 0,0-2 0,0 3 0,1-17 0,4 14 0,2 5 0,3 11 0,4-4 0,-2 12 0,8 2 0,10-2 0,4 4 0,1 1 0,-10 6 0,-4 5 0,14 14 0,-3 12 0,-9-10 0,-2 3 0,-5 5 0,-4 1 0,2 12 0,-6-8 0,-1 3 0,-3-5 0,-1 1 0,3 1 0,-2-1 0,-2-7 0,-1-2 0,-1-3 0,-4-17 0,-3-1 0,-2-2 0,-3-1 0,3 0 0,2 2 0,4-1 0,4 0 0,0-1 0</inkml:trace>
+  <inkml:trace contextRef="#ctx0" brushRef="#br0" timeOffset="150701">14654 14580 24575,'9'30'0,"2"13"0,-2 0 0,0 4 0,-2-10 0,0 0 0,-2 4 0,0-1 0,2 7 0,-6-10 0,2-17 0,-3-13 0,0-5 0</inkml:trace>
+  <inkml:trace contextRef="#ctx0" brushRef="#br0" timeOffset="151018">14675 14563 24575,'11'-10'0,"1"-3"0,-4 2 0,2-5 0,-2 9 0,-4 0 0,-2 7 0</inkml:trace>
+  <inkml:trace contextRef="#ctx0" brushRef="#br0" timeOffset="151335">14608 14784 24575,'44'5'0,"2"-7"0,-21-2 0,15-9 0,-24 7 0,22-5 0,-27 8 0,5 0 0</inkml:trace>
+  <inkml:trace contextRef="#ctx0" brushRef="#br0" timeOffset="151970">15038 14532 24575,'-9'0'0,"-2"2"0,4 4 0,-1 2 0,4 3 0,1-3 0,2 1 0,-1-1 0,5 10 0,-3 0 0,5 7 0,1 0 0,0-1 0,8 21 0,-5-36 0,3 4 0,-4-5 0,1 0 0,-7 3 0,0-4 0,-2 4 0,0 16 0,-6-7 0,0 18 0,-3-17 0,0-2 0,4-5 0,-1-7 0,0 4 0,-7-4 0,5-3 0,-7 1 0,14-13 0,3 0 0,1-1 0,2 2 0</inkml:trace>
+  <inkml:trace contextRef="#ctx0" brushRef="#br0" timeOffset="152836">15712 14467 24575,'5'7'0,"7"17"0,2 5 0,5 4 0,3 8 0,2 3 0,-2-7 0,0-2 0,-2 0 0,0 0 0,-1-4 0,-2-2 0,0-3 0,-3-43 0,-4-9 0,1-5 0,0 0 0,-1-1-696,2-11 0,-1 0 696,-2 15 0,0 0 0,-2-12 0,0 0 0,1 9 0,0 1 0,-2-3 0,0 2 0,3-3 0,-7 19 0,0 9 0</inkml:trace>
+  <inkml:trace contextRef="#ctx0" brushRef="#br0" timeOffset="153753">17068 14148 24575,'-30'6'0,"8"1"0,9 1 0,4 4 0,4 3 0,-6 14 0,8 9 0,0 0 0,12 6 0,-2-23 0,10 13 0,-1-16 0,13 3 0,-4-11 0,-3-11 0,-11-3 0,-7 0 0,-2 2 0</inkml:trace>
+  <inkml:trace contextRef="#ctx0" brushRef="#br0" timeOffset="154421">17273 14142 24575,'-6'-2'0,"0"0"0,2 2 0,-1 4 0,-2 5 0,0 7 0,2 8 0,3-8 0,2 4 0,0-11 0,4 4 0,0-3 0,6 2 0,2-5 0,-3-1 0,2-4 0,-1-5 0,-3-2 0,7-12 0,-9 7 0,5-11 0,-4-3 0,-3 9 0,1-8 0,-4 8 0,0 7 0,0 0 0,1 11 0,0 5 0,9 16 0,-3-5 0,4 5 0,-6-13 0,-3-10 0</inkml:trace>
+  <inkml:trace contextRef="#ctx0" brushRef="#br0" timeOffset="154705">17389 13708 24575,'13'44'0,"0"-1"0,-4-18 0,1 0 0,7 22 0,-2-17 0,5 7 0,-3-11 0,0-6 0,-4-9 0,-5-10 0,-3-1 0,-2 0 0</inkml:trace>
+  <inkml:trace contextRef="#ctx0" brushRef="#br0" timeOffset="154971">17592 13568 24575,'9'17'0,"3"20"0,3-4 0,-2 4 0,0 3 0,0-7 0,0 1 0,3 12 0,-1-1 0,-3-13 0,-2-3 0,4 13-820,-7-33 1,-5-8 0,0-1 0</inkml:trace>
+  <inkml:trace contextRef="#ctx0" brushRef="#br0" timeOffset="155455">17792 13882 24575,'6'-5'0,"2"-4"0,4-14 0,-1 9 0,4-23 0,-8 26 0,7-26 0,-10 18 0,3-8 0,-7 14 0,-1 7 0,-7 2 0,1 3 0,-2-1 0,-1 5 0,2 5 0,-1 11 0,3 17 0,12 9 0,-2-7 0,7-4 0,-4-21 0,-4-3 0,6-4 0,-8-4 0,5-2 0</inkml:trace>
+  <inkml:trace contextRef="#ctx0" brushRef="#br0" timeOffset="155958">18003 13697 24575,'-9'0'0,"0"8"0,2-2 0,3 16 0,6-11 0,1 9 0,1-11 0,12 10 0,-6-9 0,9 2 0,-6-10 0,-1-16 0,-2 2 0,0-15 0,0-9 0,-1 3 0,-2-9 0,-2 22 0,-5-1 0,-2 12 0,-2 0 0,-4 3 0,-7 4 0,7 0 0,-3 2 0</inkml:trace>
+  <inkml:trace contextRef="#ctx0" brushRef="#br0" timeOffset="156338">18029 13411 24575,'15'39'0,"-2"-2"0,0-8 0,1 2 0,3 6 0,1 2-1093,-1-7 1,0 2 0,-1-1-547,4 6 1,-1-2 1494,0-1 1,-2-5 2122,-7-13-1979,-7-12 0,-2-3 0,-2-5 0</inkml:trace>
+  <inkml:trace contextRef="#ctx0" brushRef="#br0" timeOffset="157301">15327 14774 24575,'31'8'0,"-7"-5"0,2 0 0,8 3 0,1-2 0,-5-3 0,-1-1 0,21 1 0,-28-10 0,-8 3 0,-4-2 0,-6 6 0,-2 0 0</inkml:trace>
+  <inkml:trace contextRef="#ctx0" brushRef="#br0" timeOffset="166718">7025 12380 24575,'47'4'0,"-1"-1"0,-9 0 0,2-1 0,0 1 0,3 0 0,2 1 0,0 0-1093,-2 0 1,1-1 0,6 1 997,-10-1 1,5 0 0,3 0 0,2 1-1,0-1 1,-1 0 0,-2 0-453,0 1 1,-2-1 0,0 0 0,0 0 0,3 1 0,2-1 340,-7-1 1,2 1-1,3-1 1,1 1-1,0-1 1,1 0-1,-1 1 1,-2-1-1,-2 0 1,-3 1-211,7 0 0,-3 0 0,-2 0 1,-1 0-1,0-1 0,2 1 416,5-2 0,2 1 0,0-1 0,-1-1 0,-2 1 0,-6 0-317,6 1 0,-5 0 0,3-1 317,-3 0 0,3 0 0,1 0 0,0 0 0,-3 0 0,-2 1 0,-2-1 0,0 1 0,2-1 0,-3 0 0,2 0 0,1 0 0,-2 1 0,-2-1 0,8 2 0,-2 0 0,-2-1 0,-6-1 0,0-1 0,0 0 0,5 3 0,0 0 0,3 0 0,-2-3 0,3 1 0,2-2 0,0 2 0,-4-1 0,-1 1 0,2 1 0,1-1 0,1-1-96,0 1 0,1-1 1,2 0-1,-1-1 1,0 1-1,-3 0 96,-1 0 0,-2 0 0,0 0 0,-2 0 0,0 0 0,4 0 0,0 0 0,-3 0 0,-4 0 0,10 0 0,-8 0 0,9 0 1312,-19 0 1,3 0-1313,1 2 0,3-1 0,2 1 0,4-2 0,2 0 0,0 1 767,3 1 0,0 0 0,-1-1-767,-2-4 0,-1 0 0,-4-1 0,-1 2 0,-4-2 742,-2-3 0,-3-1-742,0 1 2739,-3 0-2739,-12 3 566,1-1-566,-9 1 3276,2-2-2978,-4-2-298,0-6 0,-2-6 0,-2-10 0,-2 9 0,-1-4 0,-1-2 0,-2 4 0,-2-2 0,-2-16 0,-1-2-952,0 10 1,0 1-1,-1-1 952,-3-13 0,0 0 0,1 12 0,-1 0 0,1 0-107,-4-9 0,2 1 107,2 9 0,0 0 0,1-5 0,1 5 0,1 4 0,-2-10 0,-1 8 0,6 13 0,-6-14 0,7 23 2820,1-4-2820,4 9 249,-2-1-249,2 0 0,-4 1 0,0-1 0,-19 0 0,-14 4-837,14 0 0,-2 0 837,-6 1 0,-2 0 0,-12 0 0,-5 0 0,13 0 0,-1 1 0,-1-2 0,4 0 0,0 0 0,-2 0 0,-1-1-820,-9 2 1,-2 0 0,-1 0 0,6-1 491,5 0 1,3-1-1,-2 0 328,-4 2 0,-3 0 0,-1 0 0,5 0 0,6 0 0,3 0 0,-2 0-370,-4 1 1,-2-1-1,-1 0 1,0-1 369,1 0 0,1-2 0,0 0 0,-2 0 0,4 0 0,-2 0 0,-1-1 0,1 1 0,2-1 0,-2 0 0,1-1 0,1 1 0,1 0-559,-5-2 1,2 0 0,1 2 558,4 2 0,1 1 0,6 0 0,-7 1 137,6 0 0,-6 0 0,1 0-137,-15 0 0,0 0 0,5 0 0,-2 0 0,9-1 0,-5 0 0,2 0 0,6-1 742,6 0 0,1-1-742,-12 0 0,-6 0 0,6-1 0,9-1 0,1 1 565,-18 0 1,-3 2-566,8-1 0,-1 2 0,6 0 0,-2 2 0,3-1 0,2 0 0,0 0 0,-3-2 0,-4-1 0,3-1 0,-6-1 0,0 0-54,6 0 0,-2-1 1,3 1 53,-6 0 0,3 1 0,-2-2 0,3 2 139,13 4 0,1-1-139,0-1 0,0 0 1079,-13 1 1,1 2-1080,-5 2 0,6-2 0,-7-1 0,2 0-1563,-4-2 0,-1-1 1563,0 0 0,-4-1 0,4-1 0,11-1 0,3 0 0,0 0 1085,-18-1 0,4 2-1085,20 0 0,3 2 487,-17 3-487,24 0 0,-2 0 0,-27 0 0,20 0 0,-1 0 0,-3 0 0,0 0 1638,2 0 0,3 0-660,6 0-978,-2 0 0,14 0 0,-10 0 0,-7-3 0,-23 2 0,11-2 0,1 3 0,22 2 0,0 4 0,-11 2 0,-1 0 0,-4 3 0,-3-2 0,1-2 0,16 0 0,-6 0 0,17 0 0,2-1 0,2 15 0,-3 0 0,-2 17 0,-3 0 0,-1 2 0,3-5 0,0 1-706,2-1 1,-1 2-1,0-3 706,1-4 0,0-1 0,2 5 0,1 3 0,-1-2-313,-2 1 1,1 1 312,-1 6 0,1 4 0,0-4 0,-1-7 0,0-2 0,2 9 0,-1-3 0,0-9 0,3 4 0,0-19 0,2-8 0,0-8 2045,2 0-2045,0-2 697,2 2-697,0 0 0,18 5 0,6 2 0,-2-1 0,3 1-547,13 2 1,8 1 546,-11-5 0,6-1 0,3 1 0,-3-2 0,-5 0-1093,-3 0 1,-5-1 0,4 1 922,2-1 0,6 0 0,1 1 0,-5-2 0,-9 1 170,9-2 0,-16 0 0,-21 0 0</inkml:trace>
+  <inkml:trace contextRef="#ctx0" brushRef="#br0" timeOffset="171250">20532 10422 24575,'-1'34'0,"0"-1"0,1 1 0,0 4 0,0-1 0,-2 10 0,0-1 0,1-16 0,2-2 0,0-1 0,0 0 0,-1 9 0,2-16 0,-2-10 0,2-4 0,0 10 0,6 10 0,-2-2 0,5 3 0,-4-19 0,10-2 0,-1-7 0,8-1 0,9-1 0,1 1 0,15 2-972,-14 5 1,3 0 971,-4-1 0,5-1 0,1 0 0,9 1 0,4-1 0,1 0 0,-5 0 0,0-1 0,-2-1 0,0 0 0,3 1-547,-7-1 1,2 1 0,2 0 0,0-1 0,-2 1 0,-3-1-105,4 1 1,-3-1 0,-1 1 0,-2 0 650,1 1 0,-2 0 0,2 2-394,1-1 0,2 2 0,2-1 1,-1 1 393,-1-2 0,-1 1 0,2-1 0,3 1 0,-5-1 0,3-1 0,2 1 0,0 0 0,0 0 0,-3-1-656,2 1 1,-1-1-1,0 1 1,-1-1 0,0-1 576,1 0 0,2-1 0,-1 0 0,-2 0 0,-1 0 79,-1 1 0,-1-1 0,-2 1 0,-3-1 267,12-1 1,-1 0-268,-12-1 0,1 1 0,-2 1 0,12 1 0,0 0 395,-9 0 1,2 0 0,1 0-396,4 2 0,1-1 0,-3 1 0,5 2 0,-2-1-156,-12-3 0,1 0 1,1 0 155,0 0 0,1-1 0,2 0 819,-3-1 0,3-1 0,-1 0 0,0-2-807,10-2 0,-1-1 0,-2 0-12,-4 3 0,-3 0 0,-5-2 365,11-13-365,-38 15 3276,-4 2-3170,7 1 3098,26 4-3204,-10-3 0,2-1 0,6 0 0,-1 0 0,-3-2 0,-1-1 0,12-5 1140,1 0-1140,-4 0 0,-2 2 0,3 0 0,-8 1 0,0 0 0,7-1 0,1-1 0,0 1 0,-2-1 0,11-5 0,-5 3 0,-27 1 0,-9 6 0,2-6 0,5-4 410,-2-3-410,-1-15 0,-15-6 0,-3 10 0,-4-2 0,-2-6 0,-3-1 0,-1-1 0,-1-2 0,0-4 0,1 0 0,5 9 0,0 0 0,-1 0 0,1-1 0,2 2 0,1 1 0,2 4 0,0 1 0,2 2 0,0-1 0,2-13 0,0 0 0,0-1 0,0 5 0,0 1 0,0 9 0,-2 11 0,2 8 0,-7 2 0,-2 8 0,-14 6 0,9-4 0,-20-1 0,-17 0 0,0-2 0,16-4 0,1-1 0,-2 0 0,-2 0-656,-3 1 1,-3 1-1,0-1 1,-1 1 0,3-1-165,-4-1 1,1-1 0,1 0 0,0 0 761,0 1 1,0-1-1,0 1 1,-3 0-490,9 1 1,-2 0 0,-2 0 0,0 0 0,1 0 0,2 0 294,-4 0 0,3 0 0,0 0 0,-1 0 0,-3 0 32,5 1 1,-1-1-1,-2 1 1,-1 0-1,1 0 1,1 0-1,2 0 220,-8-1 0,3 0 0,0 0 0,2 0 0,0 1-457,5 0 0,1 0 1,0 0-1,0 0 0,-1 0 457,-4 0 0,-1-1 0,0 0 0,0-1 0,3 1 0,-2 0 0,1 0 0,2 0 0,2 0 707,-1 0 0,3 0 0,-3 0-707,0 0 0,-3 0 0,0 0 0,4 0 0,4 1 0,3 1 0,-2 0 0,-4 0 0,-2-1 0,1 1 893,1 0 1,1 0 0,4 0-894,7 0 0,2 0 0,-16-1 0,-1-2 0,6-1 0,1-1 0,2 3 0,-2-1 0,3-2 0,-3-1 0,2 2 0,-7 1 0,0 0 0,4 0 0,-2-1 0,1 0 0,-14 2 0,3 0 0,13 0 0,1 0 0,0 5 0,4-1 0,-3-2 1010,-1 6 0,-3 2-1010,4-1 0,1-1 0,-15 5 0,4 2 0</inkml:trace>
+  <inkml:trace contextRef="#ctx0" brushRef="#br0" timeOffset="174219">17726 11515 24575,'19'-20'0,"-1"1"0,9-10 0,-14 19 0,-6 6 0,6-3 0,12-4 0,-4-1 0,2-1-717,12-3 0,0 0 717,-8 1 0,2 0-586,1 0 0,4-1 0,-3 2 586,-7 2 0,1-1 0,6-1 0,7-4 0,3 0 0,-1 0 0,-6 2-1639,9-4 1,1 0 1560,-7 5 0,7-3 1,2 0-1,-1 0 1,-3 2 77,-3 1 0,-3 2 0,0 0 0,0 1 0,0-1 0,0 1 0,0 0 0,1 0 0,4-3 0,2 0 0,-2 0 0,-3 2-164,-3 0 1,-3 2-1,1-1 164,-1 1 0,0 0 0,1 1 0,3 1 0,0 0 0,-2 1 0,5 1 0,-2 1-429,6 1 1,1 0 428,0-2 0,-2 0 0,-12 4 0,1 0 624,9-5 0,-1 1-624,-8 3 0,-3 1 3276,17-4-3095,-17 4 1,-2 0-182,6 0 0,-7-1 0,0 0 641,19-1-641,-10 1 0,0-1 669,10-7 0,-4 6 0,-29 0 1</inkml:trace>
+  <inkml:trace contextRef="#ctx0" brushRef="#br0" timeOffset="175035">19994 10456 24575,'24'9'0,"0"0"0,9 4 0,3 1 0,0-2 0,2 1 0,1 1 0,0 1 0,0 1 0,1-1 0,0-1 0,1-1 0,-5 0 0,1 3 0,-3-1 0,-4-4 0,-6-1 0,-15-2 0,-7 0 0,-2 8 0,0 5 0,-2-1 0,-5 8 0,-2 1 0,-3-2 0,2-3 0,-1 2 0,-16 6 0,17-23 0,-13 13 0,17-19 0,-4 5 0,3-4 0,-2 2 0,1 1 0,1 2 0,1-1 0,3 0 0,0-4 0,1-2 0,0 0 0</inkml:trace>
+  <inkml:trace contextRef="#ctx0" brushRef="#br0" timeOffset="175617">16791 11170 24575,'8'5'0,"0"3"0,6 14 0,3 8 0,0 12 0,-2-7 0,0 4 0,0 6 0,0 2-574,-3-10 1,1 1 0,0-1 573,0 0 0,-1-2 0,0-2 160,-1 0 0,-2-4-160,6 11 0,-15-34 0,0-2 0,-2-2 0,2 0 0,-2-2 0</inkml:trace>
+  <inkml:trace contextRef="#ctx0" brushRef="#br0" timeOffset="175950">16620 11597 8191,'33'-8'0,"0"0"0,-1 1 0,6-1 0,0 2 0,1-1 835,-2 0 0,-1 1 0,1-1-835,1 0 0,0 1 0,-4 0 1513,-5 1 1,-2 0-1514,-1-3 0,-1 1 1999,8 0-1999,-12 0 819,-13 5 0,-2 0 0,-4 2 0</inkml:trace>
+  <inkml:trace contextRef="#ctx0" brushRef="#br0" timeOffset="177987">16366 11774 24575,'-6'4'0,"-1"0"0,-9 5 0,-16 4 0,2 2 0,1 1 0,-9 5 0,15-2 0,6 0 0,15-7 0,0 9 0,1-12 0,-6 15 0,3 4 0,-6 0 0,6-3 0,-6-3 0,4-2 0,-10 14 0,-1 9 0,2-7 0,3-5 0,3-13 0,5-16 0,0 4 0,2 1 0,2 22 0,17-7 0,-17-30 0,11-20 0,-34-15 0,-4 12 0,-9 26 0,4-5 0,11 2 0,4-3 0,-7 5 0,-11 4 0,-14 7 0,0 4 0,13-1 0,5 0 0,3-7 0,-14 6 0,-2-2 0,9 1 0,-2 0 0,-2 0 0,-1-2-639,3 1 1,0-1 638,0-1 0,2-2 0,-7-1-653,0 0 653,0 0 0,12 0 0,-1 0 0,6 0 0,0 0 0,-10 0 0,2 0 0,1-2 0,-13 2 0,11-2 0,-10 2 0,16 1 0,-2 0 0,-7-1 0,-1 0 0,0-2 0,-1-1-267,1 0 0,-2-1 1,4 0 266,7 0 0,0-1 0,-13-2 0,3 1 625,7 5-625,7-1 0,-1 0 0,-15 2 0,5 0 0,4 0 0,0 0 0,8 0 2105,-25 0-2105,4 0 0,-3 0 0,-1 0 0,22 0 0,0 0 0,-17 0 0,3 0 0,20 0 0,-8 0 0,15 0 0,-13-2 0,-13 1 0,7-1 0,0 0 0,7 1 0,2 1 0,-5-3 0,3 1 0,8 1 0,-1-2 0,8 3 0,2 0 0,-2 0 0,-13 0 0,-6 0 0,-2 0 0,-1 0 0,-3-1 0,0 2 0,6-1 0,5 1 0,10 0 0,4 1 0,-13 1 0,-5 0 0,-3-1 0,-5 3 0,0 0 0,1-3 0,2 1 0,-14 1 0,30-5 0,-2-3 0,-8-4 0,4 4 0,0-3 0,15 6 0,1 0 0,4 1 0</inkml:trace>
+  <inkml:trace contextRef="#ctx0" brushRef="#br0" timeOffset="178784">13075 11924 24575,'-13'6'0,"3"-3"0,1 4 0,-7 0 0,1 0 0,-30 5 0,16-5 0,0 0 0,-19 3 0,9 0 0,2 1 0,9-3 0,-19 9 0,27-9 0,3-2 0,-6 9 0,4-5 0,-1 4 0,-3 2 0,-1-2 0,1-1 0,-13 12 0,7-8 0,3-1 0,10-4 0,-14 10 0,21-15 0,1 1 0,5-4 0,3 0 0,25 7 0,-2-1 0,23 7 0,-13-4 0,-9-2 0,10 7 0,7 3 0,-2-5 0,2 0-1093,3 0 1,5 0 0,-3-2 912,-11-4 1,-1-2 0,-2-2 179,8 0 0,-6-2 0,-6 0 0,-17 2 0,-8 1 0,-1-2 0,-3-3 0,-1-2 0</inkml:trace>
+  <inkml:trace contextRef="#ctx0" brushRef="#br0" timeOffset="179620">15994 10408 24575,'15'24'0,"1"0"0,4 13 0,2 5 0,1-3 0,2 4 0,-1-3-1093,-5-6 1,0-1 0,0-1 381,1 0 0,-1 0 0,-1-6 711,11 8 1622,1-3-1622,-9-12 876,4-2-876,-10-11 0,-3-4 0,1-5 2912,-6-1-2912,11-18 0,2-10 0,-6 2 0,-1-5 0,2-1-820,3-1 1,2-3 0,0 0 0,-2 0 184,-2 2 1,-3 1 0,1 0 0,0 0 634,1 1 0,2 1 0,-2 0 0,-2 3-836,2-14 0,-2 2 836,3-1 0,-1 2 0,-5 10 0,-1 2-109,-1-3 1,0 4 108,1 2 0,-3 5 0,-6 19 0</inkml:trace>
+  <inkml:trace contextRef="#ctx0" brushRef="#br0" timeOffset="188501">26126 9934 24575,'-12'9'0,"4"-2"0,-10 5 0,9-6 0,-9 7 0,-5 5 0,2 0 0,-2 2 0,-2 1 0,0 0-888,-6 6 0,-1 0 888,5-2 0,0-1 0,1-4 0,2-2 0,-16 13 0,17-14 0,2-3 0,3-5 0,-4 9 0,22-20 0</inkml:trace>
+  <inkml:trace contextRef="#ctx0" brushRef="#br0" timeOffset="189037">25560 10157 8191,'-15'22'0,"0"0"0,-11 14 3276,3 1-2383,7-16 1,0 0 1924,-2 6-2818,-6 9 1719,12-14-1719,2 0 3276,4-6 0,-1 12-3044,3-2-232,4-6 0,-2-1 0,4-13 0,-2-2 0,4 0 0,0-2 0,6 2 0,13-3 0,8-1 0,11 2 0,3-2 0,-10-2 0,3-1 0,-2 0-599,11 1 0,-4-1 599,6-7 0,-34 4 0,-13 4 0,0 0 0</inkml:trace>
+  <inkml:trace contextRef="#ctx0" brushRef="#br0" timeOffset="206589">5462 11847 24575,'7'-12'0,"0"5"0,19-12 0,-2 11 0,4 0 0,5-3 0,2 0 0,7 2 0,0 1 0,-15 3 0,-2 1 0,21 1 0,-29 3 0,4 2 0,-9 0 0,5 7 0,0 6 0,0 7 0,0 2 0,4 4-376,0 2 0,-2-1 376,-5-10 0,3 5 0,-1 0 0,-6 0 0,7 14 0,-16-18 0,-1-1 0,0-4 752,-1-3-752,0 0 0,-5 2 0,2-2 0,-8 7 0,-2-7 0,-8-1 0,-5 3 0,6-7 0,3 3 0,9-11 0,4 0 0,-15-13 0,9 4 0,-12-5 0,14 3 0,3 4 0,2-6 0,4 5 0,-4-4 0,3 0 0,3-2 0,8 3 0,15 1 0,-5 8 0,9-2 0,-19 4 0,1-3 0,-5 3 0,1-2 0,2 6 0,11 16 0,4 5 0,6 10-384,-12-12 0,-1-1 384,1 2 0,10 15 0,-19-26 0,5 2 0,-11-9 0,0-2 0</inkml:trace>
+  <inkml:trace contextRef="#ctx0" brushRef="#br0" timeOffset="208489">24064 10039 8191,'-21'10'0,"0"9"1638,-2-6 0,-3 2-745,-2 8 1,-1 5-894,2-1 0,0 3 0,1 2 265,2 1 0,1 2 1,2 0-266,2-6 0,0 1 0,3 1 0,3 4 0,3 2 0,2-2 0,4 2 0,3-1 0,-3 12 0,3 1 0,3-15 0,2-1 0,0 0 0,2 11 0,5 2 0,1-13 0,3 3 0,2 1 0,-1-3 0,1 3 0,0-2 0,6 1 0,2-2 0,4 3 0,4 0 0,1-2 0,-2-4-235,0-4 0,0-4 0,1-1 0,2 0 235,5 5 0,2-1 0,1-1 0,1-4 0,-3-6 0,1-2 0,1-4 0,2-1 0,-3-3 0,1-1 0,2-2 0,0-3 0,0-1 367,3-4 0,1-2 0,-1-2 0,1-1 0,-1-2-367,-6 2 0,1 0 0,-1-2 0,-1-1 0,-2-3 0,-3-3-656,2-10 1,-3-6-1,-3-2 1,-3-1 0,-4 1 575,-4 3 1,-3 0 0,-4-1 0,-5-2 79,-4-8 0,-5-3 0,-4 0 0,-4 4 27,-5 1 0,-4 3 1,-5-1-28,1 6 0,-4-2 0,-1 0 0,-2 1 0,1 3 0,-2 0 0,-2 2 0,0 2 0,0-1 0,-5-4 0,-2-1 0,1 3 0,2 4 0,3 8 0,2 3 0,0 3 0,-4 0 0,2 3 0,7 4 0,1 2 1124,-12-4 1,-2 1-1125,-6 0 0,-3 0 0,13 4 0,-2 0 0,0 1 235,-4 0 0,-2 1 1,2 1-236,-7-1 0,1 1 0,5 2 0,1 0 1638,9 2 0,3 1-270,-1-1 662,2 3-2030,25-2 208,2-2-208,4 1 2700,1-2-2700,-1 0 605,0 0-605,0 0 0,-2 0 0,0 0 0</inkml:trace>
+  <inkml:trace contextRef="#ctx0" brushRef="#br0" timeOffset="220835">5381 11520 24575,'14'11'0,"-1"1"0,-3 4 0,12 13 0,3 3 0,-2-1 0,3 3 0,-1 0 0,0 1-913,-6-8 1,1 1 0,-2 0 912,5 6 0,-1-2 0,-6-8 0,-2-3 648,1 3-648,2-2 0,-6-8 0,10 14 0,-3-8 0,2 7 2089,2-2-2089,-6-1 0,-7-11 0,-1-3 0,-3 0 0,2-2 0,6 14 0,-7-9 0,4 4 0,5 16 0,-3-11 0,-2 1 0,1 1 0,1 3 0,-3-4 0,-5-14 0,-2-9 0,1-9 0,5-7 0,6-20 0,5-2 0,1-4-1331,-4 3 1,0 0 1330,4-5 0,1-1 0,-5 2 0,-2 3-1822,0-2 1822,1-1 0,-1-3-95,-4 7 0,0 0 95,4-7 0,0-2 0,-3-1 0,0 2 0,-1 10 0,-1 3 0,-4 8 0,1 2 0,2-9 0,-2 18 2360,-4 2-2360,2 7 2069,-4-5-2069,2 4 244,-2 2-244,2-3 0,-2 4 0,2-2 0,-2 3 0,0 0 0</inkml:trace>
+  <inkml:trace contextRef="#ctx0" brushRef="#br0" timeOffset="222750">7827 11339 24575,'-6'0'0,"-2"0"0,2 2 0,-5-2 0,-19 2 0,-7-5 0,-6-3 0,6 0 0,-4-1 0,-1 0-820,-1-1 1,-3 0 0,0 0 0,3-1 115,-3 0 0,3 0 1,0 0 703,0 0 0,1 0 0,4 3 0,2 2 0,4 2 0,6 0 0,1 0 0,-24 7 0,12 3 0,13 0 0,-1 0 0,-9 5 0,-7 0 0,23-8 3276,5 0-1164,4-1-2112,1 0 0,4 0 0,1 0 0,2 0 0,-2 0 0,-5 7 0,0 0 0,-3 6 0,5-5 0,1 3 0,-1 3 0,3 11 0,-3 1 0,2-2 0,0 3 0,-6 3 0,-2 3-1093,0-1 1,-1 2 0,0-1 989,-2 7 1,-1 1 102,3-9 0,0 2 0,2-3-51,0 1 1,2 0 50,2 12 0,2-1 0,0-17 0,1-3 0,6 2 0,1-5 0,2-8 0,2-6 3276,4-4-3091,34 0-185,-9-4 0,6 0 0,1 1-585,-5 0 0,0 1 1,3-1 584,-3-2 0,3 0 0,2 0 0,-2 0 0,-4 0 0,1 2 0,-3 0 0,-1 0-94,6-1 1,1 0 0,-5 0 93,-7 2 0,-1 0 0,2 0 0,4 1 0,1-1 0,8 1 0,2-1 0,3 1-611,-2-1 1,3 1 0,2 0 0,-1 0 610,-10 0 0,0 0 0,0 0 0,0 1 0,0-1 0,1 0 0,0 1 0,0-1 0,-1 0 0,-2 1-933,9 3 1,-2 0 0,0 0 932,1 1 0,1 1 0,-2-1 0,-9-4 0,-2-1 0,3 2 0,2 0 0,3 1 0,1 0 0,-2-1-42,-2-3 0,-1-1 0,0-1 0,2 1 42,8 2 0,1 0 0,0 1 0,0-2 0,-3-2 0,0-1 0,-1-1 0,-1 1-470,4 1 0,-2-1 0,4 0 470,-8-1 0,2 0 0,2 0 0,1 0 0,0 0-350,-5 0 1,1 1 0,1 0 0,0 0 0,2 0 0,0 0 349,1-1 0,1 0 0,1 0 0,1 0 0,1 0 0,0 1 0,0-1 0,-7 1 0,2 0 0,0 0 0,1 1 0,-1-1 0,0 1 0,0-1 0,-2 0 0,-2 0 0,9-1 0,-2 0 0,-1 0 0,-2 0 0,1 0 0,-2 1 0,8 1 0,0 0 0,-1 0 0,-4 0 0,-9 0 1005,3-2 1,-7 1-1006,-5 1 0,-8 0 1316,-16-2-1316,-2-2 1779,9-18-1779,-2 0 0,4-8 0,1-4 0,3-9 1638,-5 12 0,0-2-296,-5-3 1,-1 1-1343,-3 3 0,-1-1 0,-1-17 0,-2 2 0,-4 0 0,-2 4 0,-2 2 0,-2 8 0,2 3 0,0-1 0,-2-6 0,1 14 0,-2-1 0,-3 9 0,-21-15 0,-4 2 0,-3 4 0,2-3 0,18 14 0,1-2 0,-13-3 0,17 10 0,-12-2 0,-10-1 0,-1 2 0,-2 1 0,-2 3 0,-3-1-582,9 1 1,-1 1 0,-2-1 0,-2 1 0,-3 1 581,6 1 0,-3 0 0,-3 1 0,0 0 0,-1 1 0,0-1 0,1 1 0,3-1-547,-5 1 1,1-1 0,1 0 0,0 0 0,0 1 0,-1 0 121,-2 0 1,-2 2 0,0-1 0,1 0 0,1 0 0,3-2 424,-5-1 0,1-2 0,4 0 0,5 0-1013,-5 0 1,3-1 1012,11 0 0,-2-2 0,-3 1 0,-4-2 0,-5 0 0,0 0 0,3 1 0,-1 1 0,2 1 0,-4-1-543,5 0 0,-3-1 0,-2 0 1,1 0-1,2 2 543,1 0 0,2 1 0,-1 1 0,-3-1 0,0 0 0,-3 0 0,-3 0 0,0 0 0,1 0 0,3 1 0,-1 0 0,3 0 0,0 1 0,-1 0 0,-2-1 0,5 0 0,-3-1 0,-1 1 0,-1-1 0,2 0 0,2 1 0,5 1 0,-17 0 0,7 1 0,-2 0 0,4-1 0,0-1 0,-2 1 0,0-1 0,0 1 0,-2 0 0,1-1 0,2 1 0,4 0 0,1-1 0,0 1 0,-1-1 0,-6 0 0,-1-1 0,2 0 0,3 0 347,6-1 0,3 1 0,1-1-347,-13-1 0,2 0 0,2 0 0,2 1 0,7 2 0,3 0 0,-7-2 0,14 4 0,17 0 0</inkml:trace>
+  <inkml:trace contextRef="#ctx0" brushRef="#br0" timeOffset="244052">1836 12865 24575,'0'0'0</inkml:trace>
+  <inkml:trace contextRef="#ctx0" brushRef="#br0" timeOffset="257052">27395 443 24575,'7'19'0,"-2"-7"0,-2 9 0,-1-9 0,1 11 0,2-6 0,-3 14 0,2-17 0,-3 9 0,0-14 0,2 6 0,0 3 0,3 0 0,-2 6 0,0-8 0,-2-4 0,0-5 0,4-5 0,-2-2 0,4-2 0,10-3 0,4 0 0,6-1 0,15-1 0,4 0-981,-13 1 1,1 0-1,0 0 981,11-1 0,-2 0 0,-11 1 0,-7 0 0,-8 2 0,-3 1 0,-13 1 0,2 2 0,0-4 0,-1 4 0,0-2 0</inkml:trace>
+  <inkml:trace contextRef="#ctx0" brushRef="#br0" timeOffset="286701">19001 9049 24575,'28'1'0,"0"0"0,8 1 0,5-2 0,2 0-972,-17 0 1,-1 0 971,6-2 0,0 0 0,-4 0 0,1-1 0,0-4 0,-1 0 0,-3 3 0,1-2 168,11-5 0,1-2-168,-4 2 0,1-1 0,6-2 0,-2-1 0,-13 4 0,-3 2 389,6-4-389,-20 9 0,5 4 0,6 4 0,-5-2 0,-1 1 0</inkml:trace>
+  <inkml:trace contextRef="#ctx0" brushRef="#br0" timeOffset="287489">19816 8775 24575,'14'10'0,"0"-1"0,3-4 0,3 0 0,0-1 0,0 0 0,-8-2 0,5 10 0,-4-4 0,7 14 0,2 2 0,6 7 0,-7-7 0,-1-2 0,0-3 0,-14-11 0,-5-4 0,-4 2 0,-5 11 0,2-7 0,-9 23 0,6-15 0,-4 7 0,-3-4 0,3-10 0,-8 10 0,10-12 0,-3 12 0,9-10 0,-4 20 0,4-18 0,1 8 0,2-19 0,2 0 0</inkml:trace>
+  <inkml:trace contextRef="#ctx0" brushRef="#br0" timeOffset="288734">5141 11063 24575,'45'0'0,"-7"2"0,2 0 0,1 1 0,4 1-820,-6-1 1,6 2 0,1-1 0,-4 0-274,-1-2 1,-3 1 0,2-1 482,8 2 0,2-1 0,-7 0 1664,-13-3 1,-5 0-1055,8 0 0,-13 0 0,-17 0 0</inkml:trace>
+  <inkml:trace contextRef="#ctx0" brushRef="#br0" timeOffset="289268">5938 10935 24575,'23'14'0,"0"-1"0,3-2 0,5 0 0,-2 1 0,1 0 0,4 0 0,-2-1 0,-6 0 0,-4 0 0,-1 1 0,-16-3 0,-5-2 0,-5 4 0,-9 8 0,0-2 0,-4 5 0,2-4 0,8-5 0,-6 1 0,8-6 0,-3 3 0,2-4 0,-7 10 0,-4 0 0,0-2 0,4 0 0,8-13 0,6 0 0</inkml:trace>
+  <inkml:trace contextRef="#ctx0" brushRef="#br0" timeOffset="292903">18264 7468 24575,'22'0'0,"5"-1"0,5-2 0,4-1 0,2-1 0,11 2 0,0 0-1639,-4-4 1,-1 1 867,2 5 0,1 1 771,-10-1 0,1-1 0,3 1-60,-2 0 0,3 2 1,0-1-1,-2 0 60,5-1 0,-2 0 0,-2 0 0,-2 0 0,-1 1 0,-6 0 0,0-3 0,-28 3 0</inkml:trace>
+  <inkml:trace contextRef="#ctx0" brushRef="#br0" timeOffset="293301">19179 7215 24575,'48'-2'0,"-11"7"0,6 13 0,-19-2 0,-6 4 0,-8-7 0,-3 3 0,-9 3 0,-7 7 0,-9 3 0,0-2 0,-2 8 0,9-16 0,1 8 0,0-2 0,4-9 0,1 2 0,3-13 0</inkml:trace>
+</inkml:ink>
+</file>
+
 <file path=ppt/notesMasters/notesMaster1.xml><?xml version="1.0" encoding="utf-8"?>
 <p:notesMaster xmlns:a="http://schemas.openxmlformats.org/drawingml/2006/main" xmlns:r="http://schemas.openxmlformats.org/officeDocument/2006/relationships" xmlns:p="http://schemas.openxmlformats.org/presentationml/2006/main">
   <p:cSld>
@@ -237,7 +414,7 @@
           <a:p>
             <a:fld id="{C5B45307-6ED4-B142-BD64-10F739779302}" type="datetimeFigureOut">
               <a:rPr lang="en-US" smtClean="0"/>
-              <a:t>9/11/25</a:t>
+              <a:t>1/28/26</a:t>
             </a:fld>
             <a:endParaRPr lang="en-US"/>
           </a:p>
@@ -561,7 +738,7 @@
           <a:noFill/>
           <a:extLst>
             <a:ext uri="{909E8E84-426E-40dd-AFC4-6F175D3DCCD1}">
-              <a14:hiddenFill xmlns="" xmlns:a14="http://schemas.microsoft.com/office/drawing/2010/main">
+              <a14:hiddenFill xmlns:a14="http://schemas.microsoft.com/office/drawing/2010/main" xmlns="">
                 <a:solidFill>
                   <a:srgbClr val="FFFFFF"/>
                 </a:solidFill>
@@ -620,7 +797,7 @@
             </a:ln>
             <a:extLst>
               <a:ext uri="{91240B29-F687-4f45-9708-019B960494DF}">
-                <a14:hiddenLine xmlns="" xmlns:a14="http://schemas.microsoft.com/office/drawing/2010/main" w="9525">
+                <a14:hiddenLine xmlns:a14="http://schemas.microsoft.com/office/drawing/2010/main" xmlns="" w="9525">
                   <a:solidFill>
                     <a:srgbClr val="000000"/>
                   </a:solidFill>
@@ -710,7 +887,7 @@
             </a:ln>
             <a:extLst>
               <a:ext uri="{91240B29-F687-4f45-9708-019B960494DF}">
-                <a14:hiddenLine xmlns="" xmlns:a14="http://schemas.microsoft.com/office/drawing/2010/main" w="9525">
+                <a14:hiddenLine xmlns:a14="http://schemas.microsoft.com/office/drawing/2010/main" xmlns="" w="9525">
                   <a:solidFill>
                     <a:srgbClr val="000000"/>
                   </a:solidFill>
@@ -800,7 +977,7 @@
             </a:ln>
             <a:extLst>
               <a:ext uri="{91240B29-F687-4f45-9708-019B960494DF}">
-                <a14:hiddenLine xmlns="" xmlns:a14="http://schemas.microsoft.com/office/drawing/2010/main" w="9525">
+                <a14:hiddenLine xmlns:a14="http://schemas.microsoft.com/office/drawing/2010/main" xmlns="" w="9525">
                   <a:solidFill>
                     <a:srgbClr val="000000"/>
                   </a:solidFill>
@@ -834,7 +1011,7 @@
             </a:ln>
             <a:extLst>
               <a:ext uri="{91240B29-F687-4f45-9708-019B960494DF}">
-                <a14:hiddenLine xmlns="" xmlns:a14="http://schemas.microsoft.com/office/drawing/2010/main" w="9525">
+                <a14:hiddenLine xmlns:a14="http://schemas.microsoft.com/office/drawing/2010/main" xmlns="" w="9525">
                   <a:solidFill>
                     <a:srgbClr val="000000"/>
                   </a:solidFill>
@@ -924,7 +1101,7 @@
             </a:ln>
             <a:extLst>
               <a:ext uri="{91240B29-F687-4f45-9708-019B960494DF}">
-                <a14:hiddenLine xmlns="" xmlns:a14="http://schemas.microsoft.com/office/drawing/2010/main" w="9525">
+                <a14:hiddenLine xmlns:a14="http://schemas.microsoft.com/office/drawing/2010/main" xmlns="" w="9525">
                   <a:solidFill>
                     <a:srgbClr val="000000"/>
                   </a:solidFill>
@@ -986,7 +1163,7 @@
             </a:ln>
             <a:extLst>
               <a:ext uri="{91240B29-F687-4f45-9708-019B960494DF}">
-                <a14:hiddenLine xmlns="" xmlns:a14="http://schemas.microsoft.com/office/drawing/2010/main" w="9525">
+                <a14:hiddenLine xmlns:a14="http://schemas.microsoft.com/office/drawing/2010/main" xmlns="" w="9525">
                   <a:solidFill>
                     <a:srgbClr val="000000"/>
                   </a:solidFill>
@@ -1048,7 +1225,7 @@
             </a:ln>
             <a:extLst>
               <a:ext uri="{91240B29-F687-4f45-9708-019B960494DF}">
-                <a14:hiddenLine xmlns="" xmlns:a14="http://schemas.microsoft.com/office/drawing/2010/main" w="9525">
+                <a14:hiddenLine xmlns:a14="http://schemas.microsoft.com/office/drawing/2010/main" xmlns="" w="9525">
                   <a:solidFill>
                     <a:srgbClr val="000000"/>
                   </a:solidFill>
@@ -1138,7 +1315,7 @@
             </a:ln>
             <a:extLst>
               <a:ext uri="{91240B29-F687-4f45-9708-019B960494DF}">
-                <a14:hiddenLine xmlns="" xmlns:a14="http://schemas.microsoft.com/office/drawing/2010/main" w="9525">
+                <a14:hiddenLine xmlns:a14="http://schemas.microsoft.com/office/drawing/2010/main" xmlns="" w="9525">
                   <a:solidFill>
                     <a:srgbClr val="000000"/>
                   </a:solidFill>
@@ -1200,7 +1377,7 @@
             </a:ln>
             <a:extLst>
               <a:ext uri="{91240B29-F687-4f45-9708-019B960494DF}">
-                <a14:hiddenLine xmlns="" xmlns:a14="http://schemas.microsoft.com/office/drawing/2010/main" w="9525">
+                <a14:hiddenLine xmlns:a14="http://schemas.microsoft.com/office/drawing/2010/main" xmlns="" w="9525">
                   <a:solidFill>
                     <a:srgbClr val="000000"/>
                   </a:solidFill>
@@ -1262,7 +1439,7 @@
             </a:ln>
             <a:extLst>
               <a:ext uri="{91240B29-F687-4f45-9708-019B960494DF}">
-                <a14:hiddenLine xmlns="" xmlns:a14="http://schemas.microsoft.com/office/drawing/2010/main" w="9525">
+                <a14:hiddenLine xmlns:a14="http://schemas.microsoft.com/office/drawing/2010/main" xmlns="" w="9525">
                   <a:solidFill>
                     <a:srgbClr val="000000"/>
                   </a:solidFill>
@@ -1352,7 +1529,7 @@
             </a:ln>
             <a:extLst>
               <a:ext uri="{91240B29-F687-4f45-9708-019B960494DF}">
-                <a14:hiddenLine xmlns="" xmlns:a14="http://schemas.microsoft.com/office/drawing/2010/main" w="9525">
+                <a14:hiddenLine xmlns:a14="http://schemas.microsoft.com/office/drawing/2010/main" xmlns="" w="9525">
                   <a:solidFill>
                     <a:srgbClr val="000000"/>
                   </a:solidFill>
@@ -1442,7 +1619,7 @@
             </a:ln>
             <a:extLst>
               <a:ext uri="{91240B29-F687-4f45-9708-019B960494DF}">
-                <a14:hiddenLine xmlns="" xmlns:a14="http://schemas.microsoft.com/office/drawing/2010/main" w="9525">
+                <a14:hiddenLine xmlns:a14="http://schemas.microsoft.com/office/drawing/2010/main" xmlns="" w="9525">
                   <a:solidFill>
                     <a:srgbClr val="000000"/>
                   </a:solidFill>
@@ -1504,7 +1681,7 @@
             </a:ln>
             <a:extLst>
               <a:ext uri="{91240B29-F687-4f45-9708-019B960494DF}">
-                <a14:hiddenLine xmlns="" xmlns:a14="http://schemas.microsoft.com/office/drawing/2010/main" w="9525">
+                <a14:hiddenLine xmlns:a14="http://schemas.microsoft.com/office/drawing/2010/main" xmlns="" w="9525">
                   <a:solidFill>
                     <a:srgbClr val="000000"/>
                   </a:solidFill>
@@ -1614,7 +1791,7 @@
             </a:ln>
             <a:extLst>
               <a:ext uri="{91240B29-F687-4f45-9708-019B960494DF}">
-                <a14:hiddenLine xmlns="" xmlns:a14="http://schemas.microsoft.com/office/drawing/2010/main" w="9525">
+                <a14:hiddenLine xmlns:a14="http://schemas.microsoft.com/office/drawing/2010/main" xmlns="" w="9525">
                   <a:solidFill>
                     <a:srgbClr val="000000"/>
                   </a:solidFill>
@@ -1676,7 +1853,7 @@
             </a:ln>
             <a:extLst>
               <a:ext uri="{91240B29-F687-4f45-9708-019B960494DF}">
-                <a14:hiddenLine xmlns="" xmlns:a14="http://schemas.microsoft.com/office/drawing/2010/main" w="9525">
+                <a14:hiddenLine xmlns:a14="http://schemas.microsoft.com/office/drawing/2010/main" xmlns="" w="9525">
                   <a:solidFill>
                     <a:srgbClr val="000000"/>
                   </a:solidFill>
@@ -1766,7 +1943,7 @@
             </a:ln>
             <a:extLst>
               <a:ext uri="{91240B29-F687-4f45-9708-019B960494DF}">
-                <a14:hiddenLine xmlns="" xmlns:a14="http://schemas.microsoft.com/office/drawing/2010/main" w="9525">
+                <a14:hiddenLine xmlns:a14="http://schemas.microsoft.com/office/drawing/2010/main" xmlns="" w="9525">
                   <a:solidFill>
                     <a:srgbClr val="000000"/>
                   </a:solidFill>
@@ -1856,7 +2033,7 @@
             </a:ln>
             <a:extLst>
               <a:ext uri="{91240B29-F687-4f45-9708-019B960494DF}">
-                <a14:hiddenLine xmlns="" xmlns:a14="http://schemas.microsoft.com/office/drawing/2010/main" w="9525">
+                <a14:hiddenLine xmlns:a14="http://schemas.microsoft.com/office/drawing/2010/main" xmlns="" w="9525">
                   <a:solidFill>
                     <a:srgbClr val="000000"/>
                   </a:solidFill>
@@ -1918,7 +2095,7 @@
             </a:ln>
             <a:extLst>
               <a:ext uri="{91240B29-F687-4f45-9708-019B960494DF}">
-                <a14:hiddenLine xmlns="" xmlns:a14="http://schemas.microsoft.com/office/drawing/2010/main" w="9525">
+                <a14:hiddenLine xmlns:a14="http://schemas.microsoft.com/office/drawing/2010/main" xmlns="" w="9525">
                   <a:solidFill>
                     <a:srgbClr val="000000"/>
                   </a:solidFill>
@@ -2008,7 +2185,7 @@
             </a:ln>
             <a:extLst>
               <a:ext uri="{91240B29-F687-4f45-9708-019B960494DF}">
-                <a14:hiddenLine xmlns="" xmlns:a14="http://schemas.microsoft.com/office/drawing/2010/main" w="9525">
+                <a14:hiddenLine xmlns:a14="http://schemas.microsoft.com/office/drawing/2010/main" xmlns="" w="9525">
                   <a:solidFill>
                     <a:srgbClr val="000000"/>
                   </a:solidFill>
@@ -2098,7 +2275,7 @@
             </a:ln>
             <a:extLst>
               <a:ext uri="{91240B29-F687-4f45-9708-019B960494DF}">
-                <a14:hiddenLine xmlns="" xmlns:a14="http://schemas.microsoft.com/office/drawing/2010/main" w="9525">
+                <a14:hiddenLine xmlns:a14="http://schemas.microsoft.com/office/drawing/2010/main" xmlns="" w="9525">
                   <a:solidFill>
                     <a:srgbClr val="000000"/>
                   </a:solidFill>
@@ -2154,7 +2331,7 @@
             </a:ln>
             <a:extLst>
               <a:ext uri="{91240B29-F687-4f45-9708-019B960494DF}">
-                <a14:hiddenLine xmlns="" xmlns:a14="http://schemas.microsoft.com/office/drawing/2010/main" w="9525">
+                <a14:hiddenLine xmlns:a14="http://schemas.microsoft.com/office/drawing/2010/main" xmlns="" w="9525">
                   <a:solidFill>
                     <a:srgbClr val="000000"/>
                   </a:solidFill>
@@ -2244,7 +2421,7 @@
             </a:ln>
             <a:extLst>
               <a:ext uri="{91240B29-F687-4f45-9708-019B960494DF}">
-                <a14:hiddenLine xmlns="" xmlns:a14="http://schemas.microsoft.com/office/drawing/2010/main" w="9525">
+                <a14:hiddenLine xmlns:a14="http://schemas.microsoft.com/office/drawing/2010/main" xmlns="" w="9525">
                   <a:solidFill>
                     <a:srgbClr val="000000"/>
                   </a:solidFill>
@@ -2300,7 +2477,7 @@
             </a:ln>
             <a:extLst>
               <a:ext uri="{91240B29-F687-4f45-9708-019B960494DF}">
-                <a14:hiddenLine xmlns="" xmlns:a14="http://schemas.microsoft.com/office/drawing/2010/main" w="9525">
+                <a14:hiddenLine xmlns:a14="http://schemas.microsoft.com/office/drawing/2010/main" xmlns="" w="9525">
                   <a:solidFill>
                     <a:srgbClr val="000000"/>
                   </a:solidFill>
@@ -2390,7 +2567,7 @@
             </a:ln>
             <a:extLst>
               <a:ext uri="{91240B29-F687-4f45-9708-019B960494DF}">
-                <a14:hiddenLine xmlns="" xmlns:a14="http://schemas.microsoft.com/office/drawing/2010/main" w="9525">
+                <a14:hiddenLine xmlns:a14="http://schemas.microsoft.com/office/drawing/2010/main" xmlns="" w="9525">
                   <a:solidFill>
                     <a:srgbClr val="000000"/>
                   </a:solidFill>
@@ -2458,7 +2635,7 @@
             </a:ln>
             <a:extLst>
               <a:ext uri="{91240B29-F687-4f45-9708-019B960494DF}">
-                <a14:hiddenLine xmlns="" xmlns:a14="http://schemas.microsoft.com/office/drawing/2010/main" w="9525">
+                <a14:hiddenLine xmlns:a14="http://schemas.microsoft.com/office/drawing/2010/main" xmlns="" w="9525">
                   <a:solidFill>
                     <a:srgbClr val="000000"/>
                   </a:solidFill>
@@ -2548,7 +2725,7 @@
             </a:ln>
             <a:extLst>
               <a:ext uri="{91240B29-F687-4f45-9708-019B960494DF}">
-                <a14:hiddenLine xmlns="" xmlns:a14="http://schemas.microsoft.com/office/drawing/2010/main" w="9525">
+                <a14:hiddenLine xmlns:a14="http://schemas.microsoft.com/office/drawing/2010/main" xmlns="" w="9525">
                   <a:solidFill>
                     <a:srgbClr val="000000"/>
                   </a:solidFill>
@@ -2616,7 +2793,7 @@
             </a:ln>
             <a:extLst>
               <a:ext uri="{91240B29-F687-4f45-9708-019B960494DF}">
-                <a14:hiddenLine xmlns="" xmlns:a14="http://schemas.microsoft.com/office/drawing/2010/main" w="9525">
+                <a14:hiddenLine xmlns:a14="http://schemas.microsoft.com/office/drawing/2010/main" xmlns="" w="9525">
                   <a:solidFill>
                     <a:srgbClr val="000000"/>
                   </a:solidFill>
@@ -2706,7 +2883,7 @@
             </a:ln>
             <a:extLst>
               <a:ext uri="{91240B29-F687-4f45-9708-019B960494DF}">
-                <a14:hiddenLine xmlns="" xmlns:a14="http://schemas.microsoft.com/office/drawing/2010/main" w="9525">
+                <a14:hiddenLine xmlns:a14="http://schemas.microsoft.com/office/drawing/2010/main" xmlns="" w="9525">
                   <a:solidFill>
                     <a:srgbClr val="000000"/>
                   </a:solidFill>
@@ -2740,7 +2917,7 @@
             </a:ln>
             <a:extLst>
               <a:ext uri="{91240B29-F687-4f45-9708-019B960494DF}">
-                <a14:hiddenLine xmlns="" xmlns:a14="http://schemas.microsoft.com/office/drawing/2010/main" w="9525">
+                <a14:hiddenLine xmlns:a14="http://schemas.microsoft.com/office/drawing/2010/main" xmlns="" w="9525">
                   <a:solidFill>
                     <a:srgbClr val="000000"/>
                   </a:solidFill>
@@ -2830,7 +3007,7 @@
             </a:ln>
             <a:extLst>
               <a:ext uri="{91240B29-F687-4f45-9708-019B960494DF}">
-                <a14:hiddenLine xmlns="" xmlns:a14="http://schemas.microsoft.com/office/drawing/2010/main" w="9525">
+                <a14:hiddenLine xmlns:a14="http://schemas.microsoft.com/office/drawing/2010/main" xmlns="" w="9525">
                   <a:solidFill>
                     <a:srgbClr val="000000"/>
                   </a:solidFill>
@@ -2892,7 +3069,7 @@
             </a:ln>
             <a:extLst>
               <a:ext uri="{91240B29-F687-4f45-9708-019B960494DF}">
-                <a14:hiddenLine xmlns="" xmlns:a14="http://schemas.microsoft.com/office/drawing/2010/main" w="9525">
+                <a14:hiddenLine xmlns:a14="http://schemas.microsoft.com/office/drawing/2010/main" xmlns="" w="9525">
                   <a:solidFill>
                     <a:srgbClr val="000000"/>
                   </a:solidFill>
@@ -2954,7 +3131,7 @@
             </a:ln>
             <a:extLst>
               <a:ext uri="{91240B29-F687-4f45-9708-019B960494DF}">
-                <a14:hiddenLine xmlns="" xmlns:a14="http://schemas.microsoft.com/office/drawing/2010/main" w="9525">
+                <a14:hiddenLine xmlns:a14="http://schemas.microsoft.com/office/drawing/2010/main" xmlns="" w="9525">
                   <a:solidFill>
                     <a:srgbClr val="000000"/>
                   </a:solidFill>
@@ -3044,7 +3221,7 @@
             </a:ln>
             <a:extLst>
               <a:ext uri="{91240B29-F687-4f45-9708-019B960494DF}">
-                <a14:hiddenLine xmlns="" xmlns:a14="http://schemas.microsoft.com/office/drawing/2010/main" w="9525">
+                <a14:hiddenLine xmlns:a14="http://schemas.microsoft.com/office/drawing/2010/main" xmlns="" w="9525">
                   <a:solidFill>
                     <a:srgbClr val="000000"/>
                   </a:solidFill>
@@ -3112,7 +3289,7 @@
             </a:ln>
             <a:extLst>
               <a:ext uri="{91240B29-F687-4f45-9708-019B960494DF}">
-                <a14:hiddenLine xmlns="" xmlns:a14="http://schemas.microsoft.com/office/drawing/2010/main" w="9525">
+                <a14:hiddenLine xmlns:a14="http://schemas.microsoft.com/office/drawing/2010/main" xmlns="" w="9525">
                   <a:solidFill>
                     <a:srgbClr val="000000"/>
                   </a:solidFill>
@@ -3174,7 +3351,7 @@
             </a:ln>
             <a:extLst>
               <a:ext uri="{91240B29-F687-4f45-9708-019B960494DF}">
-                <a14:hiddenLine xmlns="" xmlns:a14="http://schemas.microsoft.com/office/drawing/2010/main" w="9525">
+                <a14:hiddenLine xmlns:a14="http://schemas.microsoft.com/office/drawing/2010/main" xmlns="" w="9525">
                   <a:solidFill>
                     <a:srgbClr val="000000"/>
                   </a:solidFill>
@@ -3264,7 +3441,7 @@
             </a:ln>
             <a:extLst>
               <a:ext uri="{91240B29-F687-4f45-9708-019B960494DF}">
-                <a14:hiddenLine xmlns="" xmlns:a14="http://schemas.microsoft.com/office/drawing/2010/main" w="9525">
+                <a14:hiddenLine xmlns:a14="http://schemas.microsoft.com/office/drawing/2010/main" xmlns="" w="9525">
                   <a:solidFill>
                     <a:srgbClr val="000000"/>
                   </a:solidFill>
@@ -3326,7 +3503,7 @@
             </a:ln>
             <a:extLst>
               <a:ext uri="{91240B29-F687-4f45-9708-019B960494DF}">
-                <a14:hiddenLine xmlns="" xmlns:a14="http://schemas.microsoft.com/office/drawing/2010/main" w="9525">
+                <a14:hiddenLine xmlns:a14="http://schemas.microsoft.com/office/drawing/2010/main" xmlns="" w="9525">
                   <a:solidFill>
                     <a:srgbClr val="000000"/>
                   </a:solidFill>
@@ -3416,7 +3593,7 @@
             </a:ln>
             <a:extLst>
               <a:ext uri="{91240B29-F687-4f45-9708-019B960494DF}">
-                <a14:hiddenLine xmlns="" xmlns:a14="http://schemas.microsoft.com/office/drawing/2010/main" w="9525">
+                <a14:hiddenLine xmlns:a14="http://schemas.microsoft.com/office/drawing/2010/main" xmlns="" w="9525">
                   <a:solidFill>
                     <a:srgbClr val="000000"/>
                   </a:solidFill>
@@ -3478,7 +3655,7 @@
             </a:ln>
             <a:extLst>
               <a:ext uri="{91240B29-F687-4f45-9708-019B960494DF}">
-                <a14:hiddenLine xmlns="" xmlns:a14="http://schemas.microsoft.com/office/drawing/2010/main" w="9525">
+                <a14:hiddenLine xmlns:a14="http://schemas.microsoft.com/office/drawing/2010/main" xmlns="" w="9525">
                   <a:solidFill>
                     <a:srgbClr val="000000"/>
                   </a:solidFill>
@@ -3568,7 +3745,7 @@
             </a:ln>
             <a:extLst>
               <a:ext uri="{91240B29-F687-4f45-9708-019B960494DF}">
-                <a14:hiddenLine xmlns="" xmlns:a14="http://schemas.microsoft.com/office/drawing/2010/main" w="9525">
+                <a14:hiddenLine xmlns:a14="http://schemas.microsoft.com/office/drawing/2010/main" xmlns="" w="9525">
                   <a:solidFill>
                     <a:srgbClr val="000000"/>
                   </a:solidFill>
@@ -3602,7 +3779,7 @@
             </a:ln>
             <a:extLst>
               <a:ext uri="{91240B29-F687-4f45-9708-019B960494DF}">
-                <a14:hiddenLine xmlns="" xmlns:a14="http://schemas.microsoft.com/office/drawing/2010/main" w="9525">
+                <a14:hiddenLine xmlns:a14="http://schemas.microsoft.com/office/drawing/2010/main" xmlns="" w="9525">
                   <a:solidFill>
                     <a:srgbClr val="000000"/>
                   </a:solidFill>
@@ -3667,7 +3844,7 @@
             </a:ln>
             <a:extLst>
               <a:ext uri="{91240B29-F687-4f45-9708-019B960494DF}">
-                <a14:hiddenLine xmlns="" xmlns:a14="http://schemas.microsoft.com/office/drawing/2010/main" w="9525">
+                <a14:hiddenLine xmlns:a14="http://schemas.microsoft.com/office/drawing/2010/main" xmlns="" w="9525">
                   <a:solidFill>
                     <a:srgbClr val="000000"/>
                   </a:solidFill>
@@ -3757,7 +3934,7 @@
             </a:ln>
             <a:extLst>
               <a:ext uri="{91240B29-F687-4f45-9708-019B960494DF}">
-                <a14:hiddenLine xmlns="" xmlns:a14="http://schemas.microsoft.com/office/drawing/2010/main" w="9525">
+                <a14:hiddenLine xmlns:a14="http://schemas.microsoft.com/office/drawing/2010/main" xmlns="" w="9525">
                   <a:solidFill>
                     <a:srgbClr val="000000"/>
                   </a:solidFill>
@@ -3819,7 +3996,7 @@
             </a:ln>
             <a:extLst>
               <a:ext uri="{91240B29-F687-4f45-9708-019B960494DF}">
-                <a14:hiddenLine xmlns="" xmlns:a14="http://schemas.microsoft.com/office/drawing/2010/main" w="9525">
+                <a14:hiddenLine xmlns:a14="http://schemas.microsoft.com/office/drawing/2010/main" xmlns="" w="9525">
                   <a:solidFill>
                     <a:srgbClr val="000000"/>
                   </a:solidFill>
@@ -3909,7 +4086,7 @@
             </a:ln>
             <a:extLst>
               <a:ext uri="{91240B29-F687-4f45-9708-019B960494DF}">
-                <a14:hiddenLine xmlns="" xmlns:a14="http://schemas.microsoft.com/office/drawing/2010/main" w="9525">
+                <a14:hiddenLine xmlns:a14="http://schemas.microsoft.com/office/drawing/2010/main" xmlns="" w="9525">
                   <a:solidFill>
                     <a:srgbClr val="000000"/>
                   </a:solidFill>
@@ -3999,7 +4176,7 @@
             </a:ln>
             <a:extLst>
               <a:ext uri="{91240B29-F687-4f45-9708-019B960494DF}">
-                <a14:hiddenLine xmlns="" xmlns:a14="http://schemas.microsoft.com/office/drawing/2010/main" w="9525">
+                <a14:hiddenLine xmlns:a14="http://schemas.microsoft.com/office/drawing/2010/main" xmlns="" w="9525">
                   <a:solidFill>
                     <a:srgbClr val="000000"/>
                   </a:solidFill>
@@ -4064,7 +4241,7 @@
             </a:ln>
             <a:extLst>
               <a:ext uri="{91240B29-F687-4f45-9708-019B960494DF}">
-                <a14:hiddenLine xmlns="" xmlns:a14="http://schemas.microsoft.com/office/drawing/2010/main" w="9525">
+                <a14:hiddenLine xmlns:a14="http://schemas.microsoft.com/office/drawing/2010/main" xmlns="" w="9525">
                   <a:solidFill>
                     <a:srgbClr val="000000"/>
                   </a:solidFill>
@@ -4126,7 +4303,7 @@
             </a:ln>
             <a:extLst>
               <a:ext uri="{91240B29-F687-4f45-9708-019B960494DF}">
-                <a14:hiddenLine xmlns="" xmlns:a14="http://schemas.microsoft.com/office/drawing/2010/main" w="9525">
+                <a14:hiddenLine xmlns:a14="http://schemas.microsoft.com/office/drawing/2010/main" xmlns="" w="9525">
                   <a:solidFill>
                     <a:srgbClr val="000000"/>
                   </a:solidFill>
@@ -4216,7 +4393,7 @@
             </a:ln>
             <a:extLst>
               <a:ext uri="{91240B29-F687-4f45-9708-019B960494DF}">
-                <a14:hiddenLine xmlns="" xmlns:a14="http://schemas.microsoft.com/office/drawing/2010/main" w="9525">
+                <a14:hiddenLine xmlns:a14="http://schemas.microsoft.com/office/drawing/2010/main" xmlns="" w="9525">
                   <a:solidFill>
                     <a:srgbClr val="000000"/>
                   </a:solidFill>
@@ -4306,7 +4483,7 @@
             </a:ln>
             <a:extLst>
               <a:ext uri="{91240B29-F687-4f45-9708-019B960494DF}">
-                <a14:hiddenLine xmlns="" xmlns:a14="http://schemas.microsoft.com/office/drawing/2010/main" w="9525">
+                <a14:hiddenLine xmlns:a14="http://schemas.microsoft.com/office/drawing/2010/main" xmlns="" w="9525">
                   <a:solidFill>
                     <a:srgbClr val="000000"/>
                   </a:solidFill>
@@ -4368,7 +4545,7 @@
             </a:ln>
             <a:extLst>
               <a:ext uri="{91240B29-F687-4f45-9708-019B960494DF}">
-                <a14:hiddenLine xmlns="" xmlns:a14="http://schemas.microsoft.com/office/drawing/2010/main" w="9525">
+                <a14:hiddenLine xmlns:a14="http://schemas.microsoft.com/office/drawing/2010/main" xmlns="" w="9525">
                   <a:solidFill>
                     <a:srgbClr val="000000"/>
                   </a:solidFill>
@@ -4488,7 +4665,7 @@
             </a:ln>
             <a:extLst>
               <a:ext uri="{91240B29-F687-4f45-9708-019B960494DF}">
-                <a14:hiddenLine xmlns="" xmlns:a14="http://schemas.microsoft.com/office/drawing/2010/main" w="9525">
+                <a14:hiddenLine xmlns:a14="http://schemas.microsoft.com/office/drawing/2010/main" xmlns="" w="9525">
                   <a:solidFill>
                     <a:srgbClr val="000000"/>
                   </a:solidFill>
@@ -4556,7 +4733,7 @@
             </a:ln>
             <a:extLst>
               <a:ext uri="{91240B29-F687-4f45-9708-019B960494DF}">
-                <a14:hiddenLine xmlns="" xmlns:a14="http://schemas.microsoft.com/office/drawing/2010/main" w="9525">
+                <a14:hiddenLine xmlns:a14="http://schemas.microsoft.com/office/drawing/2010/main" xmlns="" w="9525">
                   <a:solidFill>
                     <a:srgbClr val="000000"/>
                   </a:solidFill>
@@ -4646,7 +4823,7 @@
             </a:ln>
             <a:extLst>
               <a:ext uri="{91240B29-F687-4f45-9708-019B960494DF}">
-                <a14:hiddenLine xmlns="" xmlns:a14="http://schemas.microsoft.com/office/drawing/2010/main" w="9525">
+                <a14:hiddenLine xmlns:a14="http://schemas.microsoft.com/office/drawing/2010/main" xmlns="" w="9525">
                   <a:solidFill>
                     <a:srgbClr val="000000"/>
                   </a:solidFill>
@@ -4786,7 +4963,7 @@
           <a:p>
             <a:fld id="{3CF3BA0B-E698-5540-9A51-8083476D2E3D}" type="datetime1">
               <a:rPr lang="en-US" smtClean="0"/>
-              <a:t>9/11/25</a:t>
+              <a:t>1/28/26</a:t>
             </a:fld>
             <a:endParaRPr lang="en-US"/>
           </a:p>
@@ -5053,7 +5230,7 @@
           <a:p>
             <a:fld id="{2077838D-B11C-614E-A08E-4EEFC82B0C3A}" type="datetime1">
               <a:rPr lang="en-US" smtClean="0"/>
-              <a:t>9/11/25</a:t>
+              <a:t>1/28/26</a:t>
             </a:fld>
             <a:endParaRPr lang="en-US"/>
           </a:p>
@@ -5249,7 +5426,7 @@
           <a:p>
             <a:fld id="{B13A4990-3C60-3640-8339-4AA1D075E030}" type="datetime1">
               <a:rPr lang="en-US" smtClean="0"/>
-              <a:t>9/11/25</a:t>
+              <a:t>1/28/26</a:t>
             </a:fld>
             <a:endParaRPr lang="en-US"/>
           </a:p>
@@ -5512,7 +5689,7 @@
           <a:p>
             <a:fld id="{FB975995-E789-7444-A0F4-C99D7EFE52CF}" type="datetime1">
               <a:rPr lang="en-US" smtClean="0"/>
-              <a:t>9/11/25</a:t>
+              <a:t>1/28/26</a:t>
             </a:fld>
             <a:endParaRPr lang="en-US"/>
           </a:p>
@@ -5946,7 +6123,7 @@
           <a:p>
             <a:fld id="{1361CC93-0D8C-314E-940B-2B9C0C9A184D}" type="datetime1">
               <a:rPr lang="en-US" smtClean="0"/>
-              <a:t>9/11/25</a:t>
+              <a:t>1/28/26</a:t>
             </a:fld>
             <a:endParaRPr lang="en-US"/>
           </a:p>
@@ -6492,7 +6669,7 @@
           <a:p>
             <a:fld id="{FFC66E91-7F47-1D4B-A106-B2D1EABC6C33}" type="datetime1">
               <a:rPr lang="en-US" smtClean="0"/>
-              <a:t>9/11/25</a:t>
+              <a:t>1/28/26</a:t>
             </a:fld>
             <a:endParaRPr lang="en-US"/>
           </a:p>
@@ -7212,7 +7389,7 @@
           <a:p>
             <a:fld id="{3E41962D-803E-624E-B855-4E74BAAC62CE}" type="datetime1">
               <a:rPr lang="en-US" smtClean="0"/>
-              <a:t>9/11/25</a:t>
+              <a:t>1/28/26</a:t>
             </a:fld>
             <a:endParaRPr lang="en-US"/>
           </a:p>
@@ -7382,7 +7559,7 @@
           <a:p>
             <a:fld id="{CF178DDA-4B07-F247-83B3-B754B14FDD0D}" type="datetime1">
               <a:rPr lang="en-US" smtClean="0"/>
-              <a:t>9/11/25</a:t>
+              <a:t>1/28/26</a:t>
             </a:fld>
             <a:endParaRPr lang="en-US"/>
           </a:p>
@@ -7562,7 +7739,7 @@
           <a:p>
             <a:fld id="{B4471004-396B-8747-9A38-63BFCEC5D796}" type="datetime1">
               <a:rPr lang="en-US" smtClean="0"/>
-              <a:t>9/11/25</a:t>
+              <a:t>1/28/26</a:t>
             </a:fld>
             <a:endParaRPr lang="en-US"/>
           </a:p>
@@ -7732,7 +7909,7 @@
           <a:p>
             <a:fld id="{64ECE0E3-ED19-2346-A2D6-36D38B853075}" type="datetime1">
               <a:rPr lang="en-US" smtClean="0"/>
-              <a:t>9/11/25</a:t>
+              <a:t>1/28/26</a:t>
             </a:fld>
             <a:endParaRPr lang="en-US"/>
           </a:p>
@@ -7982,7 +8159,7 @@
           <a:p>
             <a:fld id="{ED43B5EC-2A1A-5C45-BED1-7B532E860D4D}" type="datetime1">
               <a:rPr lang="en-US" smtClean="0"/>
-              <a:t>9/11/25</a:t>
+              <a:t>1/28/26</a:t>
             </a:fld>
             <a:endParaRPr lang="en-US"/>
           </a:p>
@@ -8214,7 +8391,7 @@
           <a:p>
             <a:fld id="{ECF67943-9AF6-F744-AAB0-77241154B9E4}" type="datetime1">
               <a:rPr lang="en-US" smtClean="0"/>
-              <a:t>9/11/25</a:t>
+              <a:t>1/28/26</a:t>
             </a:fld>
             <a:endParaRPr lang="en-US"/>
           </a:p>
@@ -8600,7 +8777,7 @@
           <a:p>
             <a:fld id="{A4FB0B33-18F4-7146-BAA8-FA96684D8431}" type="datetime1">
               <a:rPr lang="en-US" smtClean="0"/>
-              <a:t>9/11/25</a:t>
+              <a:t>1/28/26</a:t>
             </a:fld>
             <a:endParaRPr lang="en-US"/>
           </a:p>
@@ -8723,7 +8900,7 @@
           <a:p>
             <a:fld id="{D794A0E1-81D9-7047-9501-E167FDE856C9}" type="datetime1">
               <a:rPr lang="en-US" smtClean="0"/>
-              <a:t>9/11/25</a:t>
+              <a:t>1/28/26</a:t>
             </a:fld>
             <a:endParaRPr lang="en-US"/>
           </a:p>
@@ -8818,7 +8995,7 @@
           <a:p>
             <a:fld id="{02B68B26-117A-2440-8E74-75615700EE30}" type="datetime1">
               <a:rPr lang="en-US" smtClean="0"/>
-              <a:t>9/11/25</a:t>
+              <a:t>1/28/26</a:t>
             </a:fld>
             <a:endParaRPr lang="en-US"/>
           </a:p>
@@ -9067,7 +9244,7 @@
           <a:p>
             <a:fld id="{5518F820-0046-BB43-8322-B48D912FF64B}" type="datetime1">
               <a:rPr lang="en-US" smtClean="0"/>
-              <a:t>9/11/25</a:t>
+              <a:t>1/28/26</a:t>
             </a:fld>
             <a:endParaRPr lang="en-US"/>
           </a:p>
@@ -9352,7 +9529,7 @@
           <a:p>
             <a:fld id="{BD6318F5-69AB-754B-8CD2-F6B47A9B8667}" type="datetime1">
               <a:rPr lang="en-US" smtClean="0"/>
-              <a:t>9/11/25</a:t>
+              <a:t>1/28/26</a:t>
             </a:fld>
             <a:endParaRPr lang="en-US"/>
           </a:p>
@@ -9475,7 +9652,7 @@
           <a:noFill/>
           <a:extLst>
             <a:ext uri="{909E8E84-426E-40dd-AFC4-6F175D3DCCD1}">
-              <a14:hiddenFill xmlns="" xmlns:a14="http://schemas.microsoft.com/office/drawing/2010/main">
+              <a14:hiddenFill xmlns:a14="http://schemas.microsoft.com/office/drawing/2010/main" xmlns="">
                 <a:solidFill>
                   <a:srgbClr val="FFFFFF"/>
                 </a:solidFill>
@@ -9549,7 +9726,7 @@
               </a:ln>
               <a:extLst>
                 <a:ext uri="{91240B29-F687-4f45-9708-019B960494DF}">
-                  <a14:hiddenLine xmlns="" xmlns:a14="http://schemas.microsoft.com/office/drawing/2010/main" w="9525">
+                  <a14:hiddenLine xmlns:a14="http://schemas.microsoft.com/office/drawing/2010/main" xmlns="" w="9525">
                     <a:solidFill>
                       <a:srgbClr val="000000"/>
                     </a:solidFill>
@@ -9639,7 +9816,7 @@
               </a:ln>
               <a:extLst>
                 <a:ext uri="{91240B29-F687-4f45-9708-019B960494DF}">
-                  <a14:hiddenLine xmlns="" xmlns:a14="http://schemas.microsoft.com/office/drawing/2010/main" w="9525">
+                  <a14:hiddenLine xmlns:a14="http://schemas.microsoft.com/office/drawing/2010/main" xmlns="" w="9525">
                     <a:solidFill>
                       <a:srgbClr val="000000"/>
                     </a:solidFill>
@@ -9729,7 +9906,7 @@
               </a:ln>
               <a:extLst>
                 <a:ext uri="{91240B29-F687-4f45-9708-019B960494DF}">
-                  <a14:hiddenLine xmlns="" xmlns:a14="http://schemas.microsoft.com/office/drawing/2010/main" w="9525">
+                  <a14:hiddenLine xmlns:a14="http://schemas.microsoft.com/office/drawing/2010/main" xmlns="" w="9525">
                     <a:solidFill>
                       <a:srgbClr val="000000"/>
                     </a:solidFill>
@@ -9791,7 +9968,7 @@
               </a:ln>
               <a:extLst>
                 <a:ext uri="{91240B29-F687-4f45-9708-019B960494DF}">
-                  <a14:hiddenLine xmlns="" xmlns:a14="http://schemas.microsoft.com/office/drawing/2010/main" w="9525">
+                  <a14:hiddenLine xmlns:a14="http://schemas.microsoft.com/office/drawing/2010/main" xmlns="" w="9525">
                     <a:solidFill>
                       <a:srgbClr val="000000"/>
                     </a:solidFill>
@@ -9881,7 +10058,7 @@
               </a:ln>
               <a:extLst>
                 <a:ext uri="{91240B29-F687-4f45-9708-019B960494DF}">
-                  <a14:hiddenLine xmlns="" xmlns:a14="http://schemas.microsoft.com/office/drawing/2010/main" w="9525">
+                  <a14:hiddenLine xmlns:a14="http://schemas.microsoft.com/office/drawing/2010/main" xmlns="" w="9525">
                     <a:solidFill>
                       <a:srgbClr val="000000"/>
                     </a:solidFill>
@@ -9943,7 +10120,7 @@
               </a:ln>
               <a:extLst>
                 <a:ext uri="{91240B29-F687-4f45-9708-019B960494DF}">
-                  <a14:hiddenLine xmlns="" xmlns:a14="http://schemas.microsoft.com/office/drawing/2010/main" w="9525">
+                  <a14:hiddenLine xmlns:a14="http://schemas.microsoft.com/office/drawing/2010/main" xmlns="" w="9525">
                     <a:solidFill>
                       <a:srgbClr val="000000"/>
                     </a:solidFill>
@@ -10005,7 +10182,7 @@
               </a:ln>
               <a:extLst>
                 <a:ext uri="{91240B29-F687-4f45-9708-019B960494DF}">
-                  <a14:hiddenLine xmlns="" xmlns:a14="http://schemas.microsoft.com/office/drawing/2010/main" w="9525">
+                  <a14:hiddenLine xmlns:a14="http://schemas.microsoft.com/office/drawing/2010/main" xmlns="" w="9525">
                     <a:solidFill>
                       <a:srgbClr val="000000"/>
                     </a:solidFill>
@@ -10095,7 +10272,7 @@
               </a:ln>
               <a:extLst>
                 <a:ext uri="{91240B29-F687-4f45-9708-019B960494DF}">
-                  <a14:hiddenLine xmlns="" xmlns:a14="http://schemas.microsoft.com/office/drawing/2010/main" w="9525">
+                  <a14:hiddenLine xmlns:a14="http://schemas.microsoft.com/office/drawing/2010/main" xmlns="" w="9525">
                     <a:solidFill>
                       <a:srgbClr val="000000"/>
                     </a:solidFill>
@@ -10185,7 +10362,7 @@
               </a:ln>
               <a:extLst>
                 <a:ext uri="{91240B29-F687-4f45-9708-019B960494DF}">
-                  <a14:hiddenLine xmlns="" xmlns:a14="http://schemas.microsoft.com/office/drawing/2010/main" w="9525">
+                  <a14:hiddenLine xmlns:a14="http://schemas.microsoft.com/office/drawing/2010/main" xmlns="" w="9525">
                     <a:solidFill>
                       <a:srgbClr val="000000"/>
                     </a:solidFill>
@@ -10247,7 +10424,7 @@
               </a:ln>
               <a:extLst>
                 <a:ext uri="{91240B29-F687-4f45-9708-019B960494DF}">
-                  <a14:hiddenLine xmlns="" xmlns:a14="http://schemas.microsoft.com/office/drawing/2010/main" w="9525">
+                  <a14:hiddenLine xmlns:a14="http://schemas.microsoft.com/office/drawing/2010/main" xmlns="" w="9525">
                     <a:solidFill>
                       <a:srgbClr val="000000"/>
                     </a:solidFill>
@@ -10357,7 +10534,7 @@
               </a:ln>
               <a:extLst>
                 <a:ext uri="{91240B29-F687-4f45-9708-019B960494DF}">
-                  <a14:hiddenLine xmlns="" xmlns:a14="http://schemas.microsoft.com/office/drawing/2010/main" w="9525">
+                  <a14:hiddenLine xmlns:a14="http://schemas.microsoft.com/office/drawing/2010/main" xmlns="" w="9525">
                     <a:solidFill>
                       <a:srgbClr val="000000"/>
                     </a:solidFill>
@@ -10441,7 +10618,7 @@
               </a:ln>
               <a:extLst>
                 <a:ext uri="{91240B29-F687-4f45-9708-019B960494DF}">
-                  <a14:hiddenLine xmlns="" xmlns:a14="http://schemas.microsoft.com/office/drawing/2010/main" w="9525">
+                  <a14:hiddenLine xmlns:a14="http://schemas.microsoft.com/office/drawing/2010/main" xmlns="" w="9525">
                     <a:solidFill>
                       <a:srgbClr val="000000"/>
                     </a:solidFill>
@@ -10503,7 +10680,7 @@
               </a:ln>
               <a:extLst>
                 <a:ext uri="{91240B29-F687-4f45-9708-019B960494DF}">
-                  <a14:hiddenLine xmlns="" xmlns:a14="http://schemas.microsoft.com/office/drawing/2010/main" w="9525">
+                  <a14:hiddenLine xmlns:a14="http://schemas.microsoft.com/office/drawing/2010/main" xmlns="" w="9525">
                     <a:solidFill>
                       <a:srgbClr val="000000"/>
                     </a:solidFill>
@@ -10565,7 +10742,7 @@
               </a:ln>
               <a:extLst>
                 <a:ext uri="{91240B29-F687-4f45-9708-019B960494DF}">
-                  <a14:hiddenLine xmlns="" xmlns:a14="http://schemas.microsoft.com/office/drawing/2010/main" w="9525">
+                  <a14:hiddenLine xmlns:a14="http://schemas.microsoft.com/office/drawing/2010/main" xmlns="" w="9525">
                     <a:solidFill>
                       <a:srgbClr val="000000"/>
                     </a:solidFill>
@@ -10655,7 +10832,7 @@
               </a:ln>
               <a:extLst>
                 <a:ext uri="{91240B29-F687-4f45-9708-019B960494DF}">
-                  <a14:hiddenLine xmlns="" xmlns:a14="http://schemas.microsoft.com/office/drawing/2010/main" w="9525">
+                  <a14:hiddenLine xmlns:a14="http://schemas.microsoft.com/office/drawing/2010/main" xmlns="" w="9525">
                     <a:solidFill>
                       <a:srgbClr val="000000"/>
                     </a:solidFill>
@@ -10689,7 +10866,7 @@
               </a:ln>
               <a:extLst>
                 <a:ext uri="{91240B29-F687-4f45-9708-019B960494DF}">
-                  <a14:hiddenLine xmlns="" xmlns:a14="http://schemas.microsoft.com/office/drawing/2010/main" w="9525">
+                  <a14:hiddenLine xmlns:a14="http://schemas.microsoft.com/office/drawing/2010/main" xmlns="" w="9525">
                     <a:solidFill>
                       <a:srgbClr val="000000"/>
                     </a:solidFill>
@@ -10754,7 +10931,7 @@
               </a:ln>
               <a:extLst>
                 <a:ext uri="{91240B29-F687-4f45-9708-019B960494DF}">
-                  <a14:hiddenLine xmlns="" xmlns:a14="http://schemas.microsoft.com/office/drawing/2010/main" w="9525">
+                  <a14:hiddenLine xmlns:a14="http://schemas.microsoft.com/office/drawing/2010/main" xmlns="" w="9525">
                     <a:solidFill>
                       <a:srgbClr val="000000"/>
                     </a:solidFill>
@@ -10844,7 +11021,7 @@
               </a:ln>
               <a:extLst>
                 <a:ext uri="{91240B29-F687-4f45-9708-019B960494DF}">
-                  <a14:hiddenLine xmlns="" xmlns:a14="http://schemas.microsoft.com/office/drawing/2010/main" w="9525">
+                  <a14:hiddenLine xmlns:a14="http://schemas.microsoft.com/office/drawing/2010/main" xmlns="" w="9525">
                     <a:solidFill>
                       <a:srgbClr val="000000"/>
                     </a:solidFill>
@@ -10906,7 +11083,7 @@
               </a:ln>
               <a:extLst>
                 <a:ext uri="{91240B29-F687-4f45-9708-019B960494DF}">
-                  <a14:hiddenLine xmlns="" xmlns:a14="http://schemas.microsoft.com/office/drawing/2010/main" w="9525">
+                  <a14:hiddenLine xmlns:a14="http://schemas.microsoft.com/office/drawing/2010/main" xmlns="" w="9525">
                     <a:solidFill>
                       <a:srgbClr val="000000"/>
                     </a:solidFill>
@@ -10996,7 +11173,7 @@
               </a:ln>
               <a:extLst>
                 <a:ext uri="{91240B29-F687-4f45-9708-019B960494DF}">
-                  <a14:hiddenLine xmlns="" xmlns:a14="http://schemas.microsoft.com/office/drawing/2010/main" w="9525">
+                  <a14:hiddenLine xmlns:a14="http://schemas.microsoft.com/office/drawing/2010/main" xmlns="" w="9525">
                     <a:solidFill>
                       <a:srgbClr val="000000"/>
                     </a:solidFill>
@@ -11061,7 +11238,7 @@
               </a:ln>
               <a:extLst>
                 <a:ext uri="{91240B29-F687-4f45-9708-019B960494DF}">
-                  <a14:hiddenLine xmlns="" xmlns:a14="http://schemas.microsoft.com/office/drawing/2010/main" w="9525">
+                  <a14:hiddenLine xmlns:a14="http://schemas.microsoft.com/office/drawing/2010/main" xmlns="" w="9525">
                     <a:solidFill>
                       <a:srgbClr val="000000"/>
                     </a:solidFill>
@@ -11123,7 +11300,7 @@
               </a:ln>
               <a:extLst>
                 <a:ext uri="{91240B29-F687-4f45-9708-019B960494DF}">
-                  <a14:hiddenLine xmlns="" xmlns:a14="http://schemas.microsoft.com/office/drawing/2010/main" w="9525">
+                  <a14:hiddenLine xmlns:a14="http://schemas.microsoft.com/office/drawing/2010/main" xmlns="" w="9525">
                     <a:solidFill>
                       <a:srgbClr val="000000"/>
                     </a:solidFill>
@@ -11213,7 +11390,7 @@
               </a:ln>
               <a:extLst>
                 <a:ext uri="{91240B29-F687-4f45-9708-019B960494DF}">
-                  <a14:hiddenLine xmlns="" xmlns:a14="http://schemas.microsoft.com/office/drawing/2010/main" w="9525">
+                  <a14:hiddenLine xmlns:a14="http://schemas.microsoft.com/office/drawing/2010/main" xmlns="" w="9525">
                     <a:solidFill>
                       <a:srgbClr val="000000"/>
                     </a:solidFill>
@@ -11303,7 +11480,7 @@
               </a:ln>
               <a:extLst>
                 <a:ext uri="{91240B29-F687-4f45-9708-019B960494DF}">
-                  <a14:hiddenLine xmlns="" xmlns:a14="http://schemas.microsoft.com/office/drawing/2010/main" w="9525">
+                  <a14:hiddenLine xmlns:a14="http://schemas.microsoft.com/office/drawing/2010/main" xmlns="" w="9525">
                     <a:solidFill>
                       <a:srgbClr val="000000"/>
                     </a:solidFill>
@@ -11368,7 +11545,7 @@
               </a:ln>
               <a:extLst>
                 <a:ext uri="{91240B29-F687-4f45-9708-019B960494DF}">
-                  <a14:hiddenLine xmlns="" xmlns:a14="http://schemas.microsoft.com/office/drawing/2010/main" w="9525">
+                  <a14:hiddenLine xmlns:a14="http://schemas.microsoft.com/office/drawing/2010/main" xmlns="" w="9525">
                     <a:solidFill>
                       <a:srgbClr val="000000"/>
                     </a:solidFill>
@@ -11488,7 +11665,7 @@
               </a:ln>
               <a:extLst>
                 <a:ext uri="{91240B29-F687-4f45-9708-019B960494DF}">
-                  <a14:hiddenLine xmlns="" xmlns:a14="http://schemas.microsoft.com/office/drawing/2010/main" w="9525">
+                  <a14:hiddenLine xmlns:a14="http://schemas.microsoft.com/office/drawing/2010/main" xmlns="" w="9525">
                     <a:solidFill>
                       <a:srgbClr val="000000"/>
                     </a:solidFill>
@@ -11569,7 +11746,7 @@
               </a:ln>
               <a:extLst>
                 <a:ext uri="{91240B29-F687-4f45-9708-019B960494DF}">
-                  <a14:hiddenLine xmlns="" xmlns:a14="http://schemas.microsoft.com/office/drawing/2010/main" w="9525">
+                  <a14:hiddenLine xmlns:a14="http://schemas.microsoft.com/office/drawing/2010/main" xmlns="" w="9525">
                     <a:solidFill>
                       <a:srgbClr val="000000"/>
                     </a:solidFill>
@@ -11684,7 +11861,7 @@
               </a:ln>
               <a:extLst>
                 <a:ext uri="{91240B29-F687-4f45-9708-019B960494DF}">
-                  <a14:hiddenLine xmlns="" xmlns:a14="http://schemas.microsoft.com/office/drawing/2010/main" w="9525">
+                  <a14:hiddenLine xmlns:a14="http://schemas.microsoft.com/office/drawing/2010/main" xmlns="" w="9525">
                     <a:solidFill>
                       <a:srgbClr val="000000"/>
                     </a:solidFill>
@@ -11774,7 +11951,7 @@
               </a:ln>
               <a:extLst>
                 <a:ext uri="{91240B29-F687-4f45-9708-019B960494DF}">
-                  <a14:hiddenLine xmlns="" xmlns:a14="http://schemas.microsoft.com/office/drawing/2010/main" w="9525">
+                  <a14:hiddenLine xmlns:a14="http://schemas.microsoft.com/office/drawing/2010/main" xmlns="" w="9525">
                     <a:solidFill>
                       <a:srgbClr val="000000"/>
                     </a:solidFill>
@@ -11839,7 +12016,7 @@
               </a:ln>
               <a:extLst>
                 <a:ext uri="{91240B29-F687-4f45-9708-019B960494DF}">
-                  <a14:hiddenLine xmlns="" xmlns:a14="http://schemas.microsoft.com/office/drawing/2010/main" w="9525">
+                  <a14:hiddenLine xmlns:a14="http://schemas.microsoft.com/office/drawing/2010/main" xmlns="" w="9525">
                     <a:solidFill>
                       <a:srgbClr val="000000"/>
                     </a:solidFill>
@@ -11929,7 +12106,7 @@
               </a:ln>
               <a:extLst>
                 <a:ext uri="{91240B29-F687-4f45-9708-019B960494DF}">
-                  <a14:hiddenLine xmlns="" xmlns:a14="http://schemas.microsoft.com/office/drawing/2010/main" w="9525">
+                  <a14:hiddenLine xmlns:a14="http://schemas.microsoft.com/office/drawing/2010/main" xmlns="" w="9525">
                     <a:solidFill>
                       <a:srgbClr val="000000"/>
                     </a:solidFill>
@@ -11997,7 +12174,7 @@
               </a:ln>
               <a:extLst>
                 <a:ext uri="{91240B29-F687-4f45-9708-019B960494DF}">
-                  <a14:hiddenLine xmlns="" xmlns:a14="http://schemas.microsoft.com/office/drawing/2010/main" w="9525">
+                  <a14:hiddenLine xmlns:a14="http://schemas.microsoft.com/office/drawing/2010/main" xmlns="" w="9525">
                     <a:solidFill>
                       <a:srgbClr val="000000"/>
                     </a:solidFill>
@@ -12087,7 +12264,7 @@
               </a:ln>
               <a:extLst>
                 <a:ext uri="{91240B29-F687-4f45-9708-019B960494DF}">
-                  <a14:hiddenLine xmlns="" xmlns:a14="http://schemas.microsoft.com/office/drawing/2010/main" w="9525">
+                  <a14:hiddenLine xmlns:a14="http://schemas.microsoft.com/office/drawing/2010/main" xmlns="" w="9525">
                     <a:solidFill>
                       <a:srgbClr val="000000"/>
                     </a:solidFill>
@@ -12155,7 +12332,7 @@
               </a:ln>
               <a:extLst>
                 <a:ext uri="{91240B29-F687-4f45-9708-019B960494DF}">
-                  <a14:hiddenLine xmlns="" xmlns:a14="http://schemas.microsoft.com/office/drawing/2010/main" w="9525">
+                  <a14:hiddenLine xmlns:a14="http://schemas.microsoft.com/office/drawing/2010/main" xmlns="" w="9525">
                     <a:solidFill>
                       <a:srgbClr val="000000"/>
                     </a:solidFill>
@@ -12245,7 +12422,7 @@
               </a:ln>
               <a:extLst>
                 <a:ext uri="{91240B29-F687-4f45-9708-019B960494DF}">
-                  <a14:hiddenLine xmlns="" xmlns:a14="http://schemas.microsoft.com/office/drawing/2010/main" w="9525">
+                  <a14:hiddenLine xmlns:a14="http://schemas.microsoft.com/office/drawing/2010/main" xmlns="" w="9525">
                     <a:solidFill>
                       <a:srgbClr val="000000"/>
                     </a:solidFill>
@@ -12279,7 +12456,7 @@
               </a:ln>
               <a:extLst>
                 <a:ext uri="{91240B29-F687-4f45-9708-019B960494DF}">
-                  <a14:hiddenLine xmlns="" xmlns:a14="http://schemas.microsoft.com/office/drawing/2010/main" w="9525">
+                  <a14:hiddenLine xmlns:a14="http://schemas.microsoft.com/office/drawing/2010/main" xmlns="" w="9525">
                     <a:solidFill>
                       <a:srgbClr val="000000"/>
                     </a:solidFill>
@@ -12419,7 +12596,7 @@
           <a:p>
             <a:fld id="{5C8C344D-9141-BC4D-9923-D67060F426F1}" type="datetime1">
               <a:rPr lang="en-US" smtClean="0"/>
-              <a:t>9/11/25</a:t>
+              <a:t>1/28/26</a:t>
             </a:fld>
             <a:endParaRPr lang="en-US"/>
           </a:p>
@@ -15028,6 +15205,57 @@
               </a:p>
             </p:txBody>
           </p:sp>
+        </mc:Fallback>
+      </mc:AlternateContent>
+      <mc:AlternateContent xmlns:mc="http://schemas.openxmlformats.org/markup-compatibility/2006">
+        <mc:Choice xmlns:p14="http://schemas.microsoft.com/office/powerpoint/2010/main" Requires="p14">
+          <p:contentPart p14:bwMode="auto" r:id="rId3">
+            <p14:nvContentPartPr>
+              <p14:cNvPr id="4" name="Ink 3">
+                <a:extLst>
+                  <a:ext uri="{FF2B5EF4-FFF2-40B4-BE49-F238E27FC236}">
+                    <a16:creationId xmlns:a16="http://schemas.microsoft.com/office/drawing/2014/main" id="{44F8E340-7A2D-653C-7AE7-7424FF0D57D2}"/>
+                  </a:ext>
+                </a:extLst>
+              </p14:cNvPr>
+              <p14:cNvContentPartPr/>
+              <p14:nvPr/>
+            </p14:nvContentPartPr>
+            <p14:xfrm>
+              <a:off x="660960" y="159480"/>
+              <a:ext cx="9394200" cy="5816880"/>
+            </p14:xfrm>
+          </p:contentPart>
+        </mc:Choice>
+        <mc:Fallback>
+          <p:pic>
+            <p:nvPicPr>
+              <p:cNvPr id="4" name="Ink 3">
+                <a:extLst>
+                  <a:ext uri="{FF2B5EF4-FFF2-40B4-BE49-F238E27FC236}">
+                    <a16:creationId xmlns:a16="http://schemas.microsoft.com/office/drawing/2014/main" id="{44F8E340-7A2D-653C-7AE7-7424FF0D57D2}"/>
+                  </a:ext>
+                </a:extLst>
+              </p:cNvPr>
+              <p:cNvPicPr/>
+              <p:nvPr/>
+            </p:nvPicPr>
+            <p:blipFill>
+              <a:blip r:embed="rId4"/>
+              <a:stretch>
+                <a:fillRect/>
+              </a:stretch>
+            </p:blipFill>
+            <p:spPr>
+              <a:xfrm>
+                <a:off x="651600" y="150120"/>
+                <a:ext cx="9412920" cy="5835600"/>
+              </a:xfrm>
+              <a:prstGeom prst="rect">
+                <a:avLst/>
+              </a:prstGeom>
+            </p:spPr>
+          </p:pic>
         </mc:Fallback>
       </mc:AlternateContent>
     </p:spTree>
@@ -24409,7 +24637,7 @@
         <p:spPr bwMode="auto">
           <a:xfrm>
             <a:off x="3259164" y="2552700"/>
-            <a:ext cx="5673669" cy="3785652"/>
+            <a:ext cx="6362960" cy="3785652"/>
           </a:xfrm>
           <a:prstGeom prst="rect">
             <a:avLst/>
@@ -24426,14 +24654,14 @@
           </a:ln>
           <a:extLst>
             <a:ext uri="{909E8E84-426E-40dd-AFC4-6F175D3DCCD1}">
-              <a14:hiddenFill xmlns="" xmlns:a14="http://schemas.microsoft.com/office/drawing/2010/main">
+              <a14:hiddenFill xmlns:a14="http://schemas.microsoft.com/office/drawing/2010/main" xmlns="">
                 <a:solidFill>
                   <a:srgbClr val="FFFFFF"/>
                 </a:solidFill>
               </a14:hiddenFill>
             </a:ext>
             <a:ext uri="{91240B29-F687-4f45-9708-019B960494DF}">
-              <a14:hiddenLine xmlns="" xmlns:a14="http://schemas.microsoft.com/office/drawing/2010/main" w="9525">
+              <a14:hiddenLine xmlns:a14="http://schemas.microsoft.com/office/drawing/2010/main" xmlns="" w="9525">
                 <a:solidFill>
                   <a:srgbClr val="000000"/>
                 </a:solidFill>
@@ -24727,7 +24955,7 @@
                 </a:solidFill>
                 <a:latin typeface="Calibri" panose="020F0502020204030204" pitchFamily="34" charset="0"/>
               </a:rPr>
-              <a:t>    DFS-VISIT(G, u)  // explore paths out of u</a:t>
+              <a:t>              DFS-VISIT(G, u)  // explore paths out of u</a:t>
             </a:r>
           </a:p>
           <a:p>
@@ -26023,14 +26251,14 @@
           </a:ln>
           <a:extLst>
             <a:ext uri="{909E8E84-426E-40dd-AFC4-6F175D3DCCD1}">
-              <a14:hiddenFill xmlns="" xmlns:a14="http://schemas.microsoft.com/office/drawing/2010/main">
+              <a14:hiddenFill xmlns:a14="http://schemas.microsoft.com/office/drawing/2010/main" xmlns="">
                 <a:solidFill>
                   <a:srgbClr val="FFFFFF"/>
                 </a:solidFill>
               </a14:hiddenFill>
             </a:ext>
             <a:ext uri="{91240B29-F687-4f45-9708-019B960494DF}">
-              <a14:hiddenLine xmlns="" xmlns:a14="http://schemas.microsoft.com/office/drawing/2010/main" w="9525">
+              <a14:hiddenLine xmlns:a14="http://schemas.microsoft.com/office/drawing/2010/main" xmlns="" w="9525">
                 <a:solidFill>
                   <a:srgbClr val="000000"/>
                 </a:solidFill>
@@ -26324,7 +26552,7 @@
                 </a:solidFill>
                 <a:latin typeface="Calibri" panose="020F0502020204030204" pitchFamily="34" charset="0"/>
               </a:rPr>
-              <a:t>    DFS-VISIT(G, u)</a:t>
+              <a:t>              DFS-VISIT(G, u)</a:t>
             </a:r>
           </a:p>
           <a:p>
@@ -42379,6 +42607,57 @@
           </a:fontRef>
         </p:style>
       </p:cxnSp>
+      <mc:AlternateContent xmlns:mc="http://schemas.openxmlformats.org/markup-compatibility/2006">
+        <mc:Choice xmlns:p14="http://schemas.microsoft.com/office/powerpoint/2010/main" Requires="p14">
+          <p:contentPart p14:bwMode="auto" r:id="rId4">
+            <p14:nvContentPartPr>
+              <p14:cNvPr id="2" name="Ink 1">
+                <a:extLst>
+                  <a:ext uri="{FF2B5EF4-FFF2-40B4-BE49-F238E27FC236}">
+                    <a16:creationId xmlns:a16="http://schemas.microsoft.com/office/drawing/2014/main" id="{D7A87ECF-089F-CA87-6F92-5F32767674D1}"/>
+                  </a:ext>
+                </a:extLst>
+              </p14:cNvPr>
+              <p14:cNvContentPartPr/>
+              <p14:nvPr/>
+            </p14:nvContentPartPr>
+            <p14:xfrm>
+              <a:off x="817920" y="2264400"/>
+              <a:ext cx="8797680" cy="3907440"/>
+            </p14:xfrm>
+          </p:contentPart>
+        </mc:Choice>
+        <mc:Fallback>
+          <p:pic>
+            <p:nvPicPr>
+              <p:cNvPr id="2" name="Ink 1">
+                <a:extLst>
+                  <a:ext uri="{FF2B5EF4-FFF2-40B4-BE49-F238E27FC236}">
+                    <a16:creationId xmlns:a16="http://schemas.microsoft.com/office/drawing/2014/main" id="{D7A87ECF-089F-CA87-6F92-5F32767674D1}"/>
+                  </a:ext>
+                </a:extLst>
+              </p:cNvPr>
+              <p:cNvPicPr/>
+              <p:nvPr/>
+            </p:nvPicPr>
+            <p:blipFill>
+              <a:blip r:embed="rId5"/>
+              <a:stretch>
+                <a:fillRect/>
+              </a:stretch>
+            </p:blipFill>
+            <p:spPr>
+              <a:xfrm>
+                <a:off x="808560" y="2255040"/>
+                <a:ext cx="8816400" cy="3926160"/>
+              </a:xfrm>
+              <a:prstGeom prst="rect">
+                <a:avLst/>
+              </a:prstGeom>
+            </p:spPr>
+          </p:pic>
+        </mc:Fallback>
+      </mc:AlternateContent>
     </p:spTree>
     <p:extLst>
       <p:ext uri="{BB962C8B-B14F-4D97-AF65-F5344CB8AC3E}">

</xml_diff>